<commit_message>
finished all plots plus verifying counts (except fig-distinct-counts and fig-distinct-counts-da).
</commit_message>
<xml_diff>
--- a/plots_png/pptx/plots_png.pptx
+++ b/plots_png/pptx/plots_png.pptx
@@ -105,6 +105,11 @@
       </a:defRPr>
     </a:lvl9pPr>
   </p:defaultTextStyle>
+  <p:extLst>
+    <p:ext uri="{EFAFB233-063F-42B5-8137-9DF3F51BA10A}">
+      <p15:sldGuideLst xmlns:p15="http://schemas.microsoft.com/office/powerpoint/2012/main"/>
+    </p:ext>
+  </p:extLst>
 </p:presentation>
 </file>
 
@@ -239,7 +244,7 @@
           <a:p>
             <a:fld id="{83D14EEA-DE26-4810-8E05-A65F0010FADE}" type="datetimeFigureOut">
               <a:rPr lang="de-DE" smtClean="0"/>
-              <a:t>15.10.2025</a:t>
+              <a:t>16.10.2025</a:t>
             </a:fld>
             <a:endParaRPr lang="de-DE"/>
           </a:p>
@@ -409,7 +414,7 @@
           <a:p>
             <a:fld id="{83D14EEA-DE26-4810-8E05-A65F0010FADE}" type="datetimeFigureOut">
               <a:rPr lang="de-DE" smtClean="0"/>
-              <a:t>15.10.2025</a:t>
+              <a:t>16.10.2025</a:t>
             </a:fld>
             <a:endParaRPr lang="de-DE"/>
           </a:p>
@@ -589,7 +594,7 @@
           <a:p>
             <a:fld id="{83D14EEA-DE26-4810-8E05-A65F0010FADE}" type="datetimeFigureOut">
               <a:rPr lang="de-DE" smtClean="0"/>
-              <a:t>15.10.2025</a:t>
+              <a:t>16.10.2025</a:t>
             </a:fld>
             <a:endParaRPr lang="de-DE"/>
           </a:p>
@@ -759,7 +764,7 @@
           <a:p>
             <a:fld id="{83D14EEA-DE26-4810-8E05-A65F0010FADE}" type="datetimeFigureOut">
               <a:rPr lang="de-DE" smtClean="0"/>
-              <a:t>15.10.2025</a:t>
+              <a:t>16.10.2025</a:t>
             </a:fld>
             <a:endParaRPr lang="de-DE"/>
           </a:p>
@@ -1003,7 +1008,7 @@
           <a:p>
             <a:fld id="{83D14EEA-DE26-4810-8E05-A65F0010FADE}" type="datetimeFigureOut">
               <a:rPr lang="de-DE" smtClean="0"/>
-              <a:t>15.10.2025</a:t>
+              <a:t>16.10.2025</a:t>
             </a:fld>
             <a:endParaRPr lang="de-DE"/>
           </a:p>
@@ -1235,7 +1240,7 @@
           <a:p>
             <a:fld id="{83D14EEA-DE26-4810-8E05-A65F0010FADE}" type="datetimeFigureOut">
               <a:rPr lang="de-DE" smtClean="0"/>
-              <a:t>15.10.2025</a:t>
+              <a:t>16.10.2025</a:t>
             </a:fld>
             <a:endParaRPr lang="de-DE"/>
           </a:p>
@@ -1602,7 +1607,7 @@
           <a:p>
             <a:fld id="{83D14EEA-DE26-4810-8E05-A65F0010FADE}" type="datetimeFigureOut">
               <a:rPr lang="de-DE" smtClean="0"/>
-              <a:t>15.10.2025</a:t>
+              <a:t>16.10.2025</a:t>
             </a:fld>
             <a:endParaRPr lang="de-DE"/>
           </a:p>
@@ -1720,7 +1725,7 @@
           <a:p>
             <a:fld id="{83D14EEA-DE26-4810-8E05-A65F0010FADE}" type="datetimeFigureOut">
               <a:rPr lang="de-DE" smtClean="0"/>
-              <a:t>15.10.2025</a:t>
+              <a:t>16.10.2025</a:t>
             </a:fld>
             <a:endParaRPr lang="de-DE"/>
           </a:p>
@@ -1815,7 +1820,7 @@
           <a:p>
             <a:fld id="{83D14EEA-DE26-4810-8E05-A65F0010FADE}" type="datetimeFigureOut">
               <a:rPr lang="de-DE" smtClean="0"/>
-              <a:t>15.10.2025</a:t>
+              <a:t>16.10.2025</a:t>
             </a:fld>
             <a:endParaRPr lang="de-DE"/>
           </a:p>
@@ -2092,7 +2097,7 @@
           <a:p>
             <a:fld id="{83D14EEA-DE26-4810-8E05-A65F0010FADE}" type="datetimeFigureOut">
               <a:rPr lang="de-DE" smtClean="0"/>
-              <a:t>15.10.2025</a:t>
+              <a:t>16.10.2025</a:t>
             </a:fld>
             <a:endParaRPr lang="de-DE"/>
           </a:p>
@@ -2349,7 +2354,7 @@
           <a:p>
             <a:fld id="{83D14EEA-DE26-4810-8E05-A65F0010FADE}" type="datetimeFigureOut">
               <a:rPr lang="de-DE" smtClean="0"/>
-              <a:t>15.10.2025</a:t>
+              <a:t>16.10.2025</a:t>
             </a:fld>
             <a:endParaRPr lang="de-DE"/>
           </a:p>
@@ -2562,7 +2567,7 @@
           <a:p>
             <a:fld id="{83D14EEA-DE26-4810-8E05-A65F0010FADE}" type="datetimeFigureOut">
               <a:rPr lang="de-DE" smtClean="0"/>
-              <a:t>15.10.2025</a:t>
+              <a:t>16.10.2025</a:t>
             </a:fld>
             <a:endParaRPr lang="de-DE"/>
           </a:p>
@@ -4049,8 +4054,8 @@
         </p:nvSpPr>
         <p:spPr>
           <a:xfrm>
-            <a:off x="2318369" y="7448327"/>
-            <a:ext cx="1476961" cy="430887"/>
+            <a:off x="2025389" y="7478810"/>
+            <a:ext cx="2050431" cy="430887"/>
           </a:xfrm>
           <a:prstGeom prst="rect">
             <a:avLst/>
@@ -4070,10 +4075,21 @@
               </a:rPr>
               <a:t>Mentions of Charité Datasets</a:t>
             </a:r>
-            <a:endParaRPr lang="de-DE" sz="1100" dirty="0">
-              <a:latin typeface="Arial" panose="020B0604020202020204" pitchFamily="34" charset="0"/>
-              <a:cs typeface="Arial" panose="020B0604020202020204" pitchFamily="34" charset="0"/>
-            </a:endParaRPr>
+          </a:p>
+          <a:p>
+            <a:pPr algn="ctr"/>
+            <a:r>
+              <a:rPr lang="de-DE" sz="1100" dirty="0">
+                <a:solidFill>
+                  <a:schemeClr val="bg1">
+                    <a:lumMod val="50000"/>
+                  </a:schemeClr>
+                </a:solidFill>
+                <a:latin typeface="Arial" panose="020B0604020202020204" pitchFamily="34" charset="0"/>
+                <a:cs typeface="Arial" panose="020B0604020202020204" pitchFamily="34" charset="0"/>
+              </a:rPr>
+              <a:t>(1393 Reusing Papers)</a:t>
+            </a:r>
           </a:p>
         </p:txBody>
       </p:sp>
@@ -4744,6 +4760,680 @@
           <a:chExt cx="0" cy="0"/>
         </a:xfrm>
       </p:grpSpPr>
+      <p:sp>
+        <p:nvSpPr>
+          <p:cNvPr id="3" name="Rectangle 2">
+            <a:extLst>
+              <a:ext uri="{FF2B5EF4-FFF2-40B4-BE49-F238E27FC236}">
+                <a16:creationId xmlns:a16="http://schemas.microsoft.com/office/drawing/2014/main" id="{FE9FF791-EB9E-4172-8E36-126A1971CBBF}"/>
+              </a:ext>
+            </a:extLst>
+          </p:cNvPr>
+          <p:cNvSpPr/>
+          <p:nvPr/>
+        </p:nvSpPr>
+        <p:spPr>
+          <a:xfrm>
+            <a:off x="4311933" y="3699924"/>
+            <a:ext cx="1557989" cy="430887"/>
+          </a:xfrm>
+          <a:prstGeom prst="rect">
+            <a:avLst/>
+          </a:prstGeom>
+        </p:spPr>
+        <p:txBody>
+          <a:bodyPr wrap="square">
+            <a:spAutoFit/>
+          </a:bodyPr>
+          <a:lstStyle/>
+          <a:p>
+            <a:r>
+              <a:rPr lang="en-US" sz="1100" dirty="0">
+                <a:latin typeface="Arial" panose="020B0604020202020204" pitchFamily="34" charset="0"/>
+                <a:cs typeface="Arial" panose="020B0604020202020204" pitchFamily="34" charset="0"/>
+              </a:rPr>
+              <a:t>Confirmed Citations</a:t>
+            </a:r>
+          </a:p>
+          <a:p>
+            <a:r>
+              <a:rPr lang="de-DE" sz="1050" dirty="0">
+                <a:solidFill>
+                  <a:schemeClr val="bg1">
+                    <a:lumMod val="50000"/>
+                  </a:schemeClr>
+                </a:solidFill>
+                <a:latin typeface="Arial" panose="020B0604020202020204" pitchFamily="34" charset="0"/>
+                <a:cs typeface="Arial" panose="020B0604020202020204" pitchFamily="34" charset="0"/>
+              </a:rPr>
+              <a:t>(113 Reusing Papers)</a:t>
+            </a:r>
+          </a:p>
+        </p:txBody>
+      </p:sp>
+      <p:sp>
+        <p:nvSpPr>
+          <p:cNvPr id="32" name="Rectangle: Rounded Corners 31">
+            <a:extLst>
+              <a:ext uri="{FF2B5EF4-FFF2-40B4-BE49-F238E27FC236}">
+                <a16:creationId xmlns:a16="http://schemas.microsoft.com/office/drawing/2014/main" id="{759DB630-BAD7-4C3C-8ABD-E809EE7D6421}"/>
+              </a:ext>
+            </a:extLst>
+          </p:cNvPr>
+          <p:cNvSpPr/>
+          <p:nvPr/>
+        </p:nvSpPr>
+        <p:spPr>
+          <a:xfrm>
+            <a:off x="3464482" y="3739545"/>
+            <a:ext cx="847452" cy="351647"/>
+          </a:xfrm>
+          <a:prstGeom prst="roundRect">
+            <a:avLst/>
+          </a:prstGeom>
+          <a:gradFill flip="none" rotWithShape="1">
+            <a:gsLst>
+              <a:gs pos="84000">
+                <a:srgbClr val="75D4FF"/>
+              </a:gs>
+              <a:gs pos="68000">
+                <a:srgbClr val="00B0F0"/>
+              </a:gs>
+              <a:gs pos="100000">
+                <a:schemeClr val="bg1">
+                  <a:lumMod val="95000"/>
+                </a:schemeClr>
+              </a:gs>
+            </a:gsLst>
+            <a:lin ang="18900000" scaled="1"/>
+            <a:tileRect/>
+          </a:gradFill>
+          <a:ln>
+            <a:noFill/>
+          </a:ln>
+          <a:effectLst>
+            <a:outerShdw blurRad="50800" dist="38100" dir="8100000" algn="tr" rotWithShape="0">
+              <a:prstClr val="black">
+                <a:alpha val="40000"/>
+              </a:prstClr>
+            </a:outerShdw>
+          </a:effectLst>
+        </p:spPr>
+        <p:style>
+          <a:lnRef idx="2">
+            <a:schemeClr val="accent1">
+              <a:shade val="50000"/>
+            </a:schemeClr>
+          </a:lnRef>
+          <a:fillRef idx="1">
+            <a:schemeClr val="accent1"/>
+          </a:fillRef>
+          <a:effectRef idx="0">
+            <a:schemeClr val="accent1"/>
+          </a:effectRef>
+          <a:fontRef idx="minor">
+            <a:schemeClr val="lt1"/>
+          </a:fontRef>
+        </p:style>
+        <p:txBody>
+          <a:bodyPr rtlCol="0" anchor="ctr"/>
+          <a:lstStyle/>
+          <a:p>
+            <a:pPr algn="ctr"/>
+            <a:r>
+              <a:rPr lang="en-US" sz="1200">
+                <a:solidFill>
+                  <a:schemeClr val="tx1"/>
+                </a:solidFill>
+                <a:latin typeface="Arial" panose="020B0604020202020204" pitchFamily="34" charset="0"/>
+                <a:cs typeface="Arial" panose="020B0604020202020204" pitchFamily="34" charset="0"/>
+              </a:rPr>
+              <a:t>1765</a:t>
+            </a:r>
+            <a:endParaRPr lang="de-DE" sz="1200" dirty="0">
+              <a:solidFill>
+                <a:schemeClr val="tx1"/>
+              </a:solidFill>
+              <a:latin typeface="Arial" panose="020B0604020202020204" pitchFamily="34" charset="0"/>
+              <a:cs typeface="Arial" panose="020B0604020202020204" pitchFamily="34" charset="0"/>
+            </a:endParaRPr>
+          </a:p>
+        </p:txBody>
+      </p:sp>
+      <p:sp>
+        <p:nvSpPr>
+          <p:cNvPr id="33" name="Rectangle: Rounded Corners 32">
+            <a:extLst>
+              <a:ext uri="{FF2B5EF4-FFF2-40B4-BE49-F238E27FC236}">
+                <a16:creationId xmlns:a16="http://schemas.microsoft.com/office/drawing/2014/main" id="{F782143D-917A-4630-A7FB-072612AFAFCB}"/>
+              </a:ext>
+            </a:extLst>
+          </p:cNvPr>
+          <p:cNvSpPr/>
+          <p:nvPr/>
+        </p:nvSpPr>
+        <p:spPr>
+          <a:xfrm>
+            <a:off x="3464482" y="4659776"/>
+            <a:ext cx="847452" cy="351647"/>
+          </a:xfrm>
+          <a:prstGeom prst="roundRect">
+            <a:avLst/>
+          </a:prstGeom>
+          <a:gradFill flip="none" rotWithShape="1">
+            <a:gsLst>
+              <a:gs pos="84000">
+                <a:srgbClr val="75D4FF"/>
+              </a:gs>
+              <a:gs pos="68000">
+                <a:srgbClr val="00B0F0"/>
+              </a:gs>
+              <a:gs pos="100000">
+                <a:schemeClr val="bg1">
+                  <a:lumMod val="95000"/>
+                </a:schemeClr>
+              </a:gs>
+            </a:gsLst>
+            <a:lin ang="18900000" scaled="1"/>
+            <a:tileRect/>
+          </a:gradFill>
+          <a:ln>
+            <a:noFill/>
+          </a:ln>
+          <a:effectLst>
+            <a:outerShdw blurRad="50800" dist="38100" dir="8100000" algn="tr" rotWithShape="0">
+              <a:prstClr val="black">
+                <a:alpha val="40000"/>
+              </a:prstClr>
+            </a:outerShdw>
+          </a:effectLst>
+        </p:spPr>
+        <p:style>
+          <a:lnRef idx="2">
+            <a:schemeClr val="accent1">
+              <a:shade val="50000"/>
+            </a:schemeClr>
+          </a:lnRef>
+          <a:fillRef idx="1">
+            <a:schemeClr val="accent1"/>
+          </a:fillRef>
+          <a:effectRef idx="0">
+            <a:schemeClr val="accent1"/>
+          </a:effectRef>
+          <a:fontRef idx="minor">
+            <a:schemeClr val="lt1"/>
+          </a:fontRef>
+        </p:style>
+        <p:txBody>
+          <a:bodyPr rtlCol="0" anchor="ctr"/>
+          <a:lstStyle/>
+          <a:p>
+            <a:pPr algn="ctr"/>
+            <a:r>
+              <a:rPr lang="en-US" sz="1200" dirty="0">
+                <a:solidFill>
+                  <a:schemeClr val="tx1"/>
+                </a:solidFill>
+                <a:latin typeface="Arial" panose="020B0604020202020204" pitchFamily="34" charset="0"/>
+                <a:cs typeface="Arial" panose="020B0604020202020204" pitchFamily="34" charset="0"/>
+              </a:rPr>
+              <a:t>?</a:t>
+            </a:r>
+            <a:endParaRPr lang="de-DE" sz="1200" dirty="0">
+              <a:solidFill>
+                <a:schemeClr val="tx1"/>
+              </a:solidFill>
+              <a:latin typeface="Arial" panose="020B0604020202020204" pitchFamily="34" charset="0"/>
+              <a:cs typeface="Arial" panose="020B0604020202020204" pitchFamily="34" charset="0"/>
+            </a:endParaRPr>
+          </a:p>
+        </p:txBody>
+      </p:sp>
+      <p:cxnSp>
+        <p:nvCxnSpPr>
+          <p:cNvPr id="34" name="Straight Arrow Connector 33">
+            <a:extLst>
+              <a:ext uri="{FF2B5EF4-FFF2-40B4-BE49-F238E27FC236}">
+                <a16:creationId xmlns:a16="http://schemas.microsoft.com/office/drawing/2014/main" id="{588FEEB8-535C-4F9D-BE06-D60DEC78B11A}"/>
+              </a:ext>
+            </a:extLst>
+          </p:cNvPr>
+          <p:cNvCxnSpPr>
+            <a:cxnSpLocks/>
+            <a:stCxn id="32" idx="2"/>
+            <a:endCxn id="33" idx="0"/>
+          </p:cNvCxnSpPr>
+          <p:nvPr/>
+        </p:nvCxnSpPr>
+        <p:spPr>
+          <a:xfrm>
+            <a:off x="3888208" y="4091192"/>
+            <a:ext cx="0" cy="568585"/>
+          </a:xfrm>
+          <a:prstGeom prst="straightConnector1">
+            <a:avLst/>
+          </a:prstGeom>
+          <a:ln>
+            <a:solidFill>
+              <a:schemeClr val="bg1">
+                <a:lumMod val="65000"/>
+              </a:schemeClr>
+            </a:solidFill>
+            <a:tailEnd type="triangle"/>
+          </a:ln>
+        </p:spPr>
+        <p:style>
+          <a:lnRef idx="1">
+            <a:schemeClr val="accent1"/>
+          </a:lnRef>
+          <a:fillRef idx="0">
+            <a:schemeClr val="accent1"/>
+          </a:fillRef>
+          <a:effectRef idx="0">
+            <a:schemeClr val="accent1"/>
+          </a:effectRef>
+          <a:fontRef idx="minor">
+            <a:schemeClr val="tx1"/>
+          </a:fontRef>
+        </p:style>
+      </p:cxnSp>
+      <p:sp>
+        <p:nvSpPr>
+          <p:cNvPr id="35" name="Rectangle 34">
+            <a:extLst>
+              <a:ext uri="{FF2B5EF4-FFF2-40B4-BE49-F238E27FC236}">
+                <a16:creationId xmlns:a16="http://schemas.microsoft.com/office/drawing/2014/main" id="{F8014AD8-AB9C-478D-A1B4-21E726B7E060}"/>
+              </a:ext>
+            </a:extLst>
+          </p:cNvPr>
+          <p:cNvSpPr/>
+          <p:nvPr/>
+        </p:nvSpPr>
+        <p:spPr>
+          <a:xfrm>
+            <a:off x="4304303" y="4704794"/>
+            <a:ext cx="1558000" cy="261610"/>
+          </a:xfrm>
+          <a:prstGeom prst="rect">
+            <a:avLst/>
+          </a:prstGeom>
+        </p:spPr>
+        <p:txBody>
+          <a:bodyPr wrap="square">
+            <a:spAutoFit/>
+          </a:bodyPr>
+          <a:lstStyle/>
+          <a:p>
+            <a:r>
+              <a:rPr lang="en-US" sz="1100" dirty="0">
+                <a:latin typeface="Arial" panose="020B0604020202020204" pitchFamily="34" charset="0"/>
+                <a:cs typeface="Arial" panose="020B0604020202020204" pitchFamily="34" charset="0"/>
+              </a:rPr>
+              <a:t>Estimated Citations</a:t>
+            </a:r>
+            <a:endParaRPr lang="de-DE" sz="1100" dirty="0">
+              <a:latin typeface="Arial" panose="020B0604020202020204" pitchFamily="34" charset="0"/>
+              <a:cs typeface="Arial" panose="020B0604020202020204" pitchFamily="34" charset="0"/>
+            </a:endParaRPr>
+          </a:p>
+        </p:txBody>
+      </p:sp>
+      <p:sp>
+        <p:nvSpPr>
+          <p:cNvPr id="36" name="Rectangle: Rounded Corners 35">
+            <a:extLst>
+              <a:ext uri="{FF2B5EF4-FFF2-40B4-BE49-F238E27FC236}">
+                <a16:creationId xmlns:a16="http://schemas.microsoft.com/office/drawing/2014/main" id="{A66615DB-D6CA-4E80-B064-CD8973E779A9}"/>
+              </a:ext>
+            </a:extLst>
+          </p:cNvPr>
+          <p:cNvSpPr/>
+          <p:nvPr/>
+        </p:nvSpPr>
+        <p:spPr>
+          <a:xfrm>
+            <a:off x="3464482" y="2805223"/>
+            <a:ext cx="847452" cy="351647"/>
+          </a:xfrm>
+          <a:prstGeom prst="roundRect">
+            <a:avLst/>
+          </a:prstGeom>
+          <a:gradFill flip="none" rotWithShape="1">
+            <a:gsLst>
+              <a:gs pos="84000">
+                <a:srgbClr val="75D4FF"/>
+              </a:gs>
+              <a:gs pos="68000">
+                <a:srgbClr val="00B0F0"/>
+              </a:gs>
+              <a:gs pos="100000">
+                <a:schemeClr val="bg1">
+                  <a:lumMod val="95000"/>
+                </a:schemeClr>
+              </a:gs>
+            </a:gsLst>
+            <a:lin ang="18900000" scaled="1"/>
+            <a:tileRect/>
+          </a:gradFill>
+          <a:ln>
+            <a:noFill/>
+          </a:ln>
+          <a:effectLst>
+            <a:outerShdw blurRad="50800" dist="38100" dir="8100000" algn="tr" rotWithShape="0">
+              <a:prstClr val="black">
+                <a:alpha val="40000"/>
+              </a:prstClr>
+            </a:outerShdw>
+          </a:effectLst>
+        </p:spPr>
+        <p:style>
+          <a:lnRef idx="2">
+            <a:schemeClr val="accent1">
+              <a:shade val="50000"/>
+            </a:schemeClr>
+          </a:lnRef>
+          <a:fillRef idx="1">
+            <a:schemeClr val="accent1"/>
+          </a:fillRef>
+          <a:effectRef idx="0">
+            <a:schemeClr val="accent1"/>
+          </a:effectRef>
+          <a:fontRef idx="minor">
+            <a:schemeClr val="lt1"/>
+          </a:fontRef>
+        </p:style>
+        <p:txBody>
+          <a:bodyPr rtlCol="0" anchor="ctr"/>
+          <a:lstStyle/>
+          <a:p>
+            <a:pPr algn="ctr"/>
+            <a:r>
+              <a:rPr lang="en-US" sz="1200">
+                <a:solidFill>
+                  <a:schemeClr val="tx1"/>
+                </a:solidFill>
+                <a:latin typeface="Arial" panose="020B0604020202020204" pitchFamily="34" charset="0"/>
+                <a:cs typeface="Arial" panose="020B0604020202020204" pitchFamily="34" charset="0"/>
+              </a:rPr>
+              <a:t>35</a:t>
+            </a:r>
+            <a:endParaRPr lang="de-DE" sz="1200" dirty="0">
+              <a:solidFill>
+                <a:schemeClr val="tx1"/>
+              </a:solidFill>
+              <a:latin typeface="Arial" panose="020B0604020202020204" pitchFamily="34" charset="0"/>
+              <a:cs typeface="Arial" panose="020B0604020202020204" pitchFamily="34" charset="0"/>
+            </a:endParaRPr>
+          </a:p>
+        </p:txBody>
+      </p:sp>
+      <p:cxnSp>
+        <p:nvCxnSpPr>
+          <p:cNvPr id="37" name="Straight Arrow Connector 36">
+            <a:extLst>
+              <a:ext uri="{FF2B5EF4-FFF2-40B4-BE49-F238E27FC236}">
+                <a16:creationId xmlns:a16="http://schemas.microsoft.com/office/drawing/2014/main" id="{9CB45425-9B7D-49B1-B7E6-6CE84CD5DD4F}"/>
+              </a:ext>
+            </a:extLst>
+          </p:cNvPr>
+          <p:cNvCxnSpPr>
+            <a:cxnSpLocks/>
+            <a:stCxn id="36" idx="2"/>
+            <a:endCxn id="32" idx="0"/>
+          </p:cNvCxnSpPr>
+          <p:nvPr/>
+        </p:nvCxnSpPr>
+        <p:spPr>
+          <a:xfrm>
+            <a:off x="3888208" y="3156870"/>
+            <a:ext cx="0" cy="582675"/>
+          </a:xfrm>
+          <a:prstGeom prst="straightConnector1">
+            <a:avLst/>
+          </a:prstGeom>
+          <a:ln>
+            <a:solidFill>
+              <a:schemeClr val="bg1">
+                <a:lumMod val="65000"/>
+              </a:schemeClr>
+            </a:solidFill>
+            <a:tailEnd type="triangle"/>
+          </a:ln>
+        </p:spPr>
+        <p:style>
+          <a:lnRef idx="1">
+            <a:schemeClr val="accent1"/>
+          </a:lnRef>
+          <a:fillRef idx="0">
+            <a:schemeClr val="accent1"/>
+          </a:fillRef>
+          <a:effectRef idx="0">
+            <a:schemeClr val="accent1"/>
+          </a:effectRef>
+          <a:fontRef idx="minor">
+            <a:schemeClr val="tx1"/>
+          </a:fontRef>
+        </p:style>
+      </p:cxnSp>
+      <p:sp>
+        <p:nvSpPr>
+          <p:cNvPr id="38" name="Rectangle 37">
+            <a:extLst>
+              <a:ext uri="{FF2B5EF4-FFF2-40B4-BE49-F238E27FC236}">
+                <a16:creationId xmlns:a16="http://schemas.microsoft.com/office/drawing/2014/main" id="{793B5009-2567-4219-828C-A2FC4468E2F5}"/>
+              </a:ext>
+            </a:extLst>
+          </p:cNvPr>
+          <p:cNvSpPr/>
+          <p:nvPr/>
+        </p:nvSpPr>
+        <p:spPr>
+          <a:xfrm>
+            <a:off x="4308118" y="2842546"/>
+            <a:ext cx="1372571" cy="261610"/>
+          </a:xfrm>
+          <a:prstGeom prst="rect">
+            <a:avLst/>
+          </a:prstGeom>
+        </p:spPr>
+        <p:txBody>
+          <a:bodyPr wrap="square">
+            <a:spAutoFit/>
+          </a:bodyPr>
+          <a:lstStyle/>
+          <a:p>
+            <a:r>
+              <a:rPr lang="en-US" sz="1100" dirty="0">
+                <a:latin typeface="Arial" panose="020B0604020202020204" pitchFamily="34" charset="0"/>
+                <a:cs typeface="Arial" panose="020B0604020202020204" pitchFamily="34" charset="0"/>
+              </a:rPr>
+              <a:t>Charité Datasets</a:t>
+            </a:r>
+            <a:endParaRPr lang="de-DE" sz="1100" dirty="0">
+              <a:latin typeface="Arial" panose="020B0604020202020204" pitchFamily="34" charset="0"/>
+              <a:cs typeface="Arial" panose="020B0604020202020204" pitchFamily="34" charset="0"/>
+            </a:endParaRPr>
+          </a:p>
+        </p:txBody>
+      </p:sp>
+      <p:sp>
+        <p:nvSpPr>
+          <p:cNvPr id="39" name="Rectangle: Rounded Corners 38">
+            <a:extLst>
+              <a:ext uri="{FF2B5EF4-FFF2-40B4-BE49-F238E27FC236}">
+                <a16:creationId xmlns:a16="http://schemas.microsoft.com/office/drawing/2014/main" id="{D4DE513D-2FB1-49B7-A2CE-E030FD9CE2A4}"/>
+              </a:ext>
+            </a:extLst>
+          </p:cNvPr>
+          <p:cNvSpPr/>
+          <p:nvPr/>
+        </p:nvSpPr>
+        <p:spPr>
+          <a:xfrm>
+            <a:off x="3460666" y="1868520"/>
+            <a:ext cx="847452" cy="351647"/>
+          </a:xfrm>
+          <a:prstGeom prst="roundRect">
+            <a:avLst/>
+          </a:prstGeom>
+          <a:gradFill flip="none" rotWithShape="1">
+            <a:gsLst>
+              <a:gs pos="84000">
+                <a:srgbClr val="75D4FF"/>
+              </a:gs>
+              <a:gs pos="68000">
+                <a:srgbClr val="00B0F0"/>
+              </a:gs>
+              <a:gs pos="100000">
+                <a:schemeClr val="bg1">
+                  <a:lumMod val="95000"/>
+                </a:schemeClr>
+              </a:gs>
+            </a:gsLst>
+            <a:lin ang="18900000" scaled="1"/>
+            <a:tileRect/>
+          </a:gradFill>
+          <a:ln>
+            <a:noFill/>
+          </a:ln>
+          <a:effectLst>
+            <a:outerShdw blurRad="50800" dist="38100" dir="8100000" algn="tr" rotWithShape="0">
+              <a:prstClr val="black">
+                <a:alpha val="40000"/>
+              </a:prstClr>
+            </a:outerShdw>
+          </a:effectLst>
+        </p:spPr>
+        <p:style>
+          <a:lnRef idx="2">
+            <a:schemeClr val="accent1">
+              <a:shade val="50000"/>
+            </a:schemeClr>
+          </a:lnRef>
+          <a:fillRef idx="1">
+            <a:schemeClr val="accent1"/>
+          </a:fillRef>
+          <a:effectRef idx="0">
+            <a:schemeClr val="accent1"/>
+          </a:effectRef>
+          <a:fontRef idx="minor">
+            <a:schemeClr val="lt1"/>
+          </a:fontRef>
+        </p:style>
+        <p:txBody>
+          <a:bodyPr rtlCol="0" anchor="ctr"/>
+          <a:lstStyle/>
+          <a:p>
+            <a:pPr algn="ctr"/>
+            <a:r>
+              <a:rPr lang="en-US" sz="1200" dirty="0">
+                <a:solidFill>
+                  <a:schemeClr val="tx1"/>
+                </a:solidFill>
+                <a:latin typeface="Arial" panose="020B0604020202020204" pitchFamily="34" charset="0"/>
+                <a:cs typeface="Arial" panose="020B0604020202020204" pitchFamily="34" charset="0"/>
+              </a:rPr>
+              <a:t>28</a:t>
+            </a:r>
+            <a:endParaRPr lang="de-DE" sz="1200" dirty="0">
+              <a:solidFill>
+                <a:schemeClr val="tx1"/>
+              </a:solidFill>
+              <a:latin typeface="Arial" panose="020B0604020202020204" pitchFamily="34" charset="0"/>
+              <a:cs typeface="Arial" panose="020B0604020202020204" pitchFamily="34" charset="0"/>
+            </a:endParaRPr>
+          </a:p>
+        </p:txBody>
+      </p:sp>
+      <p:cxnSp>
+        <p:nvCxnSpPr>
+          <p:cNvPr id="40" name="Straight Arrow Connector 39">
+            <a:extLst>
+              <a:ext uri="{FF2B5EF4-FFF2-40B4-BE49-F238E27FC236}">
+                <a16:creationId xmlns:a16="http://schemas.microsoft.com/office/drawing/2014/main" id="{02B4690F-D349-475B-81BF-F2E80E19C269}"/>
+              </a:ext>
+            </a:extLst>
+          </p:cNvPr>
+          <p:cNvCxnSpPr>
+            <a:cxnSpLocks/>
+            <a:stCxn id="39" idx="2"/>
+            <a:endCxn id="36" idx="0"/>
+          </p:cNvCxnSpPr>
+          <p:nvPr/>
+        </p:nvCxnSpPr>
+        <p:spPr>
+          <a:xfrm>
+            <a:off x="3884392" y="2220167"/>
+            <a:ext cx="3816" cy="585056"/>
+          </a:xfrm>
+          <a:prstGeom prst="straightConnector1">
+            <a:avLst/>
+          </a:prstGeom>
+          <a:ln>
+            <a:solidFill>
+              <a:schemeClr val="bg1">
+                <a:lumMod val="65000"/>
+              </a:schemeClr>
+            </a:solidFill>
+            <a:tailEnd type="triangle"/>
+          </a:ln>
+        </p:spPr>
+        <p:style>
+          <a:lnRef idx="1">
+            <a:schemeClr val="accent1"/>
+          </a:lnRef>
+          <a:fillRef idx="0">
+            <a:schemeClr val="accent1"/>
+          </a:fillRef>
+          <a:effectRef idx="0">
+            <a:schemeClr val="accent1"/>
+          </a:effectRef>
+          <a:fontRef idx="minor">
+            <a:schemeClr val="tx1"/>
+          </a:fontRef>
+        </p:style>
+      </p:cxnSp>
+      <p:sp>
+        <p:nvSpPr>
+          <p:cNvPr id="41" name="Rectangle 40">
+            <a:extLst>
+              <a:ext uri="{FF2B5EF4-FFF2-40B4-BE49-F238E27FC236}">
+                <a16:creationId xmlns:a16="http://schemas.microsoft.com/office/drawing/2014/main" id="{DFB321C3-1C3C-4DCB-87EF-3C35A20F30A0}"/>
+              </a:ext>
+            </a:extLst>
+          </p:cNvPr>
+          <p:cNvSpPr/>
+          <p:nvPr/>
+        </p:nvSpPr>
+        <p:spPr>
+          <a:xfrm>
+            <a:off x="4304302" y="1905843"/>
+            <a:ext cx="1558000" cy="261610"/>
+          </a:xfrm>
+          <a:prstGeom prst="rect">
+            <a:avLst/>
+          </a:prstGeom>
+        </p:spPr>
+        <p:txBody>
+          <a:bodyPr wrap="square">
+            <a:spAutoFit/>
+          </a:bodyPr>
+          <a:lstStyle/>
+          <a:p>
+            <a:r>
+              <a:rPr lang="en-US" sz="1100" dirty="0">
+                <a:latin typeface="Arial" panose="020B0604020202020204" pitchFamily="34" charset="0"/>
+                <a:cs typeface="Arial" panose="020B0604020202020204" pitchFamily="34" charset="0"/>
+              </a:rPr>
+              <a:t>Charité Data Articles</a:t>
+            </a:r>
+            <a:endParaRPr lang="de-DE" sz="1100" dirty="0">
+              <a:latin typeface="Arial" panose="020B0604020202020204" pitchFamily="34" charset="0"/>
+              <a:cs typeface="Arial" panose="020B0604020202020204" pitchFamily="34" charset="0"/>
+            </a:endParaRPr>
+          </a:p>
+        </p:txBody>
+      </p:sp>
     </p:spTree>
     <p:extLst>
       <p:ext uri="{BB962C8B-B14F-4D97-AF65-F5344CB8AC3E}">

</xml_diff>

<commit_message>
Removed numbat-data-articles ovelaps from _8_dedup and from "for_matching" in plots prep and plots, and performed all analyses, plots prep and plots once again accordingly (Except data articles ones). That means that all variations of numbat's "1.0.1" were removed, as well as the "ds001226" numbat instance, since they are analysed separately in the data articles analysis.
</commit_message>
<xml_diff>
--- a/plots_png/pptx/plots_png.pptx
+++ b/plots_png/pptx/plots_png.pptx
@@ -244,7 +244,7 @@
           <a:p>
             <a:fld id="{83D14EEA-DE26-4810-8E05-A65F0010FADE}" type="datetimeFigureOut">
               <a:rPr lang="de-DE" smtClean="0"/>
-              <a:t>16.10.2025</a:t>
+              <a:t>21.10.2025</a:t>
             </a:fld>
             <a:endParaRPr lang="de-DE"/>
           </a:p>
@@ -414,7 +414,7 @@
           <a:p>
             <a:fld id="{83D14EEA-DE26-4810-8E05-A65F0010FADE}" type="datetimeFigureOut">
               <a:rPr lang="de-DE" smtClean="0"/>
-              <a:t>16.10.2025</a:t>
+              <a:t>21.10.2025</a:t>
             </a:fld>
             <a:endParaRPr lang="de-DE"/>
           </a:p>
@@ -594,7 +594,7 @@
           <a:p>
             <a:fld id="{83D14EEA-DE26-4810-8E05-A65F0010FADE}" type="datetimeFigureOut">
               <a:rPr lang="de-DE" smtClean="0"/>
-              <a:t>16.10.2025</a:t>
+              <a:t>21.10.2025</a:t>
             </a:fld>
             <a:endParaRPr lang="de-DE"/>
           </a:p>
@@ -764,7 +764,7 @@
           <a:p>
             <a:fld id="{83D14EEA-DE26-4810-8E05-A65F0010FADE}" type="datetimeFigureOut">
               <a:rPr lang="de-DE" smtClean="0"/>
-              <a:t>16.10.2025</a:t>
+              <a:t>21.10.2025</a:t>
             </a:fld>
             <a:endParaRPr lang="de-DE"/>
           </a:p>
@@ -1008,7 +1008,7 @@
           <a:p>
             <a:fld id="{83D14EEA-DE26-4810-8E05-A65F0010FADE}" type="datetimeFigureOut">
               <a:rPr lang="de-DE" smtClean="0"/>
-              <a:t>16.10.2025</a:t>
+              <a:t>21.10.2025</a:t>
             </a:fld>
             <a:endParaRPr lang="de-DE"/>
           </a:p>
@@ -1240,7 +1240,7 @@
           <a:p>
             <a:fld id="{83D14EEA-DE26-4810-8E05-A65F0010FADE}" type="datetimeFigureOut">
               <a:rPr lang="de-DE" smtClean="0"/>
-              <a:t>16.10.2025</a:t>
+              <a:t>21.10.2025</a:t>
             </a:fld>
             <a:endParaRPr lang="de-DE"/>
           </a:p>
@@ -1607,7 +1607,7 @@
           <a:p>
             <a:fld id="{83D14EEA-DE26-4810-8E05-A65F0010FADE}" type="datetimeFigureOut">
               <a:rPr lang="de-DE" smtClean="0"/>
-              <a:t>16.10.2025</a:t>
+              <a:t>21.10.2025</a:t>
             </a:fld>
             <a:endParaRPr lang="de-DE"/>
           </a:p>
@@ -1725,7 +1725,7 @@
           <a:p>
             <a:fld id="{83D14EEA-DE26-4810-8E05-A65F0010FADE}" type="datetimeFigureOut">
               <a:rPr lang="de-DE" smtClean="0"/>
-              <a:t>16.10.2025</a:t>
+              <a:t>21.10.2025</a:t>
             </a:fld>
             <a:endParaRPr lang="de-DE"/>
           </a:p>
@@ -1820,7 +1820,7 @@
           <a:p>
             <a:fld id="{83D14EEA-DE26-4810-8E05-A65F0010FADE}" type="datetimeFigureOut">
               <a:rPr lang="de-DE" smtClean="0"/>
-              <a:t>16.10.2025</a:t>
+              <a:t>21.10.2025</a:t>
             </a:fld>
             <a:endParaRPr lang="de-DE"/>
           </a:p>
@@ -2097,7 +2097,7 @@
           <a:p>
             <a:fld id="{83D14EEA-DE26-4810-8E05-A65F0010FADE}" type="datetimeFigureOut">
               <a:rPr lang="de-DE" smtClean="0"/>
-              <a:t>16.10.2025</a:t>
+              <a:t>21.10.2025</a:t>
             </a:fld>
             <a:endParaRPr lang="de-DE"/>
           </a:p>
@@ -2354,7 +2354,7 @@
           <a:p>
             <a:fld id="{83D14EEA-DE26-4810-8E05-A65F0010FADE}" type="datetimeFigureOut">
               <a:rPr lang="de-DE" smtClean="0"/>
-              <a:t>16.10.2025</a:t>
+              <a:t>21.10.2025</a:t>
             </a:fld>
             <a:endParaRPr lang="de-DE"/>
           </a:p>
@@ -2567,7 +2567,7 @@
           <a:p>
             <a:fld id="{83D14EEA-DE26-4810-8E05-A65F0010FADE}" type="datetimeFigureOut">
               <a:rPr lang="de-DE" smtClean="0"/>
-              <a:t>16.10.2025</a:t>
+              <a:t>21.10.2025</a:t>
             </a:fld>
             <a:endParaRPr lang="de-DE"/>
           </a:p>
@@ -3052,7 +3052,7 @@
                 <a:latin typeface="Arial" panose="020B0604020202020204" pitchFamily="34" charset="0"/>
                 <a:cs typeface="Arial" panose="020B0604020202020204" pitchFamily="34" charset="0"/>
               </a:rPr>
-              <a:t>1952</a:t>
+              <a:t>1919</a:t>
             </a:r>
             <a:endParaRPr lang="de-DE" sz="1200" dirty="0">
               <a:solidFill>
@@ -3144,7 +3144,7 @@
                 <a:latin typeface="Arial" panose="020B0604020202020204" pitchFamily="34" charset="0"/>
                 <a:cs typeface="Arial" panose="020B0604020202020204" pitchFamily="34" charset="0"/>
               </a:rPr>
-              <a:t>86</a:t>
+              <a:t>118</a:t>
             </a:r>
             <a:endParaRPr lang="de-DE" sz="1200" dirty="0">
               <a:solidFill>
@@ -3236,7 +3236,7 @@
                 <a:latin typeface="Arial" panose="020B0604020202020204" pitchFamily="34" charset="0"/>
                 <a:cs typeface="Arial" panose="020B0604020202020204" pitchFamily="34" charset="0"/>
               </a:rPr>
-              <a:t>673</a:t>
+              <a:t>1032</a:t>
             </a:r>
             <a:endParaRPr lang="de-DE" sz="1200" dirty="0">
               <a:solidFill>
@@ -3400,7 +3400,7 @@
         <p:spPr>
           <a:xfrm>
             <a:off x="4271005" y="4697099"/>
-            <a:ext cx="2126949" cy="261610"/>
+            <a:ext cx="2126949" cy="430887"/>
           </a:xfrm>
           <a:prstGeom prst="rect">
             <a:avLst/>
@@ -3417,12 +3417,17 @@
                 <a:latin typeface="Arial" panose="020B0604020202020204" pitchFamily="34" charset="0"/>
                 <a:cs typeface="Arial" panose="020B0604020202020204" pitchFamily="34" charset="0"/>
               </a:rPr>
-              <a:t>Detected Datasets</a:t>
-            </a:r>
-            <a:endParaRPr lang="de-DE" sz="1100" dirty="0">
-              <a:latin typeface="Arial" panose="020B0604020202020204" pitchFamily="34" charset="0"/>
-              <a:cs typeface="Arial" panose="020B0604020202020204" pitchFamily="34" charset="0"/>
-            </a:endParaRPr>
+              <a:t>Mentioned Datasets</a:t>
+            </a:r>
+          </a:p>
+          <a:p>
+            <a:r>
+              <a:rPr lang="en-US" sz="1100" dirty="0">
+                <a:latin typeface="Arial" panose="020B0604020202020204" pitchFamily="34" charset="0"/>
+                <a:cs typeface="Arial" panose="020B0604020202020204" pitchFamily="34" charset="0"/>
+              </a:rPr>
+              <a:t>(Manually Screened)</a:t>
+            </a:r>
           </a:p>
         </p:txBody>
       </p:sp>
@@ -3441,7 +3446,7 @@
         <p:spPr>
           <a:xfrm>
             <a:off x="4311934" y="6253603"/>
-            <a:ext cx="2126948" cy="261610"/>
+            <a:ext cx="2126948" cy="430887"/>
           </a:xfrm>
           <a:prstGeom prst="rect">
             <a:avLst/>
@@ -3460,10 +3465,15 @@
               </a:rPr>
               <a:t>Mentions of Datasets</a:t>
             </a:r>
-            <a:endParaRPr lang="de-DE" sz="1100" dirty="0">
-              <a:latin typeface="Arial" panose="020B0604020202020204" pitchFamily="34" charset="0"/>
-              <a:cs typeface="Arial" panose="020B0604020202020204" pitchFamily="34" charset="0"/>
-            </a:endParaRPr>
+          </a:p>
+          <a:p>
+            <a:r>
+              <a:rPr lang="en-US" sz="1100" dirty="0">
+                <a:latin typeface="Arial" panose="020B0604020202020204" pitchFamily="34" charset="0"/>
+                <a:cs typeface="Arial" panose="020B0604020202020204" pitchFamily="34" charset="0"/>
+              </a:rPr>
+              <a:t>(Manually Screened)</a:t>
+            </a:r>
           </a:p>
         </p:txBody>
       </p:sp>
@@ -3550,7 +3560,7 @@
                 <a:latin typeface="Arial" panose="020B0604020202020204" pitchFamily="34" charset="0"/>
                 <a:cs typeface="Arial" panose="020B0604020202020204" pitchFamily="34" charset="0"/>
               </a:rPr>
-              <a:t>90</a:t>
+              <a:t>119</a:t>
             </a:r>
             <a:endParaRPr lang="de-DE" sz="1200" dirty="0">
               <a:solidFill>
@@ -3577,7 +3587,7 @@
         <p:spPr>
           <a:xfrm>
             <a:off x="1781863" y="6216280"/>
-            <a:ext cx="815263" cy="351647"/>
+            <a:ext cx="821637" cy="351647"/>
           </a:xfrm>
           <a:prstGeom prst="roundRect">
             <a:avLst/>
@@ -3645,7 +3655,7 @@
                 <a:latin typeface="Arial" panose="020B0604020202020204" pitchFamily="34" charset="0"/>
                 <a:cs typeface="Arial" panose="020B0604020202020204" pitchFamily="34" charset="0"/>
               </a:rPr>
-              <a:t>825</a:t>
+              <a:t>790</a:t>
             </a:r>
             <a:endParaRPr lang="de-DE" sz="1200" dirty="0">
               <a:solidFill>
@@ -3732,7 +3742,7 @@
                 <a:latin typeface="Arial" panose="020B0604020202020204" pitchFamily="34" charset="0"/>
                 <a:cs typeface="Arial" panose="020B0604020202020204" pitchFamily="34" charset="0"/>
               </a:rPr>
-              <a:t>1498</a:t>
+              <a:t>1497</a:t>
             </a:r>
             <a:endParaRPr lang="de-DE" sz="1200" dirty="0">
               <a:solidFill>
@@ -3763,7 +3773,7 @@
         <p:spPr>
           <a:xfrm>
             <a:off x="2189478" y="5011423"/>
-            <a:ext cx="17" cy="1204857"/>
+            <a:ext cx="3204" cy="1204857"/>
           </a:xfrm>
           <a:prstGeom prst="straightConnector1">
             <a:avLst/>
@@ -3810,8 +3820,8 @@
         </p:nvCxnSpPr>
         <p:spPr>
           <a:xfrm>
-            <a:off x="2189495" y="6567927"/>
-            <a:ext cx="841310" cy="528753"/>
+            <a:off x="2192682" y="6567927"/>
+            <a:ext cx="838123" cy="528753"/>
           </a:xfrm>
           <a:prstGeom prst="straightConnector1">
             <a:avLst/>
@@ -3840,54 +3850,6 @@
           </a:fontRef>
         </p:style>
       </p:cxnSp>
-      <p:cxnSp>
-        <p:nvCxnSpPr>
-          <p:cNvPr id="48" name="Straight Arrow Connector 47">
-            <a:extLst>
-              <a:ext uri="{FF2B5EF4-FFF2-40B4-BE49-F238E27FC236}">
-                <a16:creationId xmlns:a16="http://schemas.microsoft.com/office/drawing/2014/main" id="{808F44C1-0995-4A8F-963E-9EB3E96DF2E1}"/>
-              </a:ext>
-            </a:extLst>
-          </p:cNvPr>
-          <p:cNvCxnSpPr>
-            <a:cxnSpLocks/>
-            <a:stCxn id="11" idx="1"/>
-            <a:endCxn id="37" idx="3"/>
-          </p:cNvCxnSpPr>
-          <p:nvPr/>
-        </p:nvCxnSpPr>
-        <p:spPr>
-          <a:xfrm flipH="1">
-            <a:off x="2597109" y="4835600"/>
-            <a:ext cx="867373" cy="0"/>
-          </a:xfrm>
-          <a:prstGeom prst="straightConnector1">
-            <a:avLst/>
-          </a:prstGeom>
-          <a:ln>
-            <a:solidFill>
-              <a:schemeClr val="bg1">
-                <a:lumMod val="65000"/>
-              </a:schemeClr>
-            </a:solidFill>
-            <a:tailEnd type="triangle"/>
-          </a:ln>
-        </p:spPr>
-        <p:style>
-          <a:lnRef idx="1">
-            <a:schemeClr val="accent1"/>
-          </a:lnRef>
-          <a:fillRef idx="0">
-            <a:schemeClr val="accent1"/>
-          </a:fillRef>
-          <a:effectRef idx="0">
-            <a:schemeClr val="accent1"/>
-          </a:effectRef>
-          <a:fontRef idx="minor">
-            <a:schemeClr val="tx1"/>
-          </a:fontRef>
-        </p:style>
-      </p:cxnSp>
       <p:sp>
         <p:nvSpPr>
           <p:cNvPr id="50" name="Rectangle 49">
@@ -3902,8 +3864,8 @@
         </p:nvSpPr>
         <p:spPr>
           <a:xfrm>
-            <a:off x="346206" y="4620156"/>
-            <a:ext cx="1409585" cy="430887"/>
+            <a:off x="229128" y="4620156"/>
+            <a:ext cx="1526663" cy="430887"/>
           </a:xfrm>
           <a:prstGeom prst="rect">
             <a:avLst/>
@@ -3921,7 +3883,7 @@
                 <a:latin typeface="Arial" panose="020B0604020202020204" pitchFamily="34" charset="0"/>
                 <a:cs typeface="Arial" panose="020B0604020202020204" pitchFamily="34" charset="0"/>
               </a:rPr>
-              <a:t>Detected Datasets</a:t>
+              <a:t>Mentioned  Datasets</a:t>
             </a:r>
           </a:p>
           <a:p>
@@ -3931,7 +3893,21 @@
                 <a:latin typeface="Arial" panose="020B0604020202020204" pitchFamily="34" charset="0"/>
                 <a:cs typeface="Arial" panose="020B0604020202020204" pitchFamily="34" charset="0"/>
               </a:rPr>
-              <a:t>(DataStet &amp; Added)</a:t>
+              <a:t>(</a:t>
+            </a:r>
+            <a:r>
+              <a:rPr lang="en-US" sz="1100" dirty="0" err="1">
+                <a:latin typeface="Arial" panose="020B0604020202020204" pitchFamily="34" charset="0"/>
+                <a:cs typeface="Arial" panose="020B0604020202020204" pitchFamily="34" charset="0"/>
+              </a:rPr>
+              <a:t>DataStet</a:t>
+            </a:r>
+            <a:r>
+              <a:rPr lang="en-US" sz="1100" dirty="0">
+                <a:latin typeface="Arial" panose="020B0604020202020204" pitchFamily="34" charset="0"/>
+                <a:cs typeface="Arial" panose="020B0604020202020204" pitchFamily="34" charset="0"/>
+              </a:rPr>
+              <a:t>)</a:t>
             </a:r>
             <a:endParaRPr lang="de-DE" sz="1100" dirty="0">
               <a:latin typeface="Arial" panose="020B0604020202020204" pitchFamily="34" charset="0"/>
@@ -3983,7 +3959,21 @@
                 <a:latin typeface="Arial" panose="020B0604020202020204" pitchFamily="34" charset="0"/>
                 <a:cs typeface="Arial" panose="020B0604020202020204" pitchFamily="34" charset="0"/>
               </a:rPr>
-              <a:t>(DataStet &amp; Added)</a:t>
+              <a:t>(</a:t>
+            </a:r>
+            <a:r>
+              <a:rPr lang="en-US" sz="1100" dirty="0" err="1">
+                <a:latin typeface="Arial" panose="020B0604020202020204" pitchFamily="34" charset="0"/>
+                <a:cs typeface="Arial" panose="020B0604020202020204" pitchFamily="34" charset="0"/>
+              </a:rPr>
+              <a:t>DataStet</a:t>
+            </a:r>
+            <a:r>
+              <a:rPr lang="en-US" sz="1100" dirty="0">
+                <a:latin typeface="Arial" panose="020B0604020202020204" pitchFamily="34" charset="0"/>
+                <a:cs typeface="Arial" panose="020B0604020202020204" pitchFamily="34" charset="0"/>
+              </a:rPr>
+              <a:t>)</a:t>
             </a:r>
             <a:endParaRPr lang="de-DE" sz="1100" dirty="0">
               <a:latin typeface="Arial" panose="020B0604020202020204" pitchFamily="34" charset="0"/>
@@ -4073,7 +4063,7 @@
                 <a:latin typeface="Arial" panose="020B0604020202020204" pitchFamily="34" charset="0"/>
                 <a:cs typeface="Arial" panose="020B0604020202020204" pitchFamily="34" charset="0"/>
               </a:rPr>
-              <a:t>Mentions of Charité Datasets</a:t>
+              <a:t>Mentions of Datasets</a:t>
             </a:r>
           </a:p>
           <a:p>
@@ -4088,17 +4078,65 @@
                 <a:latin typeface="Arial" panose="020B0604020202020204" pitchFamily="34" charset="0"/>
                 <a:cs typeface="Arial" panose="020B0604020202020204" pitchFamily="34" charset="0"/>
               </a:rPr>
-              <a:t>(1393 Reusing Papers)</a:t>
-            </a:r>
-          </a:p>
-        </p:txBody>
-      </p:sp>
-      <p:sp>
-        <p:nvSpPr>
-          <p:cNvPr id="66" name="Rectangle: Rounded Corners 65">
+              <a:t>(1390 Reusing Papers)</a:t>
+            </a:r>
+          </a:p>
+        </p:txBody>
+      </p:sp>
+      <p:cxnSp>
+        <p:nvCxnSpPr>
+          <p:cNvPr id="67" name="Straight Arrow Connector 66">
             <a:extLst>
               <a:ext uri="{FF2B5EF4-FFF2-40B4-BE49-F238E27FC236}">
-                <a16:creationId xmlns:a16="http://schemas.microsoft.com/office/drawing/2014/main" id="{3E768A55-B162-4D7D-A14C-B7D7AA6EA4FB}"/>
+                <a16:creationId xmlns:a16="http://schemas.microsoft.com/office/drawing/2014/main" id="{546E5E13-378B-484F-A381-094CCFBA2949}"/>
+              </a:ext>
+            </a:extLst>
+          </p:cNvPr>
+          <p:cNvCxnSpPr>
+            <a:cxnSpLocks/>
+            <a:stCxn id="89" idx="2"/>
+            <a:endCxn id="9" idx="0"/>
+          </p:cNvCxnSpPr>
+          <p:nvPr/>
+        </p:nvCxnSpPr>
+        <p:spPr>
+          <a:xfrm>
+            <a:off x="3884392" y="3108620"/>
+            <a:ext cx="3816" cy="630925"/>
+          </a:xfrm>
+          <a:prstGeom prst="straightConnector1">
+            <a:avLst/>
+          </a:prstGeom>
+          <a:ln>
+            <a:solidFill>
+              <a:schemeClr val="bg1">
+                <a:lumMod val="65000"/>
+              </a:schemeClr>
+            </a:solidFill>
+            <a:tailEnd type="triangle"/>
+          </a:ln>
+        </p:spPr>
+        <p:style>
+          <a:lnRef idx="1">
+            <a:schemeClr val="accent1"/>
+          </a:lnRef>
+          <a:fillRef idx="0">
+            <a:schemeClr val="accent1"/>
+          </a:fillRef>
+          <a:effectRef idx="0">
+            <a:schemeClr val="accent1"/>
+          </a:effectRef>
+          <a:fontRef idx="minor">
+            <a:schemeClr val="tx1"/>
+          </a:fontRef>
+        </p:style>
+      </p:cxnSp>
+      <p:sp>
+        <p:nvSpPr>
+          <p:cNvPr id="80" name="Rectangle: Rounded Corners 79">
+            <a:extLst>
+              <a:ext uri="{FF2B5EF4-FFF2-40B4-BE49-F238E27FC236}">
+                <a16:creationId xmlns:a16="http://schemas.microsoft.com/office/drawing/2014/main" id="{D114DA72-2DDC-49FF-88D2-5DA57C7BF46C}"/>
               </a:ext>
             </a:extLst>
           </p:cNvPr>
@@ -4107,7 +4145,230 @@
         </p:nvSpPr>
         <p:spPr>
           <a:xfrm>
-            <a:off x="3464482" y="2805223"/>
+            <a:off x="2649219" y="5459906"/>
+            <a:ext cx="815263" cy="351647"/>
+          </a:xfrm>
+          <a:prstGeom prst="roundRect">
+            <a:avLst/>
+          </a:prstGeom>
+          <a:gradFill flip="none" rotWithShape="1">
+            <a:gsLst>
+              <a:gs pos="84000">
+                <a:srgbClr val="D8F6E3"/>
+              </a:gs>
+              <a:gs pos="65000">
+                <a:srgbClr val="93FF81"/>
+              </a:gs>
+              <a:gs pos="100000">
+                <a:srgbClr val="D9FFDD"/>
+              </a:gs>
+            </a:gsLst>
+            <a:lin ang="18900000" scaled="1"/>
+            <a:tileRect/>
+          </a:gradFill>
+          <a:ln>
+            <a:noFill/>
+          </a:ln>
+          <a:effectLst>
+            <a:outerShdw blurRad="50800" dist="38100" dir="8100000" algn="tr" rotWithShape="0">
+              <a:prstClr val="black">
+                <a:alpha val="40000"/>
+              </a:prstClr>
+            </a:outerShdw>
+          </a:effectLst>
+        </p:spPr>
+        <p:style>
+          <a:lnRef idx="2">
+            <a:schemeClr val="accent1">
+              <a:shade val="50000"/>
+            </a:schemeClr>
+          </a:lnRef>
+          <a:fillRef idx="1">
+            <a:schemeClr val="accent1"/>
+          </a:fillRef>
+          <a:effectRef idx="0">
+            <a:schemeClr val="accent1"/>
+          </a:effectRef>
+          <a:fontRef idx="minor">
+            <a:schemeClr val="lt1"/>
+          </a:fontRef>
+        </p:style>
+        <p:txBody>
+          <a:bodyPr rtlCol="0" anchor="ctr"/>
+          <a:lstStyle/>
+          <a:p>
+            <a:pPr algn="ctr"/>
+            <a:r>
+              <a:rPr lang="en-US" sz="1200" dirty="0">
+                <a:solidFill>
+                  <a:schemeClr val="tx1"/>
+                </a:solidFill>
+                <a:latin typeface="Arial" panose="020B0604020202020204" pitchFamily="34" charset="0"/>
+                <a:cs typeface="Arial" panose="020B0604020202020204" pitchFamily="34" charset="0"/>
+              </a:rPr>
+              <a:t>175</a:t>
+            </a:r>
+            <a:endParaRPr lang="de-DE" sz="1200" dirty="0">
+              <a:solidFill>
+                <a:schemeClr val="tx1"/>
+              </a:solidFill>
+              <a:latin typeface="Arial" panose="020B0604020202020204" pitchFamily="34" charset="0"/>
+              <a:cs typeface="Arial" panose="020B0604020202020204" pitchFamily="34" charset="0"/>
+            </a:endParaRPr>
+          </a:p>
+        </p:txBody>
+      </p:sp>
+      <p:cxnSp>
+        <p:nvCxnSpPr>
+          <p:cNvPr id="81" name="Straight Arrow Connector 80">
+            <a:extLst>
+              <a:ext uri="{FF2B5EF4-FFF2-40B4-BE49-F238E27FC236}">
+                <a16:creationId xmlns:a16="http://schemas.microsoft.com/office/drawing/2014/main" id="{DEBAAEA7-28FC-4C4C-85C6-F295E82C619C}"/>
+              </a:ext>
+            </a:extLst>
+          </p:cNvPr>
+          <p:cNvCxnSpPr>
+            <a:cxnSpLocks/>
+            <a:endCxn id="80" idx="0"/>
+          </p:cNvCxnSpPr>
+          <p:nvPr/>
+        </p:nvCxnSpPr>
+        <p:spPr>
+          <a:xfrm>
+            <a:off x="2189495" y="5023080"/>
+            <a:ext cx="867356" cy="436826"/>
+          </a:xfrm>
+          <a:prstGeom prst="straightConnector1">
+            <a:avLst/>
+          </a:prstGeom>
+          <a:ln>
+            <a:solidFill>
+              <a:schemeClr val="bg1">
+                <a:lumMod val="65000"/>
+              </a:schemeClr>
+            </a:solidFill>
+            <a:tailEnd type="triangle"/>
+          </a:ln>
+        </p:spPr>
+        <p:style>
+          <a:lnRef idx="1">
+            <a:schemeClr val="accent1"/>
+          </a:lnRef>
+          <a:fillRef idx="0">
+            <a:schemeClr val="accent1"/>
+          </a:fillRef>
+          <a:effectRef idx="0">
+            <a:schemeClr val="accent1"/>
+          </a:effectRef>
+          <a:fontRef idx="minor">
+            <a:schemeClr val="tx1"/>
+          </a:fontRef>
+        </p:style>
+      </p:cxnSp>
+      <p:cxnSp>
+        <p:nvCxnSpPr>
+          <p:cNvPr id="82" name="Straight Arrow Connector 81">
+            <a:extLst>
+              <a:ext uri="{FF2B5EF4-FFF2-40B4-BE49-F238E27FC236}">
+                <a16:creationId xmlns:a16="http://schemas.microsoft.com/office/drawing/2014/main" id="{BFAE4691-A331-4DBF-B116-0C1888F2171E}"/>
+              </a:ext>
+            </a:extLst>
+          </p:cNvPr>
+          <p:cNvCxnSpPr>
+            <a:cxnSpLocks/>
+            <a:endCxn id="80" idx="0"/>
+          </p:cNvCxnSpPr>
+          <p:nvPr/>
+        </p:nvCxnSpPr>
+        <p:spPr>
+          <a:xfrm flipH="1">
+            <a:off x="3056851" y="5023080"/>
+            <a:ext cx="831374" cy="436826"/>
+          </a:xfrm>
+          <a:prstGeom prst="straightConnector1">
+            <a:avLst/>
+          </a:prstGeom>
+          <a:ln>
+            <a:solidFill>
+              <a:schemeClr val="bg1">
+                <a:lumMod val="65000"/>
+              </a:schemeClr>
+            </a:solidFill>
+            <a:tailEnd type="triangle"/>
+          </a:ln>
+        </p:spPr>
+        <p:style>
+          <a:lnRef idx="1">
+            <a:schemeClr val="accent1"/>
+          </a:lnRef>
+          <a:fillRef idx="0">
+            <a:schemeClr val="accent1"/>
+          </a:fillRef>
+          <a:effectRef idx="0">
+            <a:schemeClr val="accent1"/>
+          </a:effectRef>
+          <a:fontRef idx="minor">
+            <a:schemeClr val="tx1"/>
+          </a:fontRef>
+        </p:style>
+      </p:cxnSp>
+      <p:sp>
+        <p:nvSpPr>
+          <p:cNvPr id="83" name="Rectangle 82">
+            <a:extLst>
+              <a:ext uri="{FF2B5EF4-FFF2-40B4-BE49-F238E27FC236}">
+                <a16:creationId xmlns:a16="http://schemas.microsoft.com/office/drawing/2014/main" id="{B2BD9BD0-063F-41F0-AF7A-83DA5949A806}"/>
+              </a:ext>
+            </a:extLst>
+          </p:cNvPr>
+          <p:cNvSpPr/>
+          <p:nvPr/>
+        </p:nvSpPr>
+        <p:spPr>
+          <a:xfrm>
+            <a:off x="2213049" y="5809625"/>
+            <a:ext cx="1675112" cy="261610"/>
+          </a:xfrm>
+          <a:prstGeom prst="rect">
+            <a:avLst/>
+          </a:prstGeom>
+        </p:spPr>
+        <p:txBody>
+          <a:bodyPr wrap="square">
+            <a:spAutoFit/>
+          </a:bodyPr>
+          <a:lstStyle/>
+          <a:p>
+            <a:pPr algn="ctr"/>
+            <a:r>
+              <a:rPr lang="en-US" sz="1100" dirty="0">
+                <a:latin typeface="Arial" panose="020B0604020202020204" pitchFamily="34" charset="0"/>
+                <a:cs typeface="Arial" panose="020B0604020202020204" pitchFamily="34" charset="0"/>
+              </a:rPr>
+              <a:t>Detected Datasets</a:t>
+            </a:r>
+            <a:endParaRPr lang="de-DE" sz="1100" dirty="0">
+              <a:latin typeface="Arial" panose="020B0604020202020204" pitchFamily="34" charset="0"/>
+              <a:cs typeface="Arial" panose="020B0604020202020204" pitchFamily="34" charset="0"/>
+            </a:endParaRPr>
+          </a:p>
+        </p:txBody>
+      </p:sp>
+      <p:sp>
+        <p:nvSpPr>
+          <p:cNvPr id="89" name="Rectangle: Rounded Corners 88">
+            <a:extLst>
+              <a:ext uri="{FF2B5EF4-FFF2-40B4-BE49-F238E27FC236}">
+                <a16:creationId xmlns:a16="http://schemas.microsoft.com/office/drawing/2014/main" id="{E036A8D5-381A-49F8-A9E1-4091609F5EF9}"/>
+              </a:ext>
+            </a:extLst>
+          </p:cNvPr>
+          <p:cNvSpPr/>
+          <p:nvPr/>
+        </p:nvSpPr>
+        <p:spPr>
+          <a:xfrm>
+            <a:off x="3460666" y="2756973"/>
             <a:ext cx="847452" cy="351647"/>
           </a:xfrm>
           <a:prstGeom prst="roundRect">
@@ -4173,7 +4434,7 @@
                 <a:latin typeface="Arial" panose="020B0604020202020204" pitchFamily="34" charset="0"/>
                 <a:cs typeface="Arial" panose="020B0604020202020204" pitchFamily="34" charset="0"/>
               </a:rPr>
-              <a:t>2075</a:t>
+              <a:t>1583</a:t>
             </a:r>
             <a:endParaRPr lang="de-DE" sz="1200" dirty="0">
               <a:solidFill>
@@ -4185,60 +4446,12 @@
           </a:p>
         </p:txBody>
       </p:sp>
-      <p:cxnSp>
-        <p:nvCxnSpPr>
-          <p:cNvPr id="67" name="Straight Arrow Connector 66">
+      <p:sp>
+        <p:nvSpPr>
+          <p:cNvPr id="91" name="Rectangle 90">
             <a:extLst>
               <a:ext uri="{FF2B5EF4-FFF2-40B4-BE49-F238E27FC236}">
-                <a16:creationId xmlns:a16="http://schemas.microsoft.com/office/drawing/2014/main" id="{546E5E13-378B-484F-A381-094CCFBA2949}"/>
-              </a:ext>
-            </a:extLst>
-          </p:cNvPr>
-          <p:cNvCxnSpPr>
-            <a:cxnSpLocks/>
-            <a:stCxn id="66" idx="2"/>
-            <a:endCxn id="9" idx="0"/>
-          </p:cNvCxnSpPr>
-          <p:nvPr/>
-        </p:nvCxnSpPr>
-        <p:spPr>
-          <a:xfrm>
-            <a:off x="3888208" y="3156870"/>
-            <a:ext cx="0" cy="582675"/>
-          </a:xfrm>
-          <a:prstGeom prst="straightConnector1">
-            <a:avLst/>
-          </a:prstGeom>
-          <a:ln>
-            <a:solidFill>
-              <a:schemeClr val="bg1">
-                <a:lumMod val="65000"/>
-              </a:schemeClr>
-            </a:solidFill>
-            <a:tailEnd type="triangle"/>
-          </a:ln>
-        </p:spPr>
-        <p:style>
-          <a:lnRef idx="1">
-            <a:schemeClr val="accent1"/>
-          </a:lnRef>
-          <a:fillRef idx="0">
-            <a:schemeClr val="accent1"/>
-          </a:fillRef>
-          <a:effectRef idx="0">
-            <a:schemeClr val="accent1"/>
-          </a:effectRef>
-          <a:fontRef idx="minor">
-            <a:schemeClr val="tx1"/>
-          </a:fontRef>
-        </p:style>
-      </p:cxnSp>
-      <p:sp>
-        <p:nvSpPr>
-          <p:cNvPr id="68" name="Rectangle 67">
-            <a:extLst>
-              <a:ext uri="{FF2B5EF4-FFF2-40B4-BE49-F238E27FC236}">
-                <a16:creationId xmlns:a16="http://schemas.microsoft.com/office/drawing/2014/main" id="{93AD1DEF-5289-457F-B458-79BF20D3C8FF}"/>
+                <a16:creationId xmlns:a16="http://schemas.microsoft.com/office/drawing/2014/main" id="{05DFAD21-E790-4E44-A833-74531D5D852B}"/>
               </a:ext>
             </a:extLst>
           </p:cNvPr>
@@ -4247,8 +4460,8 @@
         </p:nvSpPr>
         <p:spPr>
           <a:xfrm>
-            <a:off x="4308118" y="2842546"/>
-            <a:ext cx="1372571" cy="261610"/>
+            <a:off x="4308118" y="2739829"/>
+            <a:ext cx="1665950" cy="430887"/>
           </a:xfrm>
           <a:prstGeom prst="rect">
             <a:avLst/>
@@ -4260,12 +4473,19 @@
           </a:bodyPr>
           <a:lstStyle/>
           <a:p>
+            <a:r>
+              <a:rPr lang="en-US" sz="1100" dirty="0" err="1">
+                <a:latin typeface="Arial" panose="020B0604020202020204" pitchFamily="34" charset="0"/>
+                <a:cs typeface="Arial" panose="020B0604020202020204" pitchFamily="34" charset="0"/>
+              </a:rPr>
+              <a:t>Charité</a:t>
+            </a:r>
             <a:r>
               <a:rPr lang="en-US" sz="1100" dirty="0">
                 <a:latin typeface="Arial" panose="020B0604020202020204" pitchFamily="34" charset="0"/>
                 <a:cs typeface="Arial" panose="020B0604020202020204" pitchFamily="34" charset="0"/>
               </a:rPr>
-              <a:t>Charité Datasets</a:t>
+              <a:t> Papers with Shared Datasets</a:t>
             </a:r>
             <a:endParaRPr lang="de-DE" sz="1100" dirty="0">
               <a:latin typeface="Arial" panose="020B0604020202020204" pitchFamily="34" charset="0"/>
@@ -4276,10 +4496,10 @@
       </p:sp>
       <p:sp>
         <p:nvSpPr>
-          <p:cNvPr id="80" name="Rectangle: Rounded Corners 79">
+          <p:cNvPr id="31" name="Rectangle: Rounded Corners 30">
             <a:extLst>
               <a:ext uri="{FF2B5EF4-FFF2-40B4-BE49-F238E27FC236}">
-                <a16:creationId xmlns:a16="http://schemas.microsoft.com/office/drawing/2014/main" id="{D114DA72-2DDC-49FF-88D2-5DA57C7BF46C}"/>
+                <a16:creationId xmlns:a16="http://schemas.microsoft.com/office/drawing/2014/main" id="{9F56F1E4-3546-4BA0-88CD-F399B7C26180}"/>
               </a:ext>
             </a:extLst>
           </p:cNvPr>
@@ -4288,282 +4508,7 @@
         </p:nvSpPr>
         <p:spPr>
           <a:xfrm>
-            <a:off x="2649219" y="5459906"/>
-            <a:ext cx="815263" cy="351647"/>
-          </a:xfrm>
-          <a:prstGeom prst="roundRect">
-            <a:avLst/>
-          </a:prstGeom>
-          <a:gradFill flip="none" rotWithShape="1">
-            <a:gsLst>
-              <a:gs pos="84000">
-                <a:srgbClr val="D8F6E3"/>
-              </a:gs>
-              <a:gs pos="65000">
-                <a:srgbClr val="93FF81"/>
-              </a:gs>
-              <a:gs pos="100000">
-                <a:srgbClr val="D9FFDD"/>
-              </a:gs>
-            </a:gsLst>
-            <a:lin ang="18900000" scaled="1"/>
-            <a:tileRect/>
-          </a:gradFill>
-          <a:ln>
-            <a:noFill/>
-          </a:ln>
-          <a:effectLst>
-            <a:outerShdw blurRad="50800" dist="38100" dir="8100000" algn="tr" rotWithShape="0">
-              <a:prstClr val="black">
-                <a:alpha val="40000"/>
-              </a:prstClr>
-            </a:outerShdw>
-          </a:effectLst>
-        </p:spPr>
-        <p:style>
-          <a:lnRef idx="2">
-            <a:schemeClr val="accent1">
-              <a:shade val="50000"/>
-            </a:schemeClr>
-          </a:lnRef>
-          <a:fillRef idx="1">
-            <a:schemeClr val="accent1"/>
-          </a:fillRef>
-          <a:effectRef idx="0">
-            <a:schemeClr val="accent1"/>
-          </a:effectRef>
-          <a:fontRef idx="minor">
-            <a:schemeClr val="lt1"/>
-          </a:fontRef>
-        </p:style>
-        <p:txBody>
-          <a:bodyPr rtlCol="0" anchor="ctr"/>
-          <a:lstStyle/>
-          <a:p>
-            <a:pPr algn="ctr"/>
-            <a:r>
-              <a:rPr lang="en-US" sz="1200" dirty="0">
-                <a:solidFill>
-                  <a:schemeClr val="tx1"/>
-                </a:solidFill>
-                <a:latin typeface="Arial" panose="020B0604020202020204" pitchFamily="34" charset="0"/>
-                <a:cs typeface="Arial" panose="020B0604020202020204" pitchFamily="34" charset="0"/>
-              </a:rPr>
-              <a:t>176</a:t>
-            </a:r>
-            <a:endParaRPr lang="de-DE" sz="1200" dirty="0">
-              <a:solidFill>
-                <a:schemeClr val="tx1"/>
-              </a:solidFill>
-              <a:latin typeface="Arial" panose="020B0604020202020204" pitchFamily="34" charset="0"/>
-              <a:cs typeface="Arial" panose="020B0604020202020204" pitchFamily="34" charset="0"/>
-            </a:endParaRPr>
-          </a:p>
-        </p:txBody>
-      </p:sp>
-      <p:cxnSp>
-        <p:nvCxnSpPr>
-          <p:cNvPr id="81" name="Straight Arrow Connector 80">
-            <a:extLst>
-              <a:ext uri="{FF2B5EF4-FFF2-40B4-BE49-F238E27FC236}">
-                <a16:creationId xmlns:a16="http://schemas.microsoft.com/office/drawing/2014/main" id="{DEBAAEA7-28FC-4C4C-85C6-F295E82C619C}"/>
-              </a:ext>
-            </a:extLst>
-          </p:cNvPr>
-          <p:cNvCxnSpPr>
-            <a:cxnSpLocks/>
-            <a:endCxn id="80" idx="0"/>
-          </p:cNvCxnSpPr>
-          <p:nvPr/>
-        </p:nvCxnSpPr>
-        <p:spPr>
-          <a:xfrm>
-            <a:off x="2189495" y="5023080"/>
-            <a:ext cx="867356" cy="436826"/>
-          </a:xfrm>
-          <a:prstGeom prst="straightConnector1">
-            <a:avLst/>
-          </a:prstGeom>
-          <a:ln>
-            <a:solidFill>
-              <a:schemeClr val="bg1">
-                <a:lumMod val="65000"/>
-              </a:schemeClr>
-            </a:solidFill>
-            <a:tailEnd type="triangle"/>
-          </a:ln>
-        </p:spPr>
-        <p:style>
-          <a:lnRef idx="1">
-            <a:schemeClr val="accent1"/>
-          </a:lnRef>
-          <a:fillRef idx="0">
-            <a:schemeClr val="accent1"/>
-          </a:fillRef>
-          <a:effectRef idx="0">
-            <a:schemeClr val="accent1"/>
-          </a:effectRef>
-          <a:fontRef idx="minor">
-            <a:schemeClr val="tx1"/>
-          </a:fontRef>
-        </p:style>
-      </p:cxnSp>
-      <p:cxnSp>
-        <p:nvCxnSpPr>
-          <p:cNvPr id="82" name="Straight Arrow Connector 81">
-            <a:extLst>
-              <a:ext uri="{FF2B5EF4-FFF2-40B4-BE49-F238E27FC236}">
-                <a16:creationId xmlns:a16="http://schemas.microsoft.com/office/drawing/2014/main" id="{BFAE4691-A331-4DBF-B116-0C1888F2171E}"/>
-              </a:ext>
-            </a:extLst>
-          </p:cNvPr>
-          <p:cNvCxnSpPr>
-            <a:cxnSpLocks/>
-            <a:endCxn id="80" idx="0"/>
-          </p:cNvCxnSpPr>
-          <p:nvPr/>
-        </p:nvCxnSpPr>
-        <p:spPr>
-          <a:xfrm flipH="1">
-            <a:off x="3056851" y="5023080"/>
-            <a:ext cx="831374" cy="436826"/>
-          </a:xfrm>
-          <a:prstGeom prst="straightConnector1">
-            <a:avLst/>
-          </a:prstGeom>
-          <a:ln>
-            <a:solidFill>
-              <a:schemeClr val="bg1">
-                <a:lumMod val="65000"/>
-              </a:schemeClr>
-            </a:solidFill>
-            <a:tailEnd type="triangle"/>
-          </a:ln>
-        </p:spPr>
-        <p:style>
-          <a:lnRef idx="1">
-            <a:schemeClr val="accent1"/>
-          </a:lnRef>
-          <a:fillRef idx="0">
-            <a:schemeClr val="accent1"/>
-          </a:fillRef>
-          <a:effectRef idx="0">
-            <a:schemeClr val="accent1"/>
-          </a:effectRef>
-          <a:fontRef idx="minor">
-            <a:schemeClr val="tx1"/>
-          </a:fontRef>
-        </p:style>
-      </p:cxnSp>
-      <p:sp>
-        <p:nvSpPr>
-          <p:cNvPr id="83" name="Rectangle 82">
-            <a:extLst>
-              <a:ext uri="{FF2B5EF4-FFF2-40B4-BE49-F238E27FC236}">
-                <a16:creationId xmlns:a16="http://schemas.microsoft.com/office/drawing/2014/main" id="{B2BD9BD0-063F-41F0-AF7A-83DA5949A806}"/>
-              </a:ext>
-            </a:extLst>
-          </p:cNvPr>
-          <p:cNvSpPr/>
-          <p:nvPr/>
-        </p:nvSpPr>
-        <p:spPr>
-          <a:xfrm>
-            <a:off x="2213049" y="5809625"/>
-            <a:ext cx="1675112" cy="430887"/>
-          </a:xfrm>
-          <a:prstGeom prst="rect">
-            <a:avLst/>
-          </a:prstGeom>
-        </p:spPr>
-        <p:txBody>
-          <a:bodyPr wrap="square">
-            <a:spAutoFit/>
-          </a:bodyPr>
-          <a:lstStyle/>
-          <a:p>
-            <a:pPr algn="ctr"/>
-            <a:r>
-              <a:rPr lang="en-US" sz="1100" dirty="0">
-                <a:latin typeface="Arial" panose="020B0604020202020204" pitchFamily="34" charset="0"/>
-                <a:cs typeface="Arial" panose="020B0604020202020204" pitchFamily="34" charset="0"/>
-              </a:rPr>
-              <a:t>Detected Charité Datasets</a:t>
-            </a:r>
-            <a:endParaRPr lang="de-DE" sz="1100" dirty="0">
-              <a:latin typeface="Arial" panose="020B0604020202020204" pitchFamily="34" charset="0"/>
-              <a:cs typeface="Arial" panose="020B0604020202020204" pitchFamily="34" charset="0"/>
-            </a:endParaRPr>
-          </a:p>
-        </p:txBody>
-      </p:sp>
-      <p:sp>
-        <p:nvSpPr>
-          <p:cNvPr id="84" name="Rectangle 83">
-            <a:extLst>
-              <a:ext uri="{FF2B5EF4-FFF2-40B4-BE49-F238E27FC236}">
-                <a16:creationId xmlns:a16="http://schemas.microsoft.com/office/drawing/2014/main" id="{A02124E0-F757-48A6-A940-07EAF3578E3C}"/>
-              </a:ext>
-            </a:extLst>
-          </p:cNvPr>
-          <p:cNvSpPr/>
-          <p:nvPr/>
-        </p:nvSpPr>
-        <p:spPr>
-          <a:xfrm>
-            <a:off x="2799386" y="4642761"/>
-            <a:ext cx="462817" cy="246221"/>
-          </a:xfrm>
-          <a:prstGeom prst="rect">
-            <a:avLst/>
-          </a:prstGeom>
-        </p:spPr>
-        <p:txBody>
-          <a:bodyPr wrap="square">
-            <a:spAutoFit/>
-          </a:bodyPr>
-          <a:lstStyle/>
-          <a:p>
-            <a:pPr algn="ctr"/>
-            <a:r>
-              <a:rPr lang="en-US" sz="1000" dirty="0">
-                <a:solidFill>
-                  <a:schemeClr val="bg1">
-                    <a:lumMod val="50000"/>
-                  </a:schemeClr>
-                </a:solidFill>
-                <a:latin typeface="Arial" panose="020B0604020202020204" pitchFamily="34" charset="0"/>
-                <a:cs typeface="Arial" panose="020B0604020202020204" pitchFamily="34" charset="0"/>
-              </a:rPr>
-              <a:t>(62)</a:t>
-            </a:r>
-            <a:endParaRPr lang="de-DE" sz="1000" dirty="0">
-              <a:solidFill>
-                <a:schemeClr val="bg1">
-                  <a:lumMod val="50000"/>
-                </a:schemeClr>
-              </a:solidFill>
-              <a:latin typeface="Arial" panose="020B0604020202020204" pitchFamily="34" charset="0"/>
-              <a:cs typeface="Arial" panose="020B0604020202020204" pitchFamily="34" charset="0"/>
-            </a:endParaRPr>
-          </a:p>
-        </p:txBody>
-      </p:sp>
-      <p:sp>
-        <p:nvSpPr>
-          <p:cNvPr id="89" name="Rectangle: Rounded Corners 88">
-            <a:extLst>
-              <a:ext uri="{FF2B5EF4-FFF2-40B4-BE49-F238E27FC236}">
-                <a16:creationId xmlns:a16="http://schemas.microsoft.com/office/drawing/2014/main" id="{E036A8D5-381A-49F8-A9E1-4091609F5EF9}"/>
-              </a:ext>
-            </a:extLst>
-          </p:cNvPr>
-          <p:cNvSpPr/>
-          <p:nvPr/>
-        </p:nvSpPr>
-        <p:spPr>
-          <a:xfrm>
-            <a:off x="3460666" y="1868520"/>
+            <a:off x="2649219" y="1571077"/>
             <a:ext cx="847452" cy="351647"/>
           </a:xfrm>
           <a:prstGeom prst="roundRect">
@@ -4629,7 +4574,7 @@
                 <a:latin typeface="Arial" panose="020B0604020202020204" pitchFamily="34" charset="0"/>
                 <a:cs typeface="Arial" panose="020B0604020202020204" pitchFamily="34" charset="0"/>
               </a:rPr>
-              <a:t>1589</a:t>
+              <a:t>?</a:t>
             </a:r>
             <a:endParaRPr lang="de-DE" sz="1200" dirty="0">
               <a:solidFill>
@@ -4641,26 +4586,73 @@
           </a:p>
         </p:txBody>
       </p:sp>
+      <p:sp>
+        <p:nvSpPr>
+          <p:cNvPr id="32" name="Rectangle 31">
+            <a:extLst>
+              <a:ext uri="{FF2B5EF4-FFF2-40B4-BE49-F238E27FC236}">
+                <a16:creationId xmlns:a16="http://schemas.microsoft.com/office/drawing/2014/main" id="{7A54B268-A57D-466C-96B2-2B4869C1802D}"/>
+              </a:ext>
+            </a:extLst>
+          </p:cNvPr>
+          <p:cNvSpPr/>
+          <p:nvPr/>
+        </p:nvSpPr>
+        <p:spPr>
+          <a:xfrm>
+            <a:off x="3587268" y="1610108"/>
+            <a:ext cx="1665950" cy="261610"/>
+          </a:xfrm>
+          <a:prstGeom prst="rect">
+            <a:avLst/>
+          </a:prstGeom>
+        </p:spPr>
+        <p:txBody>
+          <a:bodyPr wrap="square">
+            <a:spAutoFit/>
+          </a:bodyPr>
+          <a:lstStyle/>
+          <a:p>
+            <a:r>
+              <a:rPr lang="en-US" sz="1100" dirty="0" err="1">
+                <a:latin typeface="Arial" panose="020B0604020202020204" pitchFamily="34" charset="0"/>
+                <a:cs typeface="Arial" panose="020B0604020202020204" pitchFamily="34" charset="0"/>
+              </a:rPr>
+              <a:t>Charité</a:t>
+            </a:r>
+            <a:r>
+              <a:rPr lang="en-US" sz="1100" dirty="0">
+                <a:latin typeface="Arial" panose="020B0604020202020204" pitchFamily="34" charset="0"/>
+                <a:cs typeface="Arial" panose="020B0604020202020204" pitchFamily="34" charset="0"/>
+              </a:rPr>
+              <a:t> Papers</a:t>
+            </a:r>
+            <a:endParaRPr lang="de-DE" sz="1100" dirty="0">
+              <a:latin typeface="Arial" panose="020B0604020202020204" pitchFamily="34" charset="0"/>
+              <a:cs typeface="Arial" panose="020B0604020202020204" pitchFamily="34" charset="0"/>
+            </a:endParaRPr>
+          </a:p>
+        </p:txBody>
+      </p:sp>
       <p:cxnSp>
         <p:nvCxnSpPr>
-          <p:cNvPr id="90" name="Straight Arrow Connector 89">
+          <p:cNvPr id="4" name="Straight Arrow Connector 3">
             <a:extLst>
               <a:ext uri="{FF2B5EF4-FFF2-40B4-BE49-F238E27FC236}">
-                <a16:creationId xmlns:a16="http://schemas.microsoft.com/office/drawing/2014/main" id="{C4022197-50F9-4E7D-93EC-E8857B9CE880}"/>
+                <a16:creationId xmlns:a16="http://schemas.microsoft.com/office/drawing/2014/main" id="{AC44CFEE-44A3-463A-B397-18E4801C7FA1}"/>
               </a:ext>
             </a:extLst>
           </p:cNvPr>
           <p:cNvCxnSpPr>
-            <a:cxnSpLocks/>
-            <a:stCxn id="89" idx="2"/>
-            <a:endCxn id="66" idx="0"/>
+            <a:stCxn id="37" idx="3"/>
+            <a:endCxn id="11" idx="1"/>
           </p:cNvCxnSpPr>
           <p:nvPr/>
         </p:nvCxnSpPr>
         <p:spPr>
           <a:xfrm>
-            <a:off x="3884392" y="2220167"/>
-            <a:ext cx="3816" cy="585056"/>
+            <a:off x="2597109" y="4835600"/>
+            <a:ext cx="867373" cy="0"/>
           </a:xfrm>
           <a:prstGeom prst="straightConnector1">
             <a:avLst/>
@@ -4671,6 +4663,7 @@
                 <a:lumMod val="65000"/>
               </a:schemeClr>
             </a:solidFill>
+            <a:headEnd type="triangle"/>
             <a:tailEnd type="triangle"/>
           </a:ln>
         </p:spPr>
@@ -4689,12 +4682,61 @@
           </a:fontRef>
         </p:style>
       </p:cxnSp>
-      <p:sp>
-        <p:nvSpPr>
-          <p:cNvPr id="91" name="Rectangle 90">
+      <p:cxnSp>
+        <p:nvCxnSpPr>
+          <p:cNvPr id="40" name="Straight Arrow Connector 39">
             <a:extLst>
               <a:ext uri="{FF2B5EF4-FFF2-40B4-BE49-F238E27FC236}">
-                <a16:creationId xmlns:a16="http://schemas.microsoft.com/office/drawing/2014/main" id="{05DFAD21-E790-4E44-A833-74531D5D852B}"/>
+                <a16:creationId xmlns:a16="http://schemas.microsoft.com/office/drawing/2014/main" id="{0C5BEB27-C360-4D58-8AE3-C08092988058}"/>
+              </a:ext>
+            </a:extLst>
+          </p:cNvPr>
+          <p:cNvCxnSpPr>
+            <a:cxnSpLocks/>
+            <a:stCxn id="38" idx="3"/>
+            <a:endCxn id="13" idx="1"/>
+          </p:cNvCxnSpPr>
+          <p:nvPr/>
+        </p:nvCxnSpPr>
+        <p:spPr>
+          <a:xfrm>
+            <a:off x="2603500" y="6392104"/>
+            <a:ext cx="860999" cy="0"/>
+          </a:xfrm>
+          <a:prstGeom prst="straightConnector1">
+            <a:avLst/>
+          </a:prstGeom>
+          <a:ln>
+            <a:solidFill>
+              <a:schemeClr val="bg1">
+                <a:lumMod val="65000"/>
+              </a:schemeClr>
+            </a:solidFill>
+            <a:headEnd type="triangle"/>
+            <a:tailEnd type="triangle"/>
+          </a:ln>
+        </p:spPr>
+        <p:style>
+          <a:lnRef idx="1">
+            <a:schemeClr val="accent1"/>
+          </a:lnRef>
+          <a:fillRef idx="0">
+            <a:schemeClr val="accent1"/>
+          </a:fillRef>
+          <a:effectRef idx="0">
+            <a:schemeClr val="accent1"/>
+          </a:effectRef>
+          <a:fontRef idx="minor">
+            <a:schemeClr val="tx1"/>
+          </a:fontRef>
+        </p:style>
+      </p:cxnSp>
+      <p:sp>
+        <p:nvSpPr>
+          <p:cNvPr id="43" name="Rectangle 42">
+            <a:extLst>
+              <a:ext uri="{FF2B5EF4-FFF2-40B4-BE49-F238E27FC236}">
+                <a16:creationId xmlns:a16="http://schemas.microsoft.com/office/drawing/2014/main" id="{EED85551-9A16-4CFB-B3E1-92401FDE4558}"/>
               </a:ext>
             </a:extLst>
           </p:cNvPr>
@@ -4703,8 +4745,8 @@
         </p:nvSpPr>
         <p:spPr>
           <a:xfrm>
-            <a:off x="4304302" y="1905843"/>
-            <a:ext cx="1372571" cy="261610"/>
+            <a:off x="2744936" y="4620156"/>
+            <a:ext cx="571718" cy="230832"/>
           </a:xfrm>
           <a:prstGeom prst="rect">
             <a:avLst/>
@@ -4716,14 +4758,77 @@
           </a:bodyPr>
           <a:lstStyle/>
           <a:p>
-            <a:r>
-              <a:rPr lang="en-US" sz="1100" dirty="0">
+            <a:pPr algn="ctr"/>
+            <a:r>
+              <a:rPr lang="en-US" sz="900" dirty="0">
+                <a:solidFill>
+                  <a:schemeClr val="bg1">
+                    <a:lumMod val="65000"/>
+                  </a:schemeClr>
+                </a:solidFill>
                 <a:latin typeface="Arial" panose="020B0604020202020204" pitchFamily="34" charset="0"/>
                 <a:cs typeface="Arial" panose="020B0604020202020204" pitchFamily="34" charset="0"/>
               </a:rPr>
-              <a:t>Charité Papers</a:t>
-            </a:r>
-            <a:endParaRPr lang="de-DE" sz="1100" dirty="0">
+              <a:t>(62)</a:t>
+            </a:r>
+            <a:endParaRPr lang="de-DE" sz="900" dirty="0">
+              <a:solidFill>
+                <a:schemeClr val="bg1">
+                  <a:lumMod val="65000"/>
+                </a:schemeClr>
+              </a:solidFill>
+              <a:latin typeface="Arial" panose="020B0604020202020204" pitchFamily="34" charset="0"/>
+              <a:cs typeface="Arial" panose="020B0604020202020204" pitchFamily="34" charset="0"/>
+            </a:endParaRPr>
+          </a:p>
+        </p:txBody>
+      </p:sp>
+      <p:sp>
+        <p:nvSpPr>
+          <p:cNvPr id="44" name="Rectangle 43">
+            <a:extLst>
+              <a:ext uri="{FF2B5EF4-FFF2-40B4-BE49-F238E27FC236}">
+                <a16:creationId xmlns:a16="http://schemas.microsoft.com/office/drawing/2014/main" id="{53CC2D1C-CC06-4BB5-A6EA-12AC3E06A1F1}"/>
+              </a:ext>
+            </a:extLst>
+          </p:cNvPr>
+          <p:cNvSpPr/>
+          <p:nvPr/>
+        </p:nvSpPr>
+        <p:spPr>
+          <a:xfrm>
+            <a:off x="2751328" y="6190122"/>
+            <a:ext cx="571718" cy="230832"/>
+          </a:xfrm>
+          <a:prstGeom prst="rect">
+            <a:avLst/>
+          </a:prstGeom>
+        </p:spPr>
+        <p:txBody>
+          <a:bodyPr wrap="square">
+            <a:spAutoFit/>
+          </a:bodyPr>
+          <a:lstStyle/>
+          <a:p>
+            <a:pPr algn="ctr"/>
+            <a:r>
+              <a:rPr lang="en-US" sz="900" dirty="0">
+                <a:solidFill>
+                  <a:schemeClr val="bg1">
+                    <a:lumMod val="65000"/>
+                  </a:schemeClr>
+                </a:solidFill>
+                <a:latin typeface="Arial" panose="020B0604020202020204" pitchFamily="34" charset="0"/>
+                <a:cs typeface="Arial" panose="020B0604020202020204" pitchFamily="34" charset="0"/>
+              </a:rPr>
+              <a:t>(325)</a:t>
+            </a:r>
+            <a:endParaRPr lang="de-DE" sz="900" dirty="0">
+              <a:solidFill>
+                <a:schemeClr val="bg1">
+                  <a:lumMod val="65000"/>
+                </a:schemeClr>
+              </a:solidFill>
               <a:latin typeface="Arial" panose="020B0604020202020204" pitchFamily="34" charset="0"/>
               <a:cs typeface="Arial" panose="020B0604020202020204" pitchFamily="34" charset="0"/>
             </a:endParaRPr>
@@ -5148,14 +5253,14 @@
           <a:p>
             <a:pPr algn="ctr"/>
             <a:r>
-              <a:rPr lang="en-US" sz="1200">
+              <a:rPr lang="en-US" sz="1200" dirty="0">
                 <a:solidFill>
                   <a:schemeClr val="tx1"/>
                 </a:solidFill>
                 <a:latin typeface="Arial" panose="020B0604020202020204" pitchFamily="34" charset="0"/>
                 <a:cs typeface="Arial" panose="020B0604020202020204" pitchFamily="34" charset="0"/>
               </a:rPr>
-              <a:t>35</a:t>
+              <a:t>34</a:t>
             </a:r>
             <a:endParaRPr lang="de-DE" sz="1200" dirty="0">
               <a:solidFill>

</xml_diff>

<commit_message>
added and fixed plots and counts according to notes from 16.10.2025 meeting. 2 data articles plots are waiting for the input data. Next steps: continue adding counts to papers, write methods section.
</commit_message>
<xml_diff>
--- a/plots_png/pptx/plots_png.pptx
+++ b/plots_png/pptx/plots_png.pptx
@@ -244,7 +244,7 @@
           <a:p>
             <a:fld id="{83D14EEA-DE26-4810-8E05-A65F0010FADE}" type="datetimeFigureOut">
               <a:rPr lang="de-DE" smtClean="0"/>
-              <a:t>21.10.2025</a:t>
+              <a:t>22.10.2025</a:t>
             </a:fld>
             <a:endParaRPr lang="de-DE"/>
           </a:p>
@@ -414,7 +414,7 @@
           <a:p>
             <a:fld id="{83D14EEA-DE26-4810-8E05-A65F0010FADE}" type="datetimeFigureOut">
               <a:rPr lang="de-DE" smtClean="0"/>
-              <a:t>21.10.2025</a:t>
+              <a:t>22.10.2025</a:t>
             </a:fld>
             <a:endParaRPr lang="de-DE"/>
           </a:p>
@@ -594,7 +594,7 @@
           <a:p>
             <a:fld id="{83D14EEA-DE26-4810-8E05-A65F0010FADE}" type="datetimeFigureOut">
               <a:rPr lang="de-DE" smtClean="0"/>
-              <a:t>21.10.2025</a:t>
+              <a:t>22.10.2025</a:t>
             </a:fld>
             <a:endParaRPr lang="de-DE"/>
           </a:p>
@@ -764,7 +764,7 @@
           <a:p>
             <a:fld id="{83D14EEA-DE26-4810-8E05-A65F0010FADE}" type="datetimeFigureOut">
               <a:rPr lang="de-DE" smtClean="0"/>
-              <a:t>21.10.2025</a:t>
+              <a:t>22.10.2025</a:t>
             </a:fld>
             <a:endParaRPr lang="de-DE"/>
           </a:p>
@@ -1008,7 +1008,7 @@
           <a:p>
             <a:fld id="{83D14EEA-DE26-4810-8E05-A65F0010FADE}" type="datetimeFigureOut">
               <a:rPr lang="de-DE" smtClean="0"/>
-              <a:t>21.10.2025</a:t>
+              <a:t>22.10.2025</a:t>
             </a:fld>
             <a:endParaRPr lang="de-DE"/>
           </a:p>
@@ -1240,7 +1240,7 @@
           <a:p>
             <a:fld id="{83D14EEA-DE26-4810-8E05-A65F0010FADE}" type="datetimeFigureOut">
               <a:rPr lang="de-DE" smtClean="0"/>
-              <a:t>21.10.2025</a:t>
+              <a:t>22.10.2025</a:t>
             </a:fld>
             <a:endParaRPr lang="de-DE"/>
           </a:p>
@@ -1607,7 +1607,7 @@
           <a:p>
             <a:fld id="{83D14EEA-DE26-4810-8E05-A65F0010FADE}" type="datetimeFigureOut">
               <a:rPr lang="de-DE" smtClean="0"/>
-              <a:t>21.10.2025</a:t>
+              <a:t>22.10.2025</a:t>
             </a:fld>
             <a:endParaRPr lang="de-DE"/>
           </a:p>
@@ -1725,7 +1725,7 @@
           <a:p>
             <a:fld id="{83D14EEA-DE26-4810-8E05-A65F0010FADE}" type="datetimeFigureOut">
               <a:rPr lang="de-DE" smtClean="0"/>
-              <a:t>21.10.2025</a:t>
+              <a:t>22.10.2025</a:t>
             </a:fld>
             <a:endParaRPr lang="de-DE"/>
           </a:p>
@@ -1820,7 +1820,7 @@
           <a:p>
             <a:fld id="{83D14EEA-DE26-4810-8E05-A65F0010FADE}" type="datetimeFigureOut">
               <a:rPr lang="de-DE" smtClean="0"/>
-              <a:t>21.10.2025</a:t>
+              <a:t>22.10.2025</a:t>
             </a:fld>
             <a:endParaRPr lang="de-DE"/>
           </a:p>
@@ -2097,7 +2097,7 @@
           <a:p>
             <a:fld id="{83D14EEA-DE26-4810-8E05-A65F0010FADE}" type="datetimeFigureOut">
               <a:rPr lang="de-DE" smtClean="0"/>
-              <a:t>21.10.2025</a:t>
+              <a:t>22.10.2025</a:t>
             </a:fld>
             <a:endParaRPr lang="de-DE"/>
           </a:p>
@@ -2354,7 +2354,7 @@
           <a:p>
             <a:fld id="{83D14EEA-DE26-4810-8E05-A65F0010FADE}" type="datetimeFigureOut">
               <a:rPr lang="de-DE" smtClean="0"/>
-              <a:t>21.10.2025</a:t>
+              <a:t>22.10.2025</a:t>
             </a:fld>
             <a:endParaRPr lang="de-DE"/>
           </a:p>
@@ -2567,7 +2567,7 @@
           <a:p>
             <a:fld id="{83D14EEA-DE26-4810-8E05-A65F0010FADE}" type="datetimeFigureOut">
               <a:rPr lang="de-DE" smtClean="0"/>
-              <a:t>21.10.2025</a:t>
+              <a:t>22.10.2025</a:t>
             </a:fld>
             <a:endParaRPr lang="de-DE"/>
           </a:p>
@@ -3052,7 +3052,7 @@
                 <a:latin typeface="Arial" panose="020B0604020202020204" pitchFamily="34" charset="0"/>
                 <a:cs typeface="Arial" panose="020B0604020202020204" pitchFamily="34" charset="0"/>
               </a:rPr>
-              <a:t>1919</a:t>
+              <a:t>2385</a:t>
             </a:r>
             <a:endParaRPr lang="de-DE" sz="1200" dirty="0">
               <a:solidFill>
@@ -3399,7 +3399,7 @@
         </p:nvSpPr>
         <p:spPr>
           <a:xfrm>
-            <a:off x="4271005" y="4697099"/>
+            <a:off x="4271005" y="4634156"/>
             <a:ext cx="2126949" cy="430887"/>
           </a:xfrm>
           <a:prstGeom prst="rect">
@@ -3445,7 +3445,7 @@
         </p:nvSpPr>
         <p:spPr>
           <a:xfrm>
-            <a:off x="4311934" y="6253603"/>
+            <a:off x="4303434" y="6176659"/>
             <a:ext cx="2126948" cy="430887"/>
           </a:xfrm>
           <a:prstGeom prst="rect">
@@ -3883,7 +3883,7 @@
                 <a:latin typeface="Arial" panose="020B0604020202020204" pitchFamily="34" charset="0"/>
                 <a:cs typeface="Arial" panose="020B0604020202020204" pitchFamily="34" charset="0"/>
               </a:rPr>
-              <a:t>Mentioned  Datasets</a:t>
+              <a:t>Mentioned Datasets</a:t>
             </a:r>
           </a:p>
           <a:p>
@@ -3893,21 +3893,7 @@
                 <a:latin typeface="Arial" panose="020B0604020202020204" pitchFamily="34" charset="0"/>
                 <a:cs typeface="Arial" panose="020B0604020202020204" pitchFamily="34" charset="0"/>
               </a:rPr>
-              <a:t>(</a:t>
-            </a:r>
-            <a:r>
-              <a:rPr lang="en-US" sz="1100" dirty="0" err="1">
-                <a:latin typeface="Arial" panose="020B0604020202020204" pitchFamily="34" charset="0"/>
-                <a:cs typeface="Arial" panose="020B0604020202020204" pitchFamily="34" charset="0"/>
-              </a:rPr>
-              <a:t>DataStet</a:t>
-            </a:r>
-            <a:r>
-              <a:rPr lang="en-US" sz="1100" dirty="0">
-                <a:latin typeface="Arial" panose="020B0604020202020204" pitchFamily="34" charset="0"/>
-                <a:cs typeface="Arial" panose="020B0604020202020204" pitchFamily="34" charset="0"/>
-              </a:rPr>
-              <a:t>)</a:t>
+              <a:t>(DataStet)</a:t>
             </a:r>
             <a:endParaRPr lang="de-DE" sz="1100" dirty="0">
               <a:latin typeface="Arial" panose="020B0604020202020204" pitchFamily="34" charset="0"/>
@@ -3959,21 +3945,7 @@
                 <a:latin typeface="Arial" panose="020B0604020202020204" pitchFamily="34" charset="0"/>
                 <a:cs typeface="Arial" panose="020B0604020202020204" pitchFamily="34" charset="0"/>
               </a:rPr>
-              <a:t>(</a:t>
-            </a:r>
-            <a:r>
-              <a:rPr lang="en-US" sz="1100" dirty="0" err="1">
-                <a:latin typeface="Arial" panose="020B0604020202020204" pitchFamily="34" charset="0"/>
-                <a:cs typeface="Arial" panose="020B0604020202020204" pitchFamily="34" charset="0"/>
-              </a:rPr>
-              <a:t>DataStet</a:t>
-            </a:r>
-            <a:r>
-              <a:rPr lang="en-US" sz="1100" dirty="0">
-                <a:latin typeface="Arial" panose="020B0604020202020204" pitchFamily="34" charset="0"/>
-                <a:cs typeface="Arial" panose="020B0604020202020204" pitchFamily="34" charset="0"/>
-              </a:rPr>
-              <a:t>)</a:t>
+              <a:t>(DataStet)</a:t>
             </a:r>
             <a:endParaRPr lang="de-DE" sz="1100" dirty="0">
               <a:latin typeface="Arial" panose="020B0604020202020204" pitchFamily="34" charset="0"/>
@@ -4044,8 +4016,8 @@
         </p:nvSpPr>
         <p:spPr>
           <a:xfrm>
-            <a:off x="2025389" y="7478810"/>
-            <a:ext cx="2050431" cy="430887"/>
+            <a:off x="1927797" y="7483280"/>
+            <a:ext cx="2245616" cy="822726"/>
           </a:xfrm>
           <a:prstGeom prst="rect">
             <a:avLst/>
@@ -4057,7 +4029,11 @@
           </a:bodyPr>
           <a:lstStyle/>
           <a:p>
-            <a:pPr algn="ctr"/>
+            <a:pPr algn="ctr">
+              <a:lnSpc>
+                <a:spcPct val="150000"/>
+              </a:lnSpc>
+            </a:pPr>
             <a:r>
               <a:rPr lang="en-US" sz="1100" dirty="0">
                 <a:latin typeface="Arial" panose="020B0604020202020204" pitchFamily="34" charset="0"/>
@@ -4067,7 +4043,39 @@
             </a:r>
           </a:p>
           <a:p>
-            <a:pPr algn="ctr"/>
+            <a:pPr algn="ctr">
+              <a:lnSpc>
+                <a:spcPct val="150000"/>
+              </a:lnSpc>
+            </a:pPr>
+            <a:r>
+              <a:rPr lang="en-US" sz="1100" dirty="0">
+                <a:solidFill>
+                  <a:schemeClr val="bg1">
+                    <a:lumMod val="50000"/>
+                  </a:schemeClr>
+                </a:solidFill>
+                <a:latin typeface="Arial" panose="020B0604020202020204" pitchFamily="34" charset="0"/>
+                <a:cs typeface="Arial" panose="020B0604020202020204" pitchFamily="34" charset="0"/>
+              </a:rPr>
+              <a:t>Published in 134 Charité Papers</a:t>
+            </a:r>
+            <a:endParaRPr lang="de-DE" sz="1100" dirty="0">
+              <a:solidFill>
+                <a:schemeClr val="bg1">
+                  <a:lumMod val="50000"/>
+                </a:schemeClr>
+              </a:solidFill>
+              <a:latin typeface="Arial" panose="020B0604020202020204" pitchFamily="34" charset="0"/>
+              <a:cs typeface="Arial" panose="020B0604020202020204" pitchFamily="34" charset="0"/>
+            </a:endParaRPr>
+          </a:p>
+          <a:p>
+            <a:pPr algn="ctr">
+              <a:lnSpc>
+                <a:spcPct val="150000"/>
+              </a:lnSpc>
+            </a:pPr>
             <a:r>
               <a:rPr lang="de-DE" sz="1100" dirty="0">
                 <a:solidFill>
@@ -4078,7 +4086,7 @@
                 <a:latin typeface="Arial" panose="020B0604020202020204" pitchFamily="34" charset="0"/>
                 <a:cs typeface="Arial" panose="020B0604020202020204" pitchFamily="34" charset="0"/>
               </a:rPr>
-              <a:t>(1390 Reusing Papers)</a:t>
+              <a:t>Reused by 1390 Papers</a:t>
             </a:r>
           </a:p>
         </p:txBody>
@@ -4326,7 +4334,7 @@
         </p:nvSpPr>
         <p:spPr>
           <a:xfrm>
-            <a:off x="2213049" y="5809625"/>
+            <a:off x="2199631" y="5840218"/>
             <a:ext cx="1675112" cy="261610"/>
           </a:xfrm>
           <a:prstGeom prst="rect">
@@ -4474,18 +4482,11 @@
           <a:lstStyle/>
           <a:p>
             <a:r>
-              <a:rPr lang="en-US" sz="1100" dirty="0" err="1">
-                <a:latin typeface="Arial" panose="020B0604020202020204" pitchFamily="34" charset="0"/>
-                <a:cs typeface="Arial" panose="020B0604020202020204" pitchFamily="34" charset="0"/>
-              </a:rPr>
-              <a:t>Charité</a:t>
-            </a:r>
-            <a:r>
               <a:rPr lang="en-US" sz="1100" dirty="0">
                 <a:latin typeface="Arial" panose="020B0604020202020204" pitchFamily="34" charset="0"/>
                 <a:cs typeface="Arial" panose="020B0604020202020204" pitchFamily="34" charset="0"/>
               </a:rPr>
-              <a:t> Papers with Shared Datasets</a:t>
+              <a:t>Charité Papers with Shared Datasets</a:t>
             </a:r>
             <a:endParaRPr lang="de-DE" sz="1100" dirty="0">
               <a:latin typeface="Arial" panose="020B0604020202020204" pitchFamily="34" charset="0"/>
@@ -4508,22 +4509,22 @@
         </p:nvSpPr>
         <p:spPr>
           <a:xfrm>
-            <a:off x="2649219" y="1571077"/>
-            <a:ext cx="847452" cy="351647"/>
+            <a:off x="2110235" y="1836272"/>
+            <a:ext cx="1880740" cy="351647"/>
           </a:xfrm>
           <a:prstGeom prst="roundRect">
             <a:avLst/>
           </a:prstGeom>
           <a:gradFill flip="none" rotWithShape="1">
             <a:gsLst>
-              <a:gs pos="84000">
-                <a:srgbClr val="FCE5D6"/>
+              <a:gs pos="69000">
+                <a:schemeClr val="accent2">
+                  <a:lumMod val="60000"/>
+                  <a:lumOff val="40000"/>
+                </a:schemeClr>
               </a:gs>
-              <a:gs pos="68000">
-                <a:schemeClr val="accent2">
-                  <a:lumMod val="40000"/>
-                  <a:lumOff val="60000"/>
-                </a:schemeClr>
+              <a:gs pos="0">
+                <a:schemeClr val="accent2"/>
               </a:gs>
               <a:gs pos="100000">
                 <a:schemeClr val="bg1">
@@ -4574,60 +4575,12 @@
                 <a:latin typeface="Arial" panose="020B0604020202020204" pitchFamily="34" charset="0"/>
                 <a:cs typeface="Arial" panose="020B0604020202020204" pitchFamily="34" charset="0"/>
               </a:rPr>
-              <a:t>?</a:t>
+              <a:t>15748 Charité Papers</a:t>
             </a:r>
             <a:endParaRPr lang="de-DE" sz="1200" dirty="0">
               <a:solidFill>
                 <a:schemeClr val="tx1"/>
               </a:solidFill>
-              <a:latin typeface="Arial" panose="020B0604020202020204" pitchFamily="34" charset="0"/>
-              <a:cs typeface="Arial" panose="020B0604020202020204" pitchFamily="34" charset="0"/>
-            </a:endParaRPr>
-          </a:p>
-        </p:txBody>
-      </p:sp>
-      <p:sp>
-        <p:nvSpPr>
-          <p:cNvPr id="32" name="Rectangle 31">
-            <a:extLst>
-              <a:ext uri="{FF2B5EF4-FFF2-40B4-BE49-F238E27FC236}">
-                <a16:creationId xmlns:a16="http://schemas.microsoft.com/office/drawing/2014/main" id="{7A54B268-A57D-466C-96B2-2B4869C1802D}"/>
-              </a:ext>
-            </a:extLst>
-          </p:cNvPr>
-          <p:cNvSpPr/>
-          <p:nvPr/>
-        </p:nvSpPr>
-        <p:spPr>
-          <a:xfrm>
-            <a:off x="3587268" y="1610108"/>
-            <a:ext cx="1665950" cy="261610"/>
-          </a:xfrm>
-          <a:prstGeom prst="rect">
-            <a:avLst/>
-          </a:prstGeom>
-        </p:spPr>
-        <p:txBody>
-          <a:bodyPr wrap="square">
-            <a:spAutoFit/>
-          </a:bodyPr>
-          <a:lstStyle/>
-          <a:p>
-            <a:r>
-              <a:rPr lang="en-US" sz="1100" dirty="0" err="1">
-                <a:latin typeface="Arial" panose="020B0604020202020204" pitchFamily="34" charset="0"/>
-                <a:cs typeface="Arial" panose="020B0604020202020204" pitchFamily="34" charset="0"/>
-              </a:rPr>
-              <a:t>Charité</a:t>
-            </a:r>
-            <a:r>
-              <a:rPr lang="en-US" sz="1100" dirty="0">
-                <a:latin typeface="Arial" panose="020B0604020202020204" pitchFamily="34" charset="0"/>
-                <a:cs typeface="Arial" panose="020B0604020202020204" pitchFamily="34" charset="0"/>
-              </a:rPr>
-              <a:t> Papers</a:t>
-            </a:r>
-            <a:endParaRPr lang="de-DE" sz="1100" dirty="0">
               <a:latin typeface="Arial" panose="020B0604020202020204" pitchFamily="34" charset="0"/>
               <a:cs typeface="Arial" panose="020B0604020202020204" pitchFamily="34" charset="0"/>
             </a:endParaRPr>

</xml_diff>

<commit_message>
Fixed plots according to 22.10.2025 meeting notes
</commit_message>
<xml_diff>
--- a/plots_png/pptx/plots_png.pptx
+++ b/plots_png/pptx/plots_png.pptx
@@ -2,13 +2,14 @@
 <file path=ppt/presentation.xml><?xml version="1.0" encoding="utf-8"?>
 <p:presentation xmlns:a="http://schemas.openxmlformats.org/drawingml/2006/main" xmlns:r="http://schemas.openxmlformats.org/officeDocument/2006/relationships" xmlns:p="http://schemas.openxmlformats.org/presentationml/2006/main" saveSubsetFonts="1">
   <p:sldMasterIdLst>
-    <p:sldMasterId id="2147483660" r:id="rId1"/>
+    <p:sldMasterId id="2147483672" r:id="rId1"/>
   </p:sldMasterIdLst>
   <p:sldIdLst>
     <p:sldId id="260" r:id="rId2"/>
     <p:sldId id="256" r:id="rId3"/>
+    <p:sldId id="261" r:id="rId4"/>
   </p:sldIdLst>
-  <p:sldSz cx="6858000" cy="12192000"/>
+  <p:sldSz cx="8047038" cy="12192000"/>
   <p:notesSz cx="6858000" cy="9144000"/>
   <p:defaultTextStyle>
     <a:defPPr>
@@ -107,7 +108,18 @@
   </p:defaultTextStyle>
   <p:extLst>
     <p:ext uri="{EFAFB233-063F-42B5-8137-9DF3F51BA10A}">
-      <p15:sldGuideLst xmlns:p15="http://schemas.microsoft.com/office/powerpoint/2012/main"/>
+      <p15:sldGuideLst xmlns:p15="http://schemas.microsoft.com/office/powerpoint/2012/main">
+        <p15:guide id="1" orient="horz" pos="3840" userDrawn="1">
+          <p15:clr>
+            <a:srgbClr val="A4A3A4"/>
+          </p15:clr>
+        </p15:guide>
+        <p15:guide id="2" pos="2534" userDrawn="1">
+          <p15:clr>
+            <a:srgbClr val="A4A3A4"/>
+          </p15:clr>
+        </p15:guide>
+      </p15:sldGuideLst>
     </p:ext>
   </p:extLst>
 </p:presentation>
@@ -142,15 +154,15 @@
         </p:nvSpPr>
         <p:spPr>
           <a:xfrm>
-            <a:off x="514350" y="1995312"/>
-            <a:ext cx="5829300" cy="4244622"/>
+            <a:off x="603528" y="1995312"/>
+            <a:ext cx="6839982" cy="4244622"/>
           </a:xfrm>
         </p:spPr>
         <p:txBody>
           <a:bodyPr anchor="b"/>
           <a:lstStyle>
             <a:lvl1pPr algn="ctr">
-              <a:defRPr sz="4500"/>
+              <a:defRPr sz="5280"/>
             </a:lvl1pPr>
           </a:lstStyle>
           <a:p>
@@ -174,8 +186,8 @@
         </p:nvSpPr>
         <p:spPr>
           <a:xfrm>
-            <a:off x="857250" y="6403623"/>
-            <a:ext cx="5143500" cy="2943577"/>
+            <a:off x="1005881" y="6403625"/>
+            <a:ext cx="6035279" cy="2943577"/>
           </a:xfrm>
         </p:spPr>
         <p:txBody>
@@ -183,39 +195,39 @@
           <a:lstStyle>
             <a:lvl1pPr marL="0" indent="0" algn="ctr">
               <a:buNone/>
-              <a:defRPr sz="1800"/>
+              <a:defRPr sz="2112"/>
             </a:lvl1pPr>
-            <a:lvl2pPr marL="342900" indent="0" algn="ctr">
+            <a:lvl2pPr marL="402360" indent="0" algn="ctr">
               <a:buNone/>
-              <a:defRPr sz="1500"/>
+              <a:defRPr sz="1760"/>
             </a:lvl2pPr>
-            <a:lvl3pPr marL="685800" indent="0" algn="ctr">
+            <a:lvl3pPr marL="804720" indent="0" algn="ctr">
               <a:buNone/>
-              <a:defRPr sz="1350"/>
+              <a:defRPr sz="1584"/>
             </a:lvl3pPr>
-            <a:lvl4pPr marL="1028700" indent="0" algn="ctr">
+            <a:lvl4pPr marL="1207080" indent="0" algn="ctr">
               <a:buNone/>
-              <a:defRPr sz="1200"/>
+              <a:defRPr sz="1408"/>
             </a:lvl4pPr>
-            <a:lvl5pPr marL="1371600" indent="0" algn="ctr">
+            <a:lvl5pPr marL="1609440" indent="0" algn="ctr">
               <a:buNone/>
-              <a:defRPr sz="1200"/>
+              <a:defRPr sz="1408"/>
             </a:lvl5pPr>
-            <a:lvl6pPr marL="1714500" indent="0" algn="ctr">
+            <a:lvl6pPr marL="2011800" indent="0" algn="ctr">
               <a:buNone/>
-              <a:defRPr sz="1200"/>
+              <a:defRPr sz="1408"/>
             </a:lvl6pPr>
-            <a:lvl7pPr marL="2057400" indent="0" algn="ctr">
+            <a:lvl7pPr marL="2414160" indent="0" algn="ctr">
               <a:buNone/>
-              <a:defRPr sz="1200"/>
+              <a:defRPr sz="1408"/>
             </a:lvl7pPr>
-            <a:lvl8pPr marL="2400300" indent="0" algn="ctr">
+            <a:lvl8pPr marL="2816519" indent="0" algn="ctr">
               <a:buNone/>
-              <a:defRPr sz="1200"/>
+              <a:defRPr sz="1408"/>
             </a:lvl8pPr>
-            <a:lvl9pPr marL="2743200" indent="0" algn="ctr">
+            <a:lvl9pPr marL="3218879" indent="0" algn="ctr">
               <a:buNone/>
-              <a:defRPr sz="1200"/>
+              <a:defRPr sz="1408"/>
             </a:lvl9pPr>
           </a:lstStyle>
           <a:p>
@@ -244,7 +256,7 @@
           <a:p>
             <a:fld id="{83D14EEA-DE26-4810-8E05-A65F0010FADE}" type="datetimeFigureOut">
               <a:rPr lang="de-DE" smtClean="0"/>
-              <a:t>22.10.2025</a:t>
+              <a:t>23.10.2025</a:t>
             </a:fld>
             <a:endParaRPr lang="de-DE"/>
           </a:p>
@@ -295,7 +307,7 @@
     </p:spTree>
     <p:extLst>
       <p:ext uri="{BB962C8B-B14F-4D97-AF65-F5344CB8AC3E}">
-        <p14:creationId xmlns:p14="http://schemas.microsoft.com/office/powerpoint/2010/main" val="3703697225"/>
+        <p14:creationId xmlns:p14="http://schemas.microsoft.com/office/powerpoint/2010/main" val="35493441"/>
       </p:ext>
     </p:extLst>
   </p:cSld>
@@ -414,7 +426,7 @@
           <a:p>
             <a:fld id="{83D14EEA-DE26-4810-8E05-A65F0010FADE}" type="datetimeFigureOut">
               <a:rPr lang="de-DE" smtClean="0"/>
-              <a:t>22.10.2025</a:t>
+              <a:t>23.10.2025</a:t>
             </a:fld>
             <a:endParaRPr lang="de-DE"/>
           </a:p>
@@ -465,7 +477,7 @@
     </p:spTree>
     <p:extLst>
       <p:ext uri="{BB962C8B-B14F-4D97-AF65-F5344CB8AC3E}">
-        <p14:creationId xmlns:p14="http://schemas.microsoft.com/office/powerpoint/2010/main" val="3316822775"/>
+        <p14:creationId xmlns:p14="http://schemas.microsoft.com/office/powerpoint/2010/main" val="4096226600"/>
       </p:ext>
     </p:extLst>
   </p:cSld>
@@ -504,8 +516,8 @@
         </p:nvSpPr>
         <p:spPr>
           <a:xfrm>
-            <a:off x="4907757" y="649111"/>
-            <a:ext cx="1478756" cy="10332156"/>
+            <a:off x="5758663" y="649111"/>
+            <a:ext cx="1735143" cy="10332156"/>
           </a:xfrm>
         </p:spPr>
         <p:txBody>
@@ -532,8 +544,8 @@
         </p:nvSpPr>
         <p:spPr>
           <a:xfrm>
-            <a:off x="471488" y="649111"/>
-            <a:ext cx="4350544" cy="10332156"/>
+            <a:off x="553234" y="649111"/>
+            <a:ext cx="5104840" cy="10332156"/>
           </a:xfrm>
         </p:spPr>
         <p:txBody>
@@ -594,7 +606,7 @@
           <a:p>
             <a:fld id="{83D14EEA-DE26-4810-8E05-A65F0010FADE}" type="datetimeFigureOut">
               <a:rPr lang="de-DE" smtClean="0"/>
-              <a:t>22.10.2025</a:t>
+              <a:t>23.10.2025</a:t>
             </a:fld>
             <a:endParaRPr lang="de-DE"/>
           </a:p>
@@ -645,7 +657,7 @@
     </p:spTree>
     <p:extLst>
       <p:ext uri="{BB962C8B-B14F-4D97-AF65-F5344CB8AC3E}">
-        <p14:creationId xmlns:p14="http://schemas.microsoft.com/office/powerpoint/2010/main" val="2297925626"/>
+        <p14:creationId xmlns:p14="http://schemas.microsoft.com/office/powerpoint/2010/main" val="4058646796"/>
       </p:ext>
     </p:extLst>
   </p:cSld>
@@ -764,7 +776,7 @@
           <a:p>
             <a:fld id="{83D14EEA-DE26-4810-8E05-A65F0010FADE}" type="datetimeFigureOut">
               <a:rPr lang="de-DE" smtClean="0"/>
-              <a:t>22.10.2025</a:t>
+              <a:t>23.10.2025</a:t>
             </a:fld>
             <a:endParaRPr lang="de-DE"/>
           </a:p>
@@ -815,7 +827,7 @@
     </p:spTree>
     <p:extLst>
       <p:ext uri="{BB962C8B-B14F-4D97-AF65-F5344CB8AC3E}">
-        <p14:creationId xmlns:p14="http://schemas.microsoft.com/office/powerpoint/2010/main" val="785892562"/>
+        <p14:creationId xmlns:p14="http://schemas.microsoft.com/office/powerpoint/2010/main" val="3202912804"/>
       </p:ext>
     </p:extLst>
   </p:cSld>
@@ -854,15 +866,15 @@
         </p:nvSpPr>
         <p:spPr>
           <a:xfrm>
-            <a:off x="467916" y="3039537"/>
-            <a:ext cx="5915025" cy="5071532"/>
+            <a:off x="549043" y="3039537"/>
+            <a:ext cx="6940570" cy="5071532"/>
           </a:xfrm>
         </p:spPr>
         <p:txBody>
           <a:bodyPr anchor="b"/>
           <a:lstStyle>
             <a:lvl1pPr>
-              <a:defRPr sz="4500"/>
+              <a:defRPr sz="5280"/>
             </a:lvl1pPr>
           </a:lstStyle>
           <a:p>
@@ -886,8 +898,8 @@
         </p:nvSpPr>
         <p:spPr>
           <a:xfrm>
-            <a:off x="467916" y="8159048"/>
-            <a:ext cx="5915025" cy="2666999"/>
+            <a:off x="549043" y="8159050"/>
+            <a:ext cx="6940570" cy="2666999"/>
           </a:xfrm>
         </p:spPr>
         <p:txBody>
@@ -895,15 +907,15 @@
           <a:lstStyle>
             <a:lvl1pPr marL="0" indent="0">
               <a:buNone/>
-              <a:defRPr sz="1800">
+              <a:defRPr sz="2112">
                 <a:solidFill>
                   <a:schemeClr val="tx1"/>
                 </a:solidFill>
               </a:defRPr>
             </a:lvl1pPr>
-            <a:lvl2pPr marL="342900" indent="0">
+            <a:lvl2pPr marL="402360" indent="0">
               <a:buNone/>
-              <a:defRPr sz="1500">
+              <a:defRPr sz="1760">
                 <a:solidFill>
                   <a:schemeClr val="tx1">
                     <a:tint val="75000"/>
@@ -911,9 +923,9 @@
                 </a:solidFill>
               </a:defRPr>
             </a:lvl2pPr>
-            <a:lvl3pPr marL="685800" indent="0">
+            <a:lvl3pPr marL="804720" indent="0">
               <a:buNone/>
-              <a:defRPr sz="1350">
+              <a:defRPr sz="1584">
                 <a:solidFill>
                   <a:schemeClr val="tx1">
                     <a:tint val="75000"/>
@@ -921,9 +933,9 @@
                 </a:solidFill>
               </a:defRPr>
             </a:lvl3pPr>
-            <a:lvl4pPr marL="1028700" indent="0">
+            <a:lvl4pPr marL="1207080" indent="0">
               <a:buNone/>
-              <a:defRPr sz="1200">
+              <a:defRPr sz="1408">
                 <a:solidFill>
                   <a:schemeClr val="tx1">
                     <a:tint val="75000"/>
@@ -931,9 +943,9 @@
                 </a:solidFill>
               </a:defRPr>
             </a:lvl4pPr>
-            <a:lvl5pPr marL="1371600" indent="0">
+            <a:lvl5pPr marL="1609440" indent="0">
               <a:buNone/>
-              <a:defRPr sz="1200">
+              <a:defRPr sz="1408">
                 <a:solidFill>
                   <a:schemeClr val="tx1">
                     <a:tint val="75000"/>
@@ -941,9 +953,9 @@
                 </a:solidFill>
               </a:defRPr>
             </a:lvl5pPr>
-            <a:lvl6pPr marL="1714500" indent="0">
+            <a:lvl6pPr marL="2011800" indent="0">
               <a:buNone/>
-              <a:defRPr sz="1200">
+              <a:defRPr sz="1408">
                 <a:solidFill>
                   <a:schemeClr val="tx1">
                     <a:tint val="75000"/>
@@ -951,9 +963,9 @@
                 </a:solidFill>
               </a:defRPr>
             </a:lvl6pPr>
-            <a:lvl7pPr marL="2057400" indent="0">
+            <a:lvl7pPr marL="2414160" indent="0">
               <a:buNone/>
-              <a:defRPr sz="1200">
+              <a:defRPr sz="1408">
                 <a:solidFill>
                   <a:schemeClr val="tx1">
                     <a:tint val="75000"/>
@@ -961,9 +973,9 @@
                 </a:solidFill>
               </a:defRPr>
             </a:lvl7pPr>
-            <a:lvl8pPr marL="2400300" indent="0">
+            <a:lvl8pPr marL="2816519" indent="0">
               <a:buNone/>
-              <a:defRPr sz="1200">
+              <a:defRPr sz="1408">
                 <a:solidFill>
                   <a:schemeClr val="tx1">
                     <a:tint val="75000"/>
@@ -971,9 +983,9 @@
                 </a:solidFill>
               </a:defRPr>
             </a:lvl8pPr>
-            <a:lvl9pPr marL="2743200" indent="0">
+            <a:lvl9pPr marL="3218879" indent="0">
               <a:buNone/>
-              <a:defRPr sz="1200">
+              <a:defRPr sz="1408">
                 <a:solidFill>
                   <a:schemeClr val="tx1">
                     <a:tint val="75000"/>
@@ -1008,7 +1020,7 @@
           <a:p>
             <a:fld id="{83D14EEA-DE26-4810-8E05-A65F0010FADE}" type="datetimeFigureOut">
               <a:rPr lang="de-DE" smtClean="0"/>
-              <a:t>22.10.2025</a:t>
+              <a:t>23.10.2025</a:t>
             </a:fld>
             <a:endParaRPr lang="de-DE"/>
           </a:p>
@@ -1059,7 +1071,7 @@
     </p:spTree>
     <p:extLst>
       <p:ext uri="{BB962C8B-B14F-4D97-AF65-F5344CB8AC3E}">
-        <p14:creationId xmlns:p14="http://schemas.microsoft.com/office/powerpoint/2010/main" val="1017564766"/>
+        <p14:creationId xmlns:p14="http://schemas.microsoft.com/office/powerpoint/2010/main" val="641222210"/>
       </p:ext>
     </p:extLst>
   </p:cSld>
@@ -1121,8 +1133,8 @@
         </p:nvSpPr>
         <p:spPr>
           <a:xfrm>
-            <a:off x="471488" y="3245556"/>
-            <a:ext cx="2914650" cy="7735712"/>
+            <a:off x="553235" y="3245556"/>
+            <a:ext cx="3419991" cy="7735712"/>
           </a:xfrm>
         </p:spPr>
         <p:txBody>
@@ -1178,8 +1190,8 @@
         </p:nvSpPr>
         <p:spPr>
           <a:xfrm>
-            <a:off x="3471863" y="3245556"/>
-            <a:ext cx="2914650" cy="7735712"/>
+            <a:off x="4073814" y="3245556"/>
+            <a:ext cx="3419991" cy="7735712"/>
           </a:xfrm>
         </p:spPr>
         <p:txBody>
@@ -1240,7 +1252,7 @@
           <a:p>
             <a:fld id="{83D14EEA-DE26-4810-8E05-A65F0010FADE}" type="datetimeFigureOut">
               <a:rPr lang="de-DE" smtClean="0"/>
-              <a:t>22.10.2025</a:t>
+              <a:t>23.10.2025</a:t>
             </a:fld>
             <a:endParaRPr lang="de-DE"/>
           </a:p>
@@ -1291,7 +1303,7 @@
     </p:spTree>
     <p:extLst>
       <p:ext uri="{BB962C8B-B14F-4D97-AF65-F5344CB8AC3E}">
-        <p14:creationId xmlns:p14="http://schemas.microsoft.com/office/powerpoint/2010/main" val="96888430"/>
+        <p14:creationId xmlns:p14="http://schemas.microsoft.com/office/powerpoint/2010/main" val="1304642626"/>
       </p:ext>
     </p:extLst>
   </p:cSld>
@@ -1330,8 +1342,8 @@
         </p:nvSpPr>
         <p:spPr>
           <a:xfrm>
-            <a:off x="472381" y="649114"/>
-            <a:ext cx="5915025" cy="2356556"/>
+            <a:off x="554282" y="649114"/>
+            <a:ext cx="6940570" cy="2356556"/>
           </a:xfrm>
         </p:spPr>
         <p:txBody>
@@ -1358,8 +1370,8 @@
         </p:nvSpPr>
         <p:spPr>
           <a:xfrm>
-            <a:off x="472381" y="2988734"/>
-            <a:ext cx="2901255" cy="1464732"/>
+            <a:off x="554283" y="2988734"/>
+            <a:ext cx="3404274" cy="1464732"/>
           </a:xfrm>
         </p:spPr>
         <p:txBody>
@@ -1367,39 +1379,39 @@
           <a:lstStyle>
             <a:lvl1pPr marL="0" indent="0">
               <a:buNone/>
-              <a:defRPr sz="1800" b="1"/>
+              <a:defRPr sz="2112" b="1"/>
             </a:lvl1pPr>
-            <a:lvl2pPr marL="342900" indent="0">
+            <a:lvl2pPr marL="402360" indent="0">
               <a:buNone/>
-              <a:defRPr sz="1500" b="1"/>
+              <a:defRPr sz="1760" b="1"/>
             </a:lvl2pPr>
-            <a:lvl3pPr marL="685800" indent="0">
+            <a:lvl3pPr marL="804720" indent="0">
               <a:buNone/>
-              <a:defRPr sz="1350" b="1"/>
+              <a:defRPr sz="1584" b="1"/>
             </a:lvl3pPr>
-            <a:lvl4pPr marL="1028700" indent="0">
+            <a:lvl4pPr marL="1207080" indent="0">
               <a:buNone/>
-              <a:defRPr sz="1200" b="1"/>
+              <a:defRPr sz="1408" b="1"/>
             </a:lvl4pPr>
-            <a:lvl5pPr marL="1371600" indent="0">
+            <a:lvl5pPr marL="1609440" indent="0">
               <a:buNone/>
-              <a:defRPr sz="1200" b="1"/>
+              <a:defRPr sz="1408" b="1"/>
             </a:lvl5pPr>
-            <a:lvl6pPr marL="1714500" indent="0">
+            <a:lvl6pPr marL="2011800" indent="0">
               <a:buNone/>
-              <a:defRPr sz="1200" b="1"/>
+              <a:defRPr sz="1408" b="1"/>
             </a:lvl6pPr>
-            <a:lvl7pPr marL="2057400" indent="0">
+            <a:lvl7pPr marL="2414160" indent="0">
               <a:buNone/>
-              <a:defRPr sz="1200" b="1"/>
+              <a:defRPr sz="1408" b="1"/>
             </a:lvl7pPr>
-            <a:lvl8pPr marL="2400300" indent="0">
+            <a:lvl8pPr marL="2816519" indent="0">
               <a:buNone/>
-              <a:defRPr sz="1200" b="1"/>
+              <a:defRPr sz="1408" b="1"/>
             </a:lvl8pPr>
-            <a:lvl9pPr marL="2743200" indent="0">
+            <a:lvl9pPr marL="3218879" indent="0">
               <a:buNone/>
-              <a:defRPr sz="1200" b="1"/>
+              <a:defRPr sz="1408" b="1"/>
             </a:lvl9pPr>
           </a:lstStyle>
           <a:p>
@@ -1423,8 +1435,8 @@
         </p:nvSpPr>
         <p:spPr>
           <a:xfrm>
-            <a:off x="472381" y="4453467"/>
-            <a:ext cx="2901255" cy="6550379"/>
+            <a:off x="554283" y="4453469"/>
+            <a:ext cx="3404274" cy="6550379"/>
           </a:xfrm>
         </p:spPr>
         <p:txBody>
@@ -1480,8 +1492,8 @@
         </p:nvSpPr>
         <p:spPr>
           <a:xfrm>
-            <a:off x="3471863" y="2988734"/>
-            <a:ext cx="2915543" cy="1464732"/>
+            <a:off x="4073815" y="2988734"/>
+            <a:ext cx="3421039" cy="1464732"/>
           </a:xfrm>
         </p:spPr>
         <p:txBody>
@@ -1489,39 +1501,39 @@
           <a:lstStyle>
             <a:lvl1pPr marL="0" indent="0">
               <a:buNone/>
-              <a:defRPr sz="1800" b="1"/>
+              <a:defRPr sz="2112" b="1"/>
             </a:lvl1pPr>
-            <a:lvl2pPr marL="342900" indent="0">
+            <a:lvl2pPr marL="402360" indent="0">
               <a:buNone/>
-              <a:defRPr sz="1500" b="1"/>
+              <a:defRPr sz="1760" b="1"/>
             </a:lvl2pPr>
-            <a:lvl3pPr marL="685800" indent="0">
+            <a:lvl3pPr marL="804720" indent="0">
               <a:buNone/>
-              <a:defRPr sz="1350" b="1"/>
+              <a:defRPr sz="1584" b="1"/>
             </a:lvl3pPr>
-            <a:lvl4pPr marL="1028700" indent="0">
+            <a:lvl4pPr marL="1207080" indent="0">
               <a:buNone/>
-              <a:defRPr sz="1200" b="1"/>
+              <a:defRPr sz="1408" b="1"/>
             </a:lvl4pPr>
-            <a:lvl5pPr marL="1371600" indent="0">
+            <a:lvl5pPr marL="1609440" indent="0">
               <a:buNone/>
-              <a:defRPr sz="1200" b="1"/>
+              <a:defRPr sz="1408" b="1"/>
             </a:lvl5pPr>
-            <a:lvl6pPr marL="1714500" indent="0">
+            <a:lvl6pPr marL="2011800" indent="0">
               <a:buNone/>
-              <a:defRPr sz="1200" b="1"/>
+              <a:defRPr sz="1408" b="1"/>
             </a:lvl6pPr>
-            <a:lvl7pPr marL="2057400" indent="0">
+            <a:lvl7pPr marL="2414160" indent="0">
               <a:buNone/>
-              <a:defRPr sz="1200" b="1"/>
+              <a:defRPr sz="1408" b="1"/>
             </a:lvl7pPr>
-            <a:lvl8pPr marL="2400300" indent="0">
+            <a:lvl8pPr marL="2816519" indent="0">
               <a:buNone/>
-              <a:defRPr sz="1200" b="1"/>
+              <a:defRPr sz="1408" b="1"/>
             </a:lvl8pPr>
-            <a:lvl9pPr marL="2743200" indent="0">
+            <a:lvl9pPr marL="3218879" indent="0">
               <a:buNone/>
-              <a:defRPr sz="1200" b="1"/>
+              <a:defRPr sz="1408" b="1"/>
             </a:lvl9pPr>
           </a:lstStyle>
           <a:p>
@@ -1545,8 +1557,8 @@
         </p:nvSpPr>
         <p:spPr>
           <a:xfrm>
-            <a:off x="3471863" y="4453467"/>
-            <a:ext cx="2915543" cy="6550379"/>
+            <a:off x="4073815" y="4453469"/>
+            <a:ext cx="3421039" cy="6550379"/>
           </a:xfrm>
         </p:spPr>
         <p:txBody>
@@ -1607,7 +1619,7 @@
           <a:p>
             <a:fld id="{83D14EEA-DE26-4810-8E05-A65F0010FADE}" type="datetimeFigureOut">
               <a:rPr lang="de-DE" smtClean="0"/>
-              <a:t>22.10.2025</a:t>
+              <a:t>23.10.2025</a:t>
             </a:fld>
             <a:endParaRPr lang="de-DE"/>
           </a:p>
@@ -1658,7 +1670,7 @@
     </p:spTree>
     <p:extLst>
       <p:ext uri="{BB962C8B-B14F-4D97-AF65-F5344CB8AC3E}">
-        <p14:creationId xmlns:p14="http://schemas.microsoft.com/office/powerpoint/2010/main" val="3828072767"/>
+        <p14:creationId xmlns:p14="http://schemas.microsoft.com/office/powerpoint/2010/main" val="4164898104"/>
       </p:ext>
     </p:extLst>
   </p:cSld>
@@ -1725,7 +1737,7 @@
           <a:p>
             <a:fld id="{83D14EEA-DE26-4810-8E05-A65F0010FADE}" type="datetimeFigureOut">
               <a:rPr lang="de-DE" smtClean="0"/>
-              <a:t>22.10.2025</a:t>
+              <a:t>23.10.2025</a:t>
             </a:fld>
             <a:endParaRPr lang="de-DE"/>
           </a:p>
@@ -1776,7 +1788,7 @@
     </p:spTree>
     <p:extLst>
       <p:ext uri="{BB962C8B-B14F-4D97-AF65-F5344CB8AC3E}">
-        <p14:creationId xmlns:p14="http://schemas.microsoft.com/office/powerpoint/2010/main" val="3114181314"/>
+        <p14:creationId xmlns:p14="http://schemas.microsoft.com/office/powerpoint/2010/main" val="3069738833"/>
       </p:ext>
     </p:extLst>
   </p:cSld>
@@ -1820,7 +1832,7 @@
           <a:p>
             <a:fld id="{83D14EEA-DE26-4810-8E05-A65F0010FADE}" type="datetimeFigureOut">
               <a:rPr lang="de-DE" smtClean="0"/>
-              <a:t>22.10.2025</a:t>
+              <a:t>23.10.2025</a:t>
             </a:fld>
             <a:endParaRPr lang="de-DE"/>
           </a:p>
@@ -1871,7 +1883,7 @@
     </p:spTree>
     <p:extLst>
       <p:ext uri="{BB962C8B-B14F-4D97-AF65-F5344CB8AC3E}">
-        <p14:creationId xmlns:p14="http://schemas.microsoft.com/office/powerpoint/2010/main" val="2232556460"/>
+        <p14:creationId xmlns:p14="http://schemas.microsoft.com/office/powerpoint/2010/main" val="1351086057"/>
       </p:ext>
     </p:extLst>
   </p:cSld>
@@ -1910,15 +1922,15 @@
         </p:nvSpPr>
         <p:spPr>
           <a:xfrm>
-            <a:off x="472381" y="812800"/>
-            <a:ext cx="2211884" cy="2844800"/>
+            <a:off x="554283" y="812800"/>
+            <a:ext cx="2595379" cy="2844800"/>
           </a:xfrm>
         </p:spPr>
         <p:txBody>
           <a:bodyPr anchor="b"/>
           <a:lstStyle>
             <a:lvl1pPr>
-              <a:defRPr sz="2400"/>
+              <a:defRPr sz="2816"/>
             </a:lvl1pPr>
           </a:lstStyle>
           <a:p>
@@ -1942,39 +1954,39 @@
         </p:nvSpPr>
         <p:spPr>
           <a:xfrm>
-            <a:off x="2915543" y="1755425"/>
-            <a:ext cx="3471863" cy="8664222"/>
+            <a:off x="3421040" y="1755425"/>
+            <a:ext cx="4073813" cy="8664222"/>
           </a:xfrm>
         </p:spPr>
         <p:txBody>
           <a:bodyPr/>
           <a:lstStyle>
             <a:lvl1pPr>
-              <a:defRPr sz="2400"/>
+              <a:defRPr sz="2816"/>
             </a:lvl1pPr>
             <a:lvl2pPr>
-              <a:defRPr sz="2100"/>
+              <a:defRPr sz="2464"/>
             </a:lvl2pPr>
             <a:lvl3pPr>
-              <a:defRPr sz="1800"/>
+              <a:defRPr sz="2112"/>
             </a:lvl3pPr>
             <a:lvl4pPr>
-              <a:defRPr sz="1500"/>
+              <a:defRPr sz="1760"/>
             </a:lvl4pPr>
             <a:lvl5pPr>
-              <a:defRPr sz="1500"/>
+              <a:defRPr sz="1760"/>
             </a:lvl5pPr>
             <a:lvl6pPr>
-              <a:defRPr sz="1500"/>
+              <a:defRPr sz="1760"/>
             </a:lvl6pPr>
             <a:lvl7pPr>
-              <a:defRPr sz="1500"/>
+              <a:defRPr sz="1760"/>
             </a:lvl7pPr>
             <a:lvl8pPr>
-              <a:defRPr sz="1500"/>
+              <a:defRPr sz="1760"/>
             </a:lvl8pPr>
             <a:lvl9pPr>
-              <a:defRPr sz="1500"/>
+              <a:defRPr sz="1760"/>
             </a:lvl9pPr>
           </a:lstStyle>
           <a:p>
@@ -2027,8 +2039,8 @@
         </p:nvSpPr>
         <p:spPr>
           <a:xfrm>
-            <a:off x="472381" y="3657600"/>
-            <a:ext cx="2211884" cy="6776156"/>
+            <a:off x="554283" y="3657600"/>
+            <a:ext cx="2595379" cy="6776156"/>
           </a:xfrm>
         </p:spPr>
         <p:txBody>
@@ -2036,39 +2048,39 @@
           <a:lstStyle>
             <a:lvl1pPr marL="0" indent="0">
               <a:buNone/>
-              <a:defRPr sz="1200"/>
+              <a:defRPr sz="1408"/>
             </a:lvl1pPr>
-            <a:lvl2pPr marL="342900" indent="0">
+            <a:lvl2pPr marL="402360" indent="0">
               <a:buNone/>
-              <a:defRPr sz="1050"/>
+              <a:defRPr sz="1232"/>
             </a:lvl2pPr>
-            <a:lvl3pPr marL="685800" indent="0">
+            <a:lvl3pPr marL="804720" indent="0">
               <a:buNone/>
-              <a:defRPr sz="900"/>
+              <a:defRPr sz="1056"/>
             </a:lvl3pPr>
-            <a:lvl4pPr marL="1028700" indent="0">
+            <a:lvl4pPr marL="1207080" indent="0">
               <a:buNone/>
-              <a:defRPr sz="750"/>
+              <a:defRPr sz="880"/>
             </a:lvl4pPr>
-            <a:lvl5pPr marL="1371600" indent="0">
+            <a:lvl5pPr marL="1609440" indent="0">
               <a:buNone/>
-              <a:defRPr sz="750"/>
+              <a:defRPr sz="880"/>
             </a:lvl5pPr>
-            <a:lvl6pPr marL="1714500" indent="0">
+            <a:lvl6pPr marL="2011800" indent="0">
               <a:buNone/>
-              <a:defRPr sz="750"/>
+              <a:defRPr sz="880"/>
             </a:lvl6pPr>
-            <a:lvl7pPr marL="2057400" indent="0">
+            <a:lvl7pPr marL="2414160" indent="0">
               <a:buNone/>
-              <a:defRPr sz="750"/>
+              <a:defRPr sz="880"/>
             </a:lvl7pPr>
-            <a:lvl8pPr marL="2400300" indent="0">
+            <a:lvl8pPr marL="2816519" indent="0">
               <a:buNone/>
-              <a:defRPr sz="750"/>
+              <a:defRPr sz="880"/>
             </a:lvl8pPr>
-            <a:lvl9pPr marL="2743200" indent="0">
+            <a:lvl9pPr marL="3218879" indent="0">
               <a:buNone/>
-              <a:defRPr sz="750"/>
+              <a:defRPr sz="880"/>
             </a:lvl9pPr>
           </a:lstStyle>
           <a:p>
@@ -2097,7 +2109,7 @@
           <a:p>
             <a:fld id="{83D14EEA-DE26-4810-8E05-A65F0010FADE}" type="datetimeFigureOut">
               <a:rPr lang="de-DE" smtClean="0"/>
-              <a:t>22.10.2025</a:t>
+              <a:t>23.10.2025</a:t>
             </a:fld>
             <a:endParaRPr lang="de-DE"/>
           </a:p>
@@ -2148,7 +2160,7 @@
     </p:spTree>
     <p:extLst>
       <p:ext uri="{BB962C8B-B14F-4D97-AF65-F5344CB8AC3E}">
-        <p14:creationId xmlns:p14="http://schemas.microsoft.com/office/powerpoint/2010/main" val="3826129784"/>
+        <p14:creationId xmlns:p14="http://schemas.microsoft.com/office/powerpoint/2010/main" val="4218502842"/>
       </p:ext>
     </p:extLst>
   </p:cSld>
@@ -2187,15 +2199,15 @@
         </p:nvSpPr>
         <p:spPr>
           <a:xfrm>
-            <a:off x="472381" y="812800"/>
-            <a:ext cx="2211884" cy="2844800"/>
+            <a:off x="554283" y="812800"/>
+            <a:ext cx="2595379" cy="2844800"/>
           </a:xfrm>
         </p:spPr>
         <p:txBody>
           <a:bodyPr anchor="b"/>
           <a:lstStyle>
             <a:lvl1pPr>
-              <a:defRPr sz="2400"/>
+              <a:defRPr sz="2816"/>
             </a:lvl1pPr>
           </a:lstStyle>
           <a:p>
@@ -2219,8 +2231,8 @@
         </p:nvSpPr>
         <p:spPr>
           <a:xfrm>
-            <a:off x="2915543" y="1755425"/>
-            <a:ext cx="3471863" cy="8664222"/>
+            <a:off x="3421040" y="1755425"/>
+            <a:ext cx="4073813" cy="8664222"/>
           </a:xfrm>
         </p:spPr>
         <p:txBody>
@@ -2228,39 +2240,39 @@
           <a:lstStyle>
             <a:lvl1pPr marL="0" indent="0">
               <a:buNone/>
-              <a:defRPr sz="2400"/>
+              <a:defRPr sz="2816"/>
             </a:lvl1pPr>
-            <a:lvl2pPr marL="342900" indent="0">
+            <a:lvl2pPr marL="402360" indent="0">
               <a:buNone/>
-              <a:defRPr sz="2100"/>
+              <a:defRPr sz="2464"/>
             </a:lvl2pPr>
-            <a:lvl3pPr marL="685800" indent="0">
+            <a:lvl3pPr marL="804720" indent="0">
               <a:buNone/>
-              <a:defRPr sz="1800"/>
+              <a:defRPr sz="2112"/>
             </a:lvl3pPr>
-            <a:lvl4pPr marL="1028700" indent="0">
+            <a:lvl4pPr marL="1207080" indent="0">
               <a:buNone/>
-              <a:defRPr sz="1500"/>
+              <a:defRPr sz="1760"/>
             </a:lvl4pPr>
-            <a:lvl5pPr marL="1371600" indent="0">
+            <a:lvl5pPr marL="1609440" indent="0">
               <a:buNone/>
-              <a:defRPr sz="1500"/>
+              <a:defRPr sz="1760"/>
             </a:lvl5pPr>
-            <a:lvl6pPr marL="1714500" indent="0">
+            <a:lvl6pPr marL="2011800" indent="0">
               <a:buNone/>
-              <a:defRPr sz="1500"/>
+              <a:defRPr sz="1760"/>
             </a:lvl6pPr>
-            <a:lvl7pPr marL="2057400" indent="0">
+            <a:lvl7pPr marL="2414160" indent="0">
               <a:buNone/>
-              <a:defRPr sz="1500"/>
+              <a:defRPr sz="1760"/>
             </a:lvl7pPr>
-            <a:lvl8pPr marL="2400300" indent="0">
+            <a:lvl8pPr marL="2816519" indent="0">
               <a:buNone/>
-              <a:defRPr sz="1500"/>
+              <a:defRPr sz="1760"/>
             </a:lvl8pPr>
-            <a:lvl9pPr marL="2743200" indent="0">
+            <a:lvl9pPr marL="3218879" indent="0">
               <a:buNone/>
-              <a:defRPr sz="1500"/>
+              <a:defRPr sz="1760"/>
             </a:lvl9pPr>
           </a:lstStyle>
           <a:p>
@@ -2284,8 +2296,8 @@
         </p:nvSpPr>
         <p:spPr>
           <a:xfrm>
-            <a:off x="472381" y="3657600"/>
-            <a:ext cx="2211884" cy="6776156"/>
+            <a:off x="554283" y="3657600"/>
+            <a:ext cx="2595379" cy="6776156"/>
           </a:xfrm>
         </p:spPr>
         <p:txBody>
@@ -2293,39 +2305,39 @@
           <a:lstStyle>
             <a:lvl1pPr marL="0" indent="0">
               <a:buNone/>
-              <a:defRPr sz="1200"/>
+              <a:defRPr sz="1408"/>
             </a:lvl1pPr>
-            <a:lvl2pPr marL="342900" indent="0">
+            <a:lvl2pPr marL="402360" indent="0">
               <a:buNone/>
-              <a:defRPr sz="1050"/>
+              <a:defRPr sz="1232"/>
             </a:lvl2pPr>
-            <a:lvl3pPr marL="685800" indent="0">
+            <a:lvl3pPr marL="804720" indent="0">
               <a:buNone/>
-              <a:defRPr sz="900"/>
+              <a:defRPr sz="1056"/>
             </a:lvl3pPr>
-            <a:lvl4pPr marL="1028700" indent="0">
+            <a:lvl4pPr marL="1207080" indent="0">
               <a:buNone/>
-              <a:defRPr sz="750"/>
+              <a:defRPr sz="880"/>
             </a:lvl4pPr>
-            <a:lvl5pPr marL="1371600" indent="0">
+            <a:lvl5pPr marL="1609440" indent="0">
               <a:buNone/>
-              <a:defRPr sz="750"/>
+              <a:defRPr sz="880"/>
             </a:lvl5pPr>
-            <a:lvl6pPr marL="1714500" indent="0">
+            <a:lvl6pPr marL="2011800" indent="0">
               <a:buNone/>
-              <a:defRPr sz="750"/>
+              <a:defRPr sz="880"/>
             </a:lvl6pPr>
-            <a:lvl7pPr marL="2057400" indent="0">
+            <a:lvl7pPr marL="2414160" indent="0">
               <a:buNone/>
-              <a:defRPr sz="750"/>
+              <a:defRPr sz="880"/>
             </a:lvl7pPr>
-            <a:lvl8pPr marL="2400300" indent="0">
+            <a:lvl8pPr marL="2816519" indent="0">
               <a:buNone/>
-              <a:defRPr sz="750"/>
+              <a:defRPr sz="880"/>
             </a:lvl8pPr>
-            <a:lvl9pPr marL="2743200" indent="0">
+            <a:lvl9pPr marL="3218879" indent="0">
               <a:buNone/>
-              <a:defRPr sz="750"/>
+              <a:defRPr sz="880"/>
             </a:lvl9pPr>
           </a:lstStyle>
           <a:p>
@@ -2354,7 +2366,7 @@
           <a:p>
             <a:fld id="{83D14EEA-DE26-4810-8E05-A65F0010FADE}" type="datetimeFigureOut">
               <a:rPr lang="de-DE" smtClean="0"/>
-              <a:t>22.10.2025</a:t>
+              <a:t>23.10.2025</a:t>
             </a:fld>
             <a:endParaRPr lang="de-DE"/>
           </a:p>
@@ -2405,7 +2417,7 @@
     </p:spTree>
     <p:extLst>
       <p:ext uri="{BB962C8B-B14F-4D97-AF65-F5344CB8AC3E}">
-        <p14:creationId xmlns:p14="http://schemas.microsoft.com/office/powerpoint/2010/main" val="1732109770"/>
+        <p14:creationId xmlns:p14="http://schemas.microsoft.com/office/powerpoint/2010/main" val="1584432041"/>
       </p:ext>
     </p:extLst>
   </p:cSld>
@@ -2449,8 +2461,8 @@
         </p:nvSpPr>
         <p:spPr>
           <a:xfrm>
-            <a:off x="471488" y="649114"/>
-            <a:ext cx="5915025" cy="2356556"/>
+            <a:off x="553234" y="649114"/>
+            <a:ext cx="6940570" cy="2356556"/>
           </a:xfrm>
           <a:prstGeom prst="rect">
             <a:avLst/>
@@ -2482,8 +2494,8 @@
         </p:nvSpPr>
         <p:spPr>
           <a:xfrm>
-            <a:off x="471488" y="3245556"/>
-            <a:ext cx="5915025" cy="7735712"/>
+            <a:off x="553234" y="3245556"/>
+            <a:ext cx="6940570" cy="7735712"/>
           </a:xfrm>
           <a:prstGeom prst="rect">
             <a:avLst/>
@@ -2544,8 +2556,8 @@
         </p:nvSpPr>
         <p:spPr>
           <a:xfrm>
-            <a:off x="471488" y="11300181"/>
-            <a:ext cx="1543050" cy="649111"/>
+            <a:off x="553234" y="11300183"/>
+            <a:ext cx="1810584" cy="649111"/>
           </a:xfrm>
           <a:prstGeom prst="rect">
             <a:avLst/>
@@ -2555,7 +2567,7 @@
           <a:bodyPr vert="horz" lIns="91440" tIns="45720" rIns="91440" bIns="45720" rtlCol="0" anchor="ctr"/>
           <a:lstStyle>
             <a:lvl1pPr algn="l">
-              <a:defRPr sz="900">
+              <a:defRPr sz="1056">
                 <a:solidFill>
                   <a:schemeClr val="tx1">
                     <a:tint val="75000"/>
@@ -2567,7 +2579,7 @@
           <a:p>
             <a:fld id="{83D14EEA-DE26-4810-8E05-A65F0010FADE}" type="datetimeFigureOut">
               <a:rPr lang="de-DE" smtClean="0"/>
-              <a:t>22.10.2025</a:t>
+              <a:t>23.10.2025</a:t>
             </a:fld>
             <a:endParaRPr lang="de-DE"/>
           </a:p>
@@ -2585,8 +2597,8 @@
         </p:nvSpPr>
         <p:spPr>
           <a:xfrm>
-            <a:off x="2271713" y="11300181"/>
-            <a:ext cx="2314575" cy="649111"/>
+            <a:off x="2665583" y="11300183"/>
+            <a:ext cx="2715875" cy="649111"/>
           </a:xfrm>
           <a:prstGeom prst="rect">
             <a:avLst/>
@@ -2596,7 +2608,7 @@
           <a:bodyPr vert="horz" lIns="91440" tIns="45720" rIns="91440" bIns="45720" rtlCol="0" anchor="ctr"/>
           <a:lstStyle>
             <a:lvl1pPr algn="ctr">
-              <a:defRPr sz="900">
+              <a:defRPr sz="1056">
                 <a:solidFill>
                   <a:schemeClr val="tx1">
                     <a:tint val="75000"/>
@@ -2622,8 +2634,8 @@
         </p:nvSpPr>
         <p:spPr>
           <a:xfrm>
-            <a:off x="4843463" y="11300181"/>
-            <a:ext cx="1543050" cy="649111"/>
+            <a:off x="5683220" y="11300183"/>
+            <a:ext cx="1810584" cy="649111"/>
           </a:xfrm>
           <a:prstGeom prst="rect">
             <a:avLst/>
@@ -2633,7 +2645,7 @@
           <a:bodyPr vert="horz" lIns="91440" tIns="45720" rIns="91440" bIns="45720" rtlCol="0" anchor="ctr"/>
           <a:lstStyle>
             <a:lvl1pPr algn="r">
-              <a:defRPr sz="900">
+              <a:defRPr sz="1056">
                 <a:solidFill>
                   <a:schemeClr val="tx1">
                     <a:tint val="75000"/>
@@ -2654,27 +2666,27 @@
     </p:spTree>
     <p:extLst>
       <p:ext uri="{BB962C8B-B14F-4D97-AF65-F5344CB8AC3E}">
-        <p14:creationId xmlns:p14="http://schemas.microsoft.com/office/powerpoint/2010/main" val="3339960699"/>
+        <p14:creationId xmlns:p14="http://schemas.microsoft.com/office/powerpoint/2010/main" val="788964536"/>
       </p:ext>
     </p:extLst>
   </p:cSld>
   <p:clrMap bg1="lt1" tx1="dk1" bg2="lt2" tx2="dk2" accent1="accent1" accent2="accent2" accent3="accent3" accent4="accent4" accent5="accent5" accent6="accent6" hlink="hlink" folHlink="folHlink"/>
   <p:sldLayoutIdLst>
-    <p:sldLayoutId id="2147483661" r:id="rId1"/>
-    <p:sldLayoutId id="2147483662" r:id="rId2"/>
-    <p:sldLayoutId id="2147483663" r:id="rId3"/>
-    <p:sldLayoutId id="2147483664" r:id="rId4"/>
-    <p:sldLayoutId id="2147483665" r:id="rId5"/>
-    <p:sldLayoutId id="2147483666" r:id="rId6"/>
-    <p:sldLayoutId id="2147483667" r:id="rId7"/>
-    <p:sldLayoutId id="2147483668" r:id="rId8"/>
-    <p:sldLayoutId id="2147483669" r:id="rId9"/>
-    <p:sldLayoutId id="2147483670" r:id="rId10"/>
-    <p:sldLayoutId id="2147483671" r:id="rId11"/>
+    <p:sldLayoutId id="2147483673" r:id="rId1"/>
+    <p:sldLayoutId id="2147483674" r:id="rId2"/>
+    <p:sldLayoutId id="2147483675" r:id="rId3"/>
+    <p:sldLayoutId id="2147483676" r:id="rId4"/>
+    <p:sldLayoutId id="2147483677" r:id="rId5"/>
+    <p:sldLayoutId id="2147483678" r:id="rId6"/>
+    <p:sldLayoutId id="2147483679" r:id="rId7"/>
+    <p:sldLayoutId id="2147483680" r:id="rId8"/>
+    <p:sldLayoutId id="2147483681" r:id="rId9"/>
+    <p:sldLayoutId id="2147483682" r:id="rId10"/>
+    <p:sldLayoutId id="2147483683" r:id="rId11"/>
   </p:sldLayoutIdLst>
   <p:txStyles>
     <p:titleStyle>
-      <a:lvl1pPr algn="l" defTabSz="685800" rtl="0" eaLnBrk="1" latinLnBrk="0" hangingPunct="1">
+      <a:lvl1pPr algn="l" defTabSz="804720" rtl="0" eaLnBrk="1" latinLnBrk="0" hangingPunct="1">
         <a:lnSpc>
           <a:spcPct val="90000"/>
         </a:lnSpc>
@@ -2682,7 +2694,7 @@
           <a:spcPct val="0"/>
         </a:spcBef>
         <a:buNone/>
-        <a:defRPr sz="3300" kern="1200">
+        <a:defRPr sz="3872" kern="1200">
           <a:solidFill>
             <a:schemeClr val="tx1"/>
           </a:solidFill>
@@ -2693,16 +2705,16 @@
       </a:lvl1pPr>
     </p:titleStyle>
     <p:bodyStyle>
-      <a:lvl1pPr marL="171450" indent="-171450" algn="l" defTabSz="685800" rtl="0" eaLnBrk="1" latinLnBrk="0" hangingPunct="1">
+      <a:lvl1pPr marL="201180" indent="-201180" algn="l" defTabSz="804720" rtl="0" eaLnBrk="1" latinLnBrk="0" hangingPunct="1">
         <a:lnSpc>
           <a:spcPct val="90000"/>
         </a:lnSpc>
         <a:spcBef>
-          <a:spcPts val="750"/>
+          <a:spcPts val="880"/>
         </a:spcBef>
         <a:buFont typeface="Arial" panose="020B0604020202020204" pitchFamily="34" charset="0"/>
         <a:buChar char="•"/>
-        <a:defRPr sz="2100" kern="1200">
+        <a:defRPr sz="2464" kern="1200">
           <a:solidFill>
             <a:schemeClr val="tx1"/>
           </a:solidFill>
@@ -2711,16 +2723,16 @@
           <a:cs typeface="+mn-cs"/>
         </a:defRPr>
       </a:lvl1pPr>
-      <a:lvl2pPr marL="514350" indent="-171450" algn="l" defTabSz="685800" rtl="0" eaLnBrk="1" latinLnBrk="0" hangingPunct="1">
+      <a:lvl2pPr marL="603540" indent="-201180" algn="l" defTabSz="804720" rtl="0" eaLnBrk="1" latinLnBrk="0" hangingPunct="1">
         <a:lnSpc>
           <a:spcPct val="90000"/>
         </a:lnSpc>
         <a:spcBef>
-          <a:spcPts val="375"/>
+          <a:spcPts val="440"/>
         </a:spcBef>
         <a:buFont typeface="Arial" panose="020B0604020202020204" pitchFamily="34" charset="0"/>
         <a:buChar char="•"/>
-        <a:defRPr sz="1800" kern="1200">
+        <a:defRPr sz="2112" kern="1200">
           <a:solidFill>
             <a:schemeClr val="tx1"/>
           </a:solidFill>
@@ -2729,16 +2741,16 @@
           <a:cs typeface="+mn-cs"/>
         </a:defRPr>
       </a:lvl2pPr>
-      <a:lvl3pPr marL="857250" indent="-171450" algn="l" defTabSz="685800" rtl="0" eaLnBrk="1" latinLnBrk="0" hangingPunct="1">
+      <a:lvl3pPr marL="1005900" indent="-201180" algn="l" defTabSz="804720" rtl="0" eaLnBrk="1" latinLnBrk="0" hangingPunct="1">
         <a:lnSpc>
           <a:spcPct val="90000"/>
         </a:lnSpc>
         <a:spcBef>
-          <a:spcPts val="375"/>
+          <a:spcPts val="440"/>
         </a:spcBef>
         <a:buFont typeface="Arial" panose="020B0604020202020204" pitchFamily="34" charset="0"/>
         <a:buChar char="•"/>
-        <a:defRPr sz="1500" kern="1200">
+        <a:defRPr sz="1760" kern="1200">
           <a:solidFill>
             <a:schemeClr val="tx1"/>
           </a:solidFill>
@@ -2747,16 +2759,16 @@
           <a:cs typeface="+mn-cs"/>
         </a:defRPr>
       </a:lvl3pPr>
-      <a:lvl4pPr marL="1200150" indent="-171450" algn="l" defTabSz="685800" rtl="0" eaLnBrk="1" latinLnBrk="0" hangingPunct="1">
+      <a:lvl4pPr marL="1408260" indent="-201180" algn="l" defTabSz="804720" rtl="0" eaLnBrk="1" latinLnBrk="0" hangingPunct="1">
         <a:lnSpc>
           <a:spcPct val="90000"/>
         </a:lnSpc>
         <a:spcBef>
-          <a:spcPts val="375"/>
+          <a:spcPts val="440"/>
         </a:spcBef>
         <a:buFont typeface="Arial" panose="020B0604020202020204" pitchFamily="34" charset="0"/>
         <a:buChar char="•"/>
-        <a:defRPr sz="1350" kern="1200">
+        <a:defRPr sz="1584" kern="1200">
           <a:solidFill>
             <a:schemeClr val="tx1"/>
           </a:solidFill>
@@ -2765,16 +2777,16 @@
           <a:cs typeface="+mn-cs"/>
         </a:defRPr>
       </a:lvl4pPr>
-      <a:lvl5pPr marL="1543050" indent="-171450" algn="l" defTabSz="685800" rtl="0" eaLnBrk="1" latinLnBrk="0" hangingPunct="1">
+      <a:lvl5pPr marL="1810620" indent="-201180" algn="l" defTabSz="804720" rtl="0" eaLnBrk="1" latinLnBrk="0" hangingPunct="1">
         <a:lnSpc>
           <a:spcPct val="90000"/>
         </a:lnSpc>
         <a:spcBef>
-          <a:spcPts val="375"/>
+          <a:spcPts val="440"/>
         </a:spcBef>
         <a:buFont typeface="Arial" panose="020B0604020202020204" pitchFamily="34" charset="0"/>
         <a:buChar char="•"/>
-        <a:defRPr sz="1350" kern="1200">
+        <a:defRPr sz="1584" kern="1200">
           <a:solidFill>
             <a:schemeClr val="tx1"/>
           </a:solidFill>
@@ -2783,16 +2795,16 @@
           <a:cs typeface="+mn-cs"/>
         </a:defRPr>
       </a:lvl5pPr>
-      <a:lvl6pPr marL="1885950" indent="-171450" algn="l" defTabSz="685800" rtl="0" eaLnBrk="1" latinLnBrk="0" hangingPunct="1">
+      <a:lvl6pPr marL="2212980" indent="-201180" algn="l" defTabSz="804720" rtl="0" eaLnBrk="1" latinLnBrk="0" hangingPunct="1">
         <a:lnSpc>
           <a:spcPct val="90000"/>
         </a:lnSpc>
         <a:spcBef>
-          <a:spcPts val="375"/>
+          <a:spcPts val="440"/>
         </a:spcBef>
         <a:buFont typeface="Arial" panose="020B0604020202020204" pitchFamily="34" charset="0"/>
         <a:buChar char="•"/>
-        <a:defRPr sz="1350" kern="1200">
+        <a:defRPr sz="1584" kern="1200">
           <a:solidFill>
             <a:schemeClr val="tx1"/>
           </a:solidFill>
@@ -2801,16 +2813,16 @@
           <a:cs typeface="+mn-cs"/>
         </a:defRPr>
       </a:lvl6pPr>
-      <a:lvl7pPr marL="2228850" indent="-171450" algn="l" defTabSz="685800" rtl="0" eaLnBrk="1" latinLnBrk="0" hangingPunct="1">
+      <a:lvl7pPr marL="2615340" indent="-201180" algn="l" defTabSz="804720" rtl="0" eaLnBrk="1" latinLnBrk="0" hangingPunct="1">
         <a:lnSpc>
           <a:spcPct val="90000"/>
         </a:lnSpc>
         <a:spcBef>
-          <a:spcPts val="375"/>
+          <a:spcPts val="440"/>
         </a:spcBef>
         <a:buFont typeface="Arial" panose="020B0604020202020204" pitchFamily="34" charset="0"/>
         <a:buChar char="•"/>
-        <a:defRPr sz="1350" kern="1200">
+        <a:defRPr sz="1584" kern="1200">
           <a:solidFill>
             <a:schemeClr val="tx1"/>
           </a:solidFill>
@@ -2819,16 +2831,16 @@
           <a:cs typeface="+mn-cs"/>
         </a:defRPr>
       </a:lvl7pPr>
-      <a:lvl8pPr marL="2571750" indent="-171450" algn="l" defTabSz="685800" rtl="0" eaLnBrk="1" latinLnBrk="0" hangingPunct="1">
+      <a:lvl8pPr marL="3017699" indent="-201180" algn="l" defTabSz="804720" rtl="0" eaLnBrk="1" latinLnBrk="0" hangingPunct="1">
         <a:lnSpc>
           <a:spcPct val="90000"/>
         </a:lnSpc>
         <a:spcBef>
-          <a:spcPts val="375"/>
+          <a:spcPts val="440"/>
         </a:spcBef>
         <a:buFont typeface="Arial" panose="020B0604020202020204" pitchFamily="34" charset="0"/>
         <a:buChar char="•"/>
-        <a:defRPr sz="1350" kern="1200">
+        <a:defRPr sz="1584" kern="1200">
           <a:solidFill>
             <a:schemeClr val="tx1"/>
           </a:solidFill>
@@ -2837,16 +2849,16 @@
           <a:cs typeface="+mn-cs"/>
         </a:defRPr>
       </a:lvl8pPr>
-      <a:lvl9pPr marL="2914650" indent="-171450" algn="l" defTabSz="685800" rtl="0" eaLnBrk="1" latinLnBrk="0" hangingPunct="1">
+      <a:lvl9pPr marL="3420059" indent="-201180" algn="l" defTabSz="804720" rtl="0" eaLnBrk="1" latinLnBrk="0" hangingPunct="1">
         <a:lnSpc>
           <a:spcPct val="90000"/>
         </a:lnSpc>
         <a:spcBef>
-          <a:spcPts val="375"/>
+          <a:spcPts val="440"/>
         </a:spcBef>
         <a:buFont typeface="Arial" panose="020B0604020202020204" pitchFamily="34" charset="0"/>
         <a:buChar char="•"/>
-        <a:defRPr sz="1350" kern="1200">
+        <a:defRPr sz="1584" kern="1200">
           <a:solidFill>
             <a:schemeClr val="tx1"/>
           </a:solidFill>
@@ -2860,8 +2872,8 @@
       <a:defPPr>
         <a:defRPr lang="en-US"/>
       </a:defPPr>
-      <a:lvl1pPr marL="0" algn="l" defTabSz="685800" rtl="0" eaLnBrk="1" latinLnBrk="0" hangingPunct="1">
-        <a:defRPr sz="1350" kern="1200">
+      <a:lvl1pPr marL="0" algn="l" defTabSz="804720" rtl="0" eaLnBrk="1" latinLnBrk="0" hangingPunct="1">
+        <a:defRPr sz="1584" kern="1200">
           <a:solidFill>
             <a:schemeClr val="tx1"/>
           </a:solidFill>
@@ -2870,8 +2882,8 @@
           <a:cs typeface="+mn-cs"/>
         </a:defRPr>
       </a:lvl1pPr>
-      <a:lvl2pPr marL="342900" algn="l" defTabSz="685800" rtl="0" eaLnBrk="1" latinLnBrk="0" hangingPunct="1">
-        <a:defRPr sz="1350" kern="1200">
+      <a:lvl2pPr marL="402360" algn="l" defTabSz="804720" rtl="0" eaLnBrk="1" latinLnBrk="0" hangingPunct="1">
+        <a:defRPr sz="1584" kern="1200">
           <a:solidFill>
             <a:schemeClr val="tx1"/>
           </a:solidFill>
@@ -2880,8 +2892,8 @@
           <a:cs typeface="+mn-cs"/>
         </a:defRPr>
       </a:lvl2pPr>
-      <a:lvl3pPr marL="685800" algn="l" defTabSz="685800" rtl="0" eaLnBrk="1" latinLnBrk="0" hangingPunct="1">
-        <a:defRPr sz="1350" kern="1200">
+      <a:lvl3pPr marL="804720" algn="l" defTabSz="804720" rtl="0" eaLnBrk="1" latinLnBrk="0" hangingPunct="1">
+        <a:defRPr sz="1584" kern="1200">
           <a:solidFill>
             <a:schemeClr val="tx1"/>
           </a:solidFill>
@@ -2890,8 +2902,8 @@
           <a:cs typeface="+mn-cs"/>
         </a:defRPr>
       </a:lvl3pPr>
-      <a:lvl4pPr marL="1028700" algn="l" defTabSz="685800" rtl="0" eaLnBrk="1" latinLnBrk="0" hangingPunct="1">
-        <a:defRPr sz="1350" kern="1200">
+      <a:lvl4pPr marL="1207080" algn="l" defTabSz="804720" rtl="0" eaLnBrk="1" latinLnBrk="0" hangingPunct="1">
+        <a:defRPr sz="1584" kern="1200">
           <a:solidFill>
             <a:schemeClr val="tx1"/>
           </a:solidFill>
@@ -2900,8 +2912,8 @@
           <a:cs typeface="+mn-cs"/>
         </a:defRPr>
       </a:lvl4pPr>
-      <a:lvl5pPr marL="1371600" algn="l" defTabSz="685800" rtl="0" eaLnBrk="1" latinLnBrk="0" hangingPunct="1">
-        <a:defRPr sz="1350" kern="1200">
+      <a:lvl5pPr marL="1609440" algn="l" defTabSz="804720" rtl="0" eaLnBrk="1" latinLnBrk="0" hangingPunct="1">
+        <a:defRPr sz="1584" kern="1200">
           <a:solidFill>
             <a:schemeClr val="tx1"/>
           </a:solidFill>
@@ -2910,8 +2922,8 @@
           <a:cs typeface="+mn-cs"/>
         </a:defRPr>
       </a:lvl5pPr>
-      <a:lvl6pPr marL="1714500" algn="l" defTabSz="685800" rtl="0" eaLnBrk="1" latinLnBrk="0" hangingPunct="1">
-        <a:defRPr sz="1350" kern="1200">
+      <a:lvl6pPr marL="2011800" algn="l" defTabSz="804720" rtl="0" eaLnBrk="1" latinLnBrk="0" hangingPunct="1">
+        <a:defRPr sz="1584" kern="1200">
           <a:solidFill>
             <a:schemeClr val="tx1"/>
           </a:solidFill>
@@ -2920,8 +2932,8 @@
           <a:cs typeface="+mn-cs"/>
         </a:defRPr>
       </a:lvl6pPr>
-      <a:lvl7pPr marL="2057400" algn="l" defTabSz="685800" rtl="0" eaLnBrk="1" latinLnBrk="0" hangingPunct="1">
-        <a:defRPr sz="1350" kern="1200">
+      <a:lvl7pPr marL="2414160" algn="l" defTabSz="804720" rtl="0" eaLnBrk="1" latinLnBrk="0" hangingPunct="1">
+        <a:defRPr sz="1584" kern="1200">
           <a:solidFill>
             <a:schemeClr val="tx1"/>
           </a:solidFill>
@@ -2930,8 +2942,8 @@
           <a:cs typeface="+mn-cs"/>
         </a:defRPr>
       </a:lvl7pPr>
-      <a:lvl8pPr marL="2400300" algn="l" defTabSz="685800" rtl="0" eaLnBrk="1" latinLnBrk="0" hangingPunct="1">
-        <a:defRPr sz="1350" kern="1200">
+      <a:lvl8pPr marL="2816519" algn="l" defTabSz="804720" rtl="0" eaLnBrk="1" latinLnBrk="0" hangingPunct="1">
+        <a:defRPr sz="1584" kern="1200">
           <a:solidFill>
             <a:schemeClr val="tx1"/>
           </a:solidFill>
@@ -2940,8 +2952,8 @@
           <a:cs typeface="+mn-cs"/>
         </a:defRPr>
       </a:lvl8pPr>
-      <a:lvl9pPr marL="2743200" algn="l" defTabSz="685800" rtl="0" eaLnBrk="1" latinLnBrk="0" hangingPunct="1">
-        <a:defRPr sz="1350" kern="1200">
+      <a:lvl9pPr marL="3218879" algn="l" defTabSz="804720" rtl="0" eaLnBrk="1" latinLnBrk="0" hangingPunct="1">
+        <a:defRPr sz="1584" kern="1200">
           <a:solidFill>
             <a:schemeClr val="tx1"/>
           </a:solidFill>
@@ -2986,8 +2998,8 @@
         </p:nvSpPr>
         <p:spPr>
           <a:xfrm>
-            <a:off x="3464482" y="3739545"/>
-            <a:ext cx="847452" cy="351647"/>
+            <a:off x="4065153" y="4009166"/>
+            <a:ext cx="994383" cy="412615"/>
           </a:xfrm>
           <a:prstGeom prst="roundRect">
             <a:avLst/>
@@ -3045,7 +3057,7 @@
           <a:p>
             <a:pPr algn="ctr"/>
             <a:r>
-              <a:rPr lang="en-US" sz="1200" dirty="0">
+              <a:rPr lang="en-US" sz="1408" dirty="0">
                 <a:solidFill>
                   <a:schemeClr val="tx1"/>
                 </a:solidFill>
@@ -3054,7 +3066,7 @@
               </a:rPr>
               <a:t>2385</a:t>
             </a:r>
-            <a:endParaRPr lang="de-DE" sz="1200" dirty="0">
+            <a:endParaRPr lang="de-DE" sz="1408" dirty="0">
               <a:solidFill>
                 <a:schemeClr val="tx1"/>
               </a:solidFill>
@@ -3078,8 +3090,8 @@
         </p:nvSpPr>
         <p:spPr>
           <a:xfrm>
-            <a:off x="3464482" y="4659776"/>
-            <a:ext cx="847452" cy="351647"/>
+            <a:off x="4065153" y="5088945"/>
+            <a:ext cx="994383" cy="412615"/>
           </a:xfrm>
           <a:prstGeom prst="roundRect">
             <a:avLst/>
@@ -3137,7 +3149,7 @@
           <a:p>
             <a:pPr algn="ctr"/>
             <a:r>
-              <a:rPr lang="en-US" sz="1200" dirty="0">
+              <a:rPr lang="en-US" sz="1408" dirty="0">
                 <a:solidFill>
                   <a:schemeClr val="tx1"/>
                 </a:solidFill>
@@ -3146,7 +3158,7 @@
               </a:rPr>
               <a:t>118</a:t>
             </a:r>
-            <a:endParaRPr lang="de-DE" sz="1200" dirty="0">
+            <a:endParaRPr lang="de-DE" sz="1408" dirty="0">
               <a:solidFill>
                 <a:schemeClr val="tx1"/>
               </a:solidFill>
@@ -3170,8 +3182,8 @@
         </p:nvSpPr>
         <p:spPr>
           <a:xfrm>
-            <a:off x="3464499" y="6216280"/>
-            <a:ext cx="847452" cy="351647"/>
+            <a:off x="4065173" y="7103997"/>
+            <a:ext cx="994383" cy="412615"/>
           </a:xfrm>
           <a:prstGeom prst="roundRect">
             <a:avLst/>
@@ -3229,7 +3241,7 @@
           <a:p>
             <a:pPr algn="ctr"/>
             <a:r>
-              <a:rPr lang="en-US" sz="1200" dirty="0">
+              <a:rPr lang="en-US" sz="1408" dirty="0">
                 <a:solidFill>
                   <a:schemeClr val="tx1"/>
                 </a:solidFill>
@@ -3238,7 +3250,7 @@
               </a:rPr>
               <a:t>1032</a:t>
             </a:r>
-            <a:endParaRPr lang="de-DE" sz="1200" dirty="0">
+            <a:endParaRPr lang="de-DE" sz="1408" dirty="0">
               <a:solidFill>
                 <a:schemeClr val="tx1"/>
               </a:solidFill>
@@ -3266,8 +3278,8 @@
         </p:nvCxnSpPr>
         <p:spPr>
           <a:xfrm>
-            <a:off x="3888208" y="4091192"/>
-            <a:ext cx="0" cy="568585"/>
+            <a:off x="4562344" y="4421780"/>
+            <a:ext cx="0" cy="667166"/>
           </a:xfrm>
           <a:prstGeom prst="straightConnector1">
             <a:avLst/>
@@ -3314,8 +3326,8 @@
         </p:nvCxnSpPr>
         <p:spPr>
           <a:xfrm>
-            <a:off x="3888208" y="5011423"/>
-            <a:ext cx="17" cy="1204857"/>
+            <a:off x="4562345" y="5501561"/>
+            <a:ext cx="20" cy="1602437"/>
           </a:xfrm>
           <a:prstGeom prst="straightConnector1">
             <a:avLst/>
@@ -3358,8 +3370,8 @@
         </p:nvSpPr>
         <p:spPr>
           <a:xfrm>
-            <a:off x="4308118" y="3776868"/>
-            <a:ext cx="2486654" cy="261610"/>
+            <a:off x="5040651" y="3976290"/>
+            <a:ext cx="1841042" cy="489621"/>
           </a:xfrm>
           <a:prstGeom prst="rect">
             <a:avLst/>
@@ -3372,13 +3384,22 @@
           <a:lstStyle/>
           <a:p>
             <a:r>
-              <a:rPr lang="en-US" sz="1100" dirty="0">
+              <a:rPr lang="en-US" sz="1291" dirty="0">
                 <a:latin typeface="Arial" panose="020B0604020202020204" pitchFamily="34" charset="0"/>
                 <a:cs typeface="Arial" panose="020B0604020202020204" pitchFamily="34" charset="0"/>
               </a:rPr>
-              <a:t>Restricted / Full-Access Datasets</a:t>
-            </a:r>
-            <a:endParaRPr lang="de-DE" sz="1100" dirty="0">
+              <a:t>Restricted-Access</a:t>
+            </a:r>
+          </a:p>
+          <a:p>
+            <a:r>
+              <a:rPr lang="en-US" sz="1291" dirty="0">
+                <a:latin typeface="Arial" panose="020B0604020202020204" pitchFamily="34" charset="0"/>
+                <a:cs typeface="Arial" panose="020B0604020202020204" pitchFamily="34" charset="0"/>
+              </a:rPr>
+              <a:t>and Open Datasets</a:t>
+            </a:r>
+            <a:endParaRPr lang="de-DE" sz="1291" dirty="0">
               <a:latin typeface="Arial" panose="020B0604020202020204" pitchFamily="34" charset="0"/>
               <a:cs typeface="Arial" panose="020B0604020202020204" pitchFamily="34" charset="0"/>
             </a:endParaRPr>
@@ -3399,8 +3420,8 @@
         </p:nvSpPr>
         <p:spPr>
           <a:xfrm>
-            <a:off x="4271005" y="4634156"/>
-            <a:ext cx="2126949" cy="430887"/>
+            <a:off x="5063715" y="5042446"/>
+            <a:ext cx="994363" cy="489621"/>
           </a:xfrm>
           <a:prstGeom prst="rect">
             <a:avLst/>
@@ -3413,20 +3434,20 @@
           <a:lstStyle/>
           <a:p>
             <a:r>
-              <a:rPr lang="en-US" sz="1100" dirty="0">
+              <a:rPr lang="en-US" sz="1291" dirty="0">
                 <a:latin typeface="Arial" panose="020B0604020202020204" pitchFamily="34" charset="0"/>
                 <a:cs typeface="Arial" panose="020B0604020202020204" pitchFamily="34" charset="0"/>
               </a:rPr>
-              <a:t>Mentioned Datasets</a:t>
-            </a:r>
-          </a:p>
-          <a:p>
-            <a:r>
-              <a:rPr lang="en-US" sz="1100" dirty="0">
+              <a:t>Mentioned</a:t>
+            </a:r>
+          </a:p>
+          <a:p>
+            <a:r>
+              <a:rPr lang="en-US" sz="1291" dirty="0">
                 <a:latin typeface="Arial" panose="020B0604020202020204" pitchFamily="34" charset="0"/>
                 <a:cs typeface="Arial" panose="020B0604020202020204" pitchFamily="34" charset="0"/>
               </a:rPr>
-              <a:t>(Manually Screened)</a:t>
+              <a:t>Datasets</a:t>
             </a:r>
           </a:p>
         </p:txBody>
@@ -3445,8 +3466,8 @@
         </p:nvSpPr>
         <p:spPr>
           <a:xfrm>
-            <a:off x="4303434" y="6176659"/>
-            <a:ext cx="2126948" cy="430887"/>
+            <a:off x="5063715" y="7051395"/>
+            <a:ext cx="1105044" cy="489621"/>
           </a:xfrm>
           <a:prstGeom prst="rect">
             <a:avLst/>
@@ -3459,20 +3480,20 @@
           <a:lstStyle/>
           <a:p>
             <a:r>
-              <a:rPr lang="en-US" sz="1100" dirty="0">
+              <a:rPr lang="en-US" sz="1291" dirty="0">
                 <a:latin typeface="Arial" panose="020B0604020202020204" pitchFamily="34" charset="0"/>
                 <a:cs typeface="Arial" panose="020B0604020202020204" pitchFamily="34" charset="0"/>
               </a:rPr>
-              <a:t>Mentions of Datasets</a:t>
-            </a:r>
-          </a:p>
-          <a:p>
-            <a:r>
-              <a:rPr lang="en-US" sz="1100" dirty="0">
+              <a:t>Mentions</a:t>
+            </a:r>
+          </a:p>
+          <a:p>
+            <a:r>
+              <a:rPr lang="en-US" sz="1291" dirty="0">
                 <a:latin typeface="Arial" panose="020B0604020202020204" pitchFamily="34" charset="0"/>
                 <a:cs typeface="Arial" panose="020B0604020202020204" pitchFamily="34" charset="0"/>
               </a:rPr>
-              <a:t>(Manually Screened)</a:t>
+              <a:t>of Datasets</a:t>
             </a:r>
           </a:p>
         </p:txBody>
@@ -3491,8 +3512,8 @@
         </p:nvSpPr>
         <p:spPr>
           <a:xfrm>
-            <a:off x="1781846" y="4659776"/>
-            <a:ext cx="815263" cy="351647"/>
+            <a:off x="1793604" y="5088945"/>
+            <a:ext cx="956613" cy="412615"/>
           </a:xfrm>
           <a:prstGeom prst="roundRect">
             <a:avLst/>
@@ -3553,7 +3574,7 @@
           <a:p>
             <a:pPr algn="ctr"/>
             <a:r>
-              <a:rPr lang="en-US" sz="1200" dirty="0">
+              <a:rPr lang="en-US" sz="1408" dirty="0">
                 <a:solidFill>
                   <a:schemeClr val="tx1"/>
                 </a:solidFill>
@@ -3562,7 +3583,7 @@
               </a:rPr>
               <a:t>119</a:t>
             </a:r>
-            <a:endParaRPr lang="de-DE" sz="1200" dirty="0">
+            <a:endParaRPr lang="de-DE" sz="1408" dirty="0">
               <a:solidFill>
                 <a:schemeClr val="tx1"/>
               </a:solidFill>
@@ -3586,8 +3607,8 @@
         </p:nvSpPr>
         <p:spPr>
           <a:xfrm>
-            <a:off x="1781863" y="6216280"/>
-            <a:ext cx="821637" cy="351647"/>
+            <a:off x="1793623" y="7103997"/>
+            <a:ext cx="964092" cy="412615"/>
           </a:xfrm>
           <a:prstGeom prst="roundRect">
             <a:avLst/>
@@ -3648,7 +3669,7 @@
           <a:p>
             <a:pPr algn="ctr"/>
             <a:r>
-              <a:rPr lang="en-US" sz="1200" dirty="0">
+              <a:rPr lang="en-US" sz="1408" dirty="0">
                 <a:solidFill>
                   <a:schemeClr val="tx1"/>
                 </a:solidFill>
@@ -3657,7 +3678,7 @@
               </a:rPr>
               <a:t>790</a:t>
             </a:r>
-            <a:endParaRPr lang="de-DE" sz="1200" dirty="0">
+            <a:endParaRPr lang="de-DE" sz="1408" dirty="0">
               <a:solidFill>
                 <a:schemeClr val="tx1"/>
               </a:solidFill>
@@ -3681,8 +3702,8 @@
         </p:nvSpPr>
         <p:spPr>
           <a:xfrm>
-            <a:off x="2623173" y="7096680"/>
-            <a:ext cx="815263" cy="351647"/>
+            <a:off x="2933200" y="8137041"/>
+            <a:ext cx="956613" cy="412615"/>
           </a:xfrm>
           <a:prstGeom prst="roundRect">
             <a:avLst/>
@@ -3735,7 +3756,7 @@
           <a:p>
             <a:pPr algn="ctr"/>
             <a:r>
-              <a:rPr lang="en-US" sz="1200" dirty="0">
+              <a:rPr lang="en-US" sz="1408" dirty="0">
                 <a:solidFill>
                   <a:schemeClr val="tx1"/>
                 </a:solidFill>
@@ -3744,7 +3765,7 @@
               </a:rPr>
               <a:t>1497</a:t>
             </a:r>
-            <a:endParaRPr lang="de-DE" sz="1200" dirty="0">
+            <a:endParaRPr lang="de-DE" sz="1408" dirty="0">
               <a:solidFill>
                 <a:schemeClr val="tx1"/>
               </a:solidFill>
@@ -3765,15 +3786,14 @@
           </p:cNvPr>
           <p:cNvCxnSpPr>
             <a:cxnSpLocks/>
-            <a:stCxn id="37" idx="2"/>
             <a:endCxn id="38" idx="0"/>
           </p:cNvCxnSpPr>
           <p:nvPr/>
         </p:nvCxnSpPr>
         <p:spPr>
           <a:xfrm>
-            <a:off x="2189478" y="5011423"/>
-            <a:ext cx="3204" cy="1204857"/>
+            <a:off x="2271909" y="5501561"/>
+            <a:ext cx="3760" cy="1602437"/>
           </a:xfrm>
           <a:prstGeom prst="straightConnector1">
             <a:avLst/>
@@ -3820,8 +3840,8 @@
         </p:nvCxnSpPr>
         <p:spPr>
           <a:xfrm>
-            <a:off x="2192682" y="6567927"/>
-            <a:ext cx="838123" cy="528753"/>
+            <a:off x="2275670" y="7516612"/>
+            <a:ext cx="1135837" cy="620428"/>
           </a:xfrm>
           <a:prstGeom prst="straightConnector1">
             <a:avLst/>
@@ -3864,8 +3884,8 @@
         </p:nvSpPr>
         <p:spPr>
           <a:xfrm>
-            <a:off x="229128" y="4620156"/>
-            <a:ext cx="1526663" cy="430887"/>
+            <a:off x="683797" y="5042446"/>
+            <a:ext cx="1066474" cy="489621"/>
           </a:xfrm>
           <a:prstGeom prst="rect">
             <a:avLst/>
@@ -3879,26 +3899,22 @@
           <a:p>
             <a:pPr algn="r"/>
             <a:r>
-              <a:rPr lang="en-US" sz="1100" dirty="0">
+              <a:rPr lang="en-US" sz="1291" dirty="0">
                 <a:latin typeface="Arial" panose="020B0604020202020204" pitchFamily="34" charset="0"/>
                 <a:cs typeface="Arial" panose="020B0604020202020204" pitchFamily="34" charset="0"/>
               </a:rPr>
-              <a:t>Mentioned Datasets</a:t>
+              <a:t>Mentioned</a:t>
             </a:r>
           </a:p>
           <a:p>
             <a:pPr algn="r"/>
             <a:r>
-              <a:rPr lang="en-US" sz="1100" dirty="0">
+              <a:rPr lang="en-US" sz="1291" dirty="0">
                 <a:latin typeface="Arial" panose="020B0604020202020204" pitchFamily="34" charset="0"/>
                 <a:cs typeface="Arial" panose="020B0604020202020204" pitchFamily="34" charset="0"/>
               </a:rPr>
-              <a:t>(DataStet)</a:t>
-            </a:r>
-            <a:endParaRPr lang="de-DE" sz="1100" dirty="0">
-              <a:latin typeface="Arial" panose="020B0604020202020204" pitchFamily="34" charset="0"/>
-              <a:cs typeface="Arial" panose="020B0604020202020204" pitchFamily="34" charset="0"/>
-            </a:endParaRPr>
+              <a:t>Datasets</a:t>
+            </a:r>
           </a:p>
         </p:txBody>
       </p:sp>
@@ -3916,8 +3932,8 @@
         </p:nvSpPr>
         <p:spPr>
           <a:xfrm>
-            <a:off x="229128" y="6168964"/>
-            <a:ext cx="1526663" cy="430887"/>
+            <a:off x="685201" y="7051393"/>
+            <a:ext cx="1066474" cy="489621"/>
           </a:xfrm>
           <a:prstGeom prst="rect">
             <a:avLst/>
@@ -3931,23 +3947,23 @@
           <a:p>
             <a:pPr algn="r"/>
             <a:r>
-              <a:rPr lang="en-US" sz="1100" dirty="0">
+              <a:rPr lang="en-US" sz="1291" dirty="0">
                 <a:latin typeface="Arial" panose="020B0604020202020204" pitchFamily="34" charset="0"/>
                 <a:cs typeface="Arial" panose="020B0604020202020204" pitchFamily="34" charset="0"/>
               </a:rPr>
-              <a:t>Mentions of Datasets</a:t>
+              <a:t>Mentions</a:t>
             </a:r>
           </a:p>
           <a:p>
             <a:pPr algn="r"/>
             <a:r>
-              <a:rPr lang="en-US" sz="1100" dirty="0">
+              <a:rPr lang="en-US" sz="1291" dirty="0">
                 <a:latin typeface="Arial" panose="020B0604020202020204" pitchFamily="34" charset="0"/>
                 <a:cs typeface="Arial" panose="020B0604020202020204" pitchFamily="34" charset="0"/>
               </a:rPr>
-              <a:t>(DataStet)</a:t>
-            </a:r>
-            <a:endParaRPr lang="de-DE" sz="1100" dirty="0">
+              <a:t>of Datasets</a:t>
+            </a:r>
+            <a:endParaRPr lang="de-DE" sz="1291" dirty="0">
               <a:latin typeface="Arial" panose="020B0604020202020204" pitchFamily="34" charset="0"/>
               <a:cs typeface="Arial" panose="020B0604020202020204" pitchFamily="34" charset="0"/>
             </a:endParaRPr>
@@ -3972,8 +3988,8 @@
         </p:nvCxnSpPr>
         <p:spPr>
           <a:xfrm flipH="1">
-            <a:off x="3030805" y="6567927"/>
-            <a:ext cx="857420" cy="528753"/>
+            <a:off x="3411507" y="7516612"/>
+            <a:ext cx="1150859" cy="620428"/>
           </a:xfrm>
           <a:prstGeom prst="straightConnector1">
             <a:avLst/>
@@ -4016,8 +4032,8 @@
         </p:nvSpPr>
         <p:spPr>
           <a:xfrm>
-            <a:off x="1927797" y="7483280"/>
-            <a:ext cx="2245616" cy="822726"/>
+            <a:off x="2117258" y="8590668"/>
+            <a:ext cx="2634960" cy="949491"/>
           </a:xfrm>
           <a:prstGeom prst="rect">
             <a:avLst/>
@@ -4035,7 +4051,7 @@
               </a:lnSpc>
             </a:pPr>
             <a:r>
-              <a:rPr lang="en-US" sz="1100" dirty="0">
+              <a:rPr lang="en-US" sz="1291" dirty="0">
                 <a:latin typeface="Arial" panose="020B0604020202020204" pitchFamily="34" charset="0"/>
                 <a:cs typeface="Arial" panose="020B0604020202020204" pitchFamily="34" charset="0"/>
               </a:rPr>
@@ -4049,7 +4065,7 @@
               </a:lnSpc>
             </a:pPr>
             <a:r>
-              <a:rPr lang="en-US" sz="1100" dirty="0">
+              <a:rPr lang="en-US" sz="1291" dirty="0">
                 <a:solidFill>
                   <a:schemeClr val="bg1">
                     <a:lumMod val="50000"/>
@@ -4060,7 +4076,7 @@
               </a:rPr>
               <a:t>Published in 134 Charité Papers</a:t>
             </a:r>
-            <a:endParaRPr lang="de-DE" sz="1100" dirty="0">
+            <a:endParaRPr lang="de-DE" sz="1291" dirty="0">
               <a:solidFill>
                 <a:schemeClr val="bg1">
                   <a:lumMod val="50000"/>
@@ -4077,7 +4093,7 @@
               </a:lnSpc>
             </a:pPr>
             <a:r>
-              <a:rPr lang="de-DE" sz="1100" dirty="0">
+              <a:rPr lang="de-DE" sz="1291" dirty="0">
                 <a:solidFill>
                   <a:schemeClr val="bg1">
                     <a:lumMod val="50000"/>
@@ -4109,8 +4125,8 @@
         </p:nvCxnSpPr>
         <p:spPr>
           <a:xfrm>
-            <a:off x="3884392" y="3108620"/>
-            <a:ext cx="3816" cy="630925"/>
+            <a:off x="4557867" y="3268850"/>
+            <a:ext cx="4478" cy="740315"/>
           </a:xfrm>
           <a:prstGeom prst="straightConnector1">
             <a:avLst/>
@@ -4153,8 +4169,8 @@
         </p:nvSpPr>
         <p:spPr>
           <a:xfrm>
-            <a:off x="2649219" y="5459906"/>
-            <a:ext cx="815263" cy="351647"/>
+            <a:off x="2963761" y="6027801"/>
+            <a:ext cx="956613" cy="412615"/>
           </a:xfrm>
           <a:prstGeom prst="roundRect">
             <a:avLst/>
@@ -4207,7 +4223,7 @@
           <a:p>
             <a:pPr algn="ctr"/>
             <a:r>
-              <a:rPr lang="en-US" sz="1200" dirty="0">
+              <a:rPr lang="en-US" sz="1408" dirty="0">
                 <a:solidFill>
                   <a:schemeClr val="tx1"/>
                 </a:solidFill>
@@ -4216,7 +4232,7 @@
               </a:rPr>
               <a:t>175</a:t>
             </a:r>
-            <a:endParaRPr lang="de-DE" sz="1200" dirty="0">
+            <a:endParaRPr lang="de-DE" sz="1408" dirty="0">
               <a:solidFill>
                 <a:schemeClr val="tx1"/>
               </a:solidFill>
@@ -4243,8 +4259,8 @@
         </p:nvCxnSpPr>
         <p:spPr>
           <a:xfrm>
-            <a:off x="2189495" y="5023080"/>
-            <a:ext cx="867356" cy="436826"/>
+            <a:off x="2424329" y="5515238"/>
+            <a:ext cx="1017738" cy="512563"/>
           </a:xfrm>
           <a:prstGeom prst="straightConnector1">
             <a:avLst/>
@@ -4290,8 +4306,8 @@
         </p:nvCxnSpPr>
         <p:spPr>
           <a:xfrm flipH="1">
-            <a:off x="3056851" y="5023080"/>
-            <a:ext cx="831374" cy="436826"/>
+            <a:off x="3442068" y="5515238"/>
+            <a:ext cx="975517" cy="512563"/>
           </a:xfrm>
           <a:prstGeom prst="straightConnector1">
             <a:avLst/>
@@ -4334,8 +4350,8 @@
         </p:nvSpPr>
         <p:spPr>
           <a:xfrm>
-            <a:off x="2199631" y="5840218"/>
-            <a:ext cx="1675112" cy="261610"/>
+            <a:off x="2436223" y="6474051"/>
+            <a:ext cx="1965542" cy="290977"/>
           </a:xfrm>
           <a:prstGeom prst="rect">
             <a:avLst/>
@@ -4349,13 +4365,13 @@
           <a:p>
             <a:pPr algn="ctr"/>
             <a:r>
-              <a:rPr lang="en-US" sz="1100" dirty="0">
+              <a:rPr lang="en-US" sz="1291" dirty="0">
                 <a:latin typeface="Arial" panose="020B0604020202020204" pitchFamily="34" charset="0"/>
                 <a:cs typeface="Arial" panose="020B0604020202020204" pitchFamily="34" charset="0"/>
               </a:rPr>
               <a:t>Detected Datasets</a:t>
             </a:r>
-            <a:endParaRPr lang="de-DE" sz="1100" dirty="0">
+            <a:endParaRPr lang="de-DE" sz="1291" dirty="0">
               <a:latin typeface="Arial" panose="020B0604020202020204" pitchFamily="34" charset="0"/>
               <a:cs typeface="Arial" panose="020B0604020202020204" pitchFamily="34" charset="0"/>
             </a:endParaRPr>
@@ -4376,8 +4392,8 @@
         </p:nvSpPr>
         <p:spPr>
           <a:xfrm>
-            <a:off x="3460666" y="2756973"/>
-            <a:ext cx="847452" cy="351647"/>
+            <a:off x="4060675" y="2856235"/>
+            <a:ext cx="994383" cy="412615"/>
           </a:xfrm>
           <a:prstGeom prst="roundRect">
             <a:avLst/>
@@ -4435,7 +4451,7 @@
           <a:p>
             <a:pPr algn="ctr"/>
             <a:r>
-              <a:rPr lang="en-US" sz="1200" dirty="0">
+              <a:rPr lang="en-US" sz="1408" dirty="0">
                 <a:solidFill>
                   <a:schemeClr val="tx1"/>
                 </a:solidFill>
@@ -4444,7 +4460,7 @@
               </a:rPr>
               <a:t>1583</a:t>
             </a:r>
-            <a:endParaRPr lang="de-DE" sz="1200" dirty="0">
+            <a:endParaRPr lang="de-DE" sz="1408" dirty="0">
               <a:solidFill>
                 <a:schemeClr val="tx1"/>
               </a:solidFill>
@@ -4468,8 +4484,8 @@
         </p:nvSpPr>
         <p:spPr>
           <a:xfrm>
-            <a:off x="4308118" y="2739829"/>
-            <a:ext cx="1665950" cy="430887"/>
+            <a:off x="5055058" y="2836118"/>
+            <a:ext cx="1954792" cy="489621"/>
           </a:xfrm>
           <a:prstGeom prst="rect">
             <a:avLst/>
@@ -4482,13 +4498,13 @@
           <a:lstStyle/>
           <a:p>
             <a:r>
-              <a:rPr lang="en-US" sz="1100" dirty="0">
+              <a:rPr lang="en-US" sz="1291" dirty="0">
                 <a:latin typeface="Arial" panose="020B0604020202020204" pitchFamily="34" charset="0"/>
                 <a:cs typeface="Arial" panose="020B0604020202020204" pitchFamily="34" charset="0"/>
               </a:rPr>
               <a:t>Charité Papers with Shared Datasets</a:t>
             </a:r>
-            <a:endParaRPr lang="de-DE" sz="1100" dirty="0">
+            <a:endParaRPr lang="de-DE" sz="1291" dirty="0">
               <a:latin typeface="Arial" panose="020B0604020202020204" pitchFamily="34" charset="0"/>
               <a:cs typeface="Arial" panose="020B0604020202020204" pitchFamily="34" charset="0"/>
             </a:endParaRPr>
@@ -4509,8 +4525,8 @@
         </p:nvSpPr>
         <p:spPr>
           <a:xfrm>
-            <a:off x="2110235" y="1836272"/>
-            <a:ext cx="1880740" cy="351647"/>
+            <a:off x="1726516" y="835071"/>
+            <a:ext cx="3384956" cy="412615"/>
           </a:xfrm>
           <a:prstGeom prst="roundRect">
             <a:avLst/>
@@ -4568,16 +4584,16 @@
           <a:p>
             <a:pPr algn="ctr"/>
             <a:r>
-              <a:rPr lang="en-US" sz="1200" dirty="0">
+              <a:rPr lang="en-US" sz="1408" dirty="0">
                 <a:solidFill>
                   <a:schemeClr val="tx1"/>
                 </a:solidFill>
                 <a:latin typeface="Arial" panose="020B0604020202020204" pitchFamily="34" charset="0"/>
                 <a:cs typeface="Arial" panose="020B0604020202020204" pitchFamily="34" charset="0"/>
               </a:rPr>
-              <a:t>15748 Charité Papers</a:t>
-            </a:r>
-            <a:endParaRPr lang="de-DE" sz="1200" dirty="0">
+              <a:t>15748 Charité Papers (2020-2023)</a:t>
+            </a:r>
+            <a:endParaRPr lang="de-DE" sz="1408" dirty="0">
               <a:solidFill>
                 <a:schemeClr val="tx1"/>
               </a:solidFill>
@@ -4604,8 +4620,8 @@
         </p:nvCxnSpPr>
         <p:spPr>
           <a:xfrm>
-            <a:off x="2597109" y="4835600"/>
-            <a:ext cx="867373" cy="0"/>
+            <a:off x="2750217" y="5295253"/>
+            <a:ext cx="1314937" cy="0"/>
           </a:xfrm>
           <a:prstGeom prst="straightConnector1">
             <a:avLst/>
@@ -4653,8 +4669,8 @@
         </p:nvCxnSpPr>
         <p:spPr>
           <a:xfrm>
-            <a:off x="2603500" y="6392104"/>
-            <a:ext cx="860999" cy="0"/>
+            <a:off x="2757715" y="7310305"/>
+            <a:ext cx="1307458" cy="0"/>
           </a:xfrm>
           <a:prstGeom prst="straightConnector1">
             <a:avLst/>
@@ -4698,36 +4714,78 @@
         </p:nvSpPr>
         <p:spPr>
           <a:xfrm>
-            <a:off x="2744936" y="4620156"/>
-            <a:ext cx="571718" cy="230832"/>
+            <a:off x="2913819" y="5063018"/>
+            <a:ext cx="1041839" cy="461088"/>
           </a:xfrm>
           <a:prstGeom prst="rect">
             <a:avLst/>
           </a:prstGeom>
-        </p:spPr>
+          <a:ln>
+            <a:noFill/>
+            <a:headEnd type="triangle"/>
+            <a:tailEnd type="triangle"/>
+          </a:ln>
+        </p:spPr>
+        <p:style>
+          <a:lnRef idx="1">
+            <a:schemeClr val="accent1"/>
+          </a:lnRef>
+          <a:fillRef idx="0">
+            <a:schemeClr val="accent1"/>
+          </a:fillRef>
+          <a:effectRef idx="0">
+            <a:schemeClr val="accent1"/>
+          </a:effectRef>
+          <a:fontRef idx="minor">
+            <a:schemeClr val="tx1"/>
+          </a:fontRef>
+        </p:style>
         <p:txBody>
           <a:bodyPr wrap="square">
             <a:spAutoFit/>
           </a:bodyPr>
           <a:lstStyle/>
           <a:p>
-            <a:pPr algn="ctr"/>
-            <a:r>
-              <a:rPr lang="en-US" sz="900" dirty="0">
+            <a:pPr algn="ctr">
+              <a:lnSpc>
+                <a:spcPts val="1500"/>
+              </a:lnSpc>
+            </a:pPr>
+            <a:r>
+              <a:rPr lang="en-US" sz="1100" dirty="0">
                 <a:solidFill>
                   <a:schemeClr val="bg1">
-                    <a:lumMod val="65000"/>
+                    <a:lumMod val="50000"/>
                   </a:schemeClr>
                 </a:solidFill>
                 <a:latin typeface="Arial" panose="020B0604020202020204" pitchFamily="34" charset="0"/>
                 <a:cs typeface="Arial" panose="020B0604020202020204" pitchFamily="34" charset="0"/>
               </a:rPr>
-              <a:t>(62)</a:t>
-            </a:r>
-            <a:endParaRPr lang="de-DE" sz="900" dirty="0">
+              <a:t>62</a:t>
+            </a:r>
+          </a:p>
+          <a:p>
+            <a:pPr algn="ctr">
+              <a:lnSpc>
+                <a:spcPts val="1500"/>
+              </a:lnSpc>
+            </a:pPr>
+            <a:r>
+              <a:rPr lang="en-US" sz="1100" dirty="0">
+                <a:solidFill>
+                  <a:schemeClr val="bg1">
+                    <a:lumMod val="50000"/>
+                  </a:schemeClr>
+                </a:solidFill>
+                <a:latin typeface="Arial" panose="020B0604020202020204" pitchFamily="34" charset="0"/>
+                <a:cs typeface="Arial" panose="020B0604020202020204" pitchFamily="34" charset="0"/>
+              </a:rPr>
+              <a:t>Overlapping</a:t>
+            </a:r>
+            <a:endParaRPr lang="de-DE" sz="1100" dirty="0">
               <a:solidFill>
                 <a:schemeClr val="bg1">
-                  <a:lumMod val="65000"/>
+                  <a:lumMod val="50000"/>
                 </a:schemeClr>
               </a:solidFill>
               <a:latin typeface="Arial" panose="020B0604020202020204" pitchFamily="34" charset="0"/>
@@ -4750,8 +4808,8 @@
         </p:nvSpPr>
         <p:spPr>
           <a:xfrm>
-            <a:off x="2751328" y="6190122"/>
-            <a:ext cx="571718" cy="230832"/>
+            <a:off x="2906455" y="7084130"/>
+            <a:ext cx="1033011" cy="461088"/>
           </a:xfrm>
           <a:prstGeom prst="rect">
             <a:avLst/>
@@ -4763,23 +4821,46 @@
           </a:bodyPr>
           <a:lstStyle/>
           <a:p>
-            <a:pPr algn="ctr"/>
-            <a:r>
-              <a:rPr lang="en-US" sz="900" dirty="0">
+            <a:pPr algn="ctr">
+              <a:lnSpc>
+                <a:spcPts val="1500"/>
+              </a:lnSpc>
+            </a:pPr>
+            <a:r>
+              <a:rPr lang="en-US" sz="1100" dirty="0">
                 <a:solidFill>
                   <a:schemeClr val="bg1">
-                    <a:lumMod val="65000"/>
+                    <a:lumMod val="50000"/>
                   </a:schemeClr>
                 </a:solidFill>
                 <a:latin typeface="Arial" panose="020B0604020202020204" pitchFamily="34" charset="0"/>
                 <a:cs typeface="Arial" panose="020B0604020202020204" pitchFamily="34" charset="0"/>
               </a:rPr>
-              <a:t>(325)</a:t>
-            </a:r>
-            <a:endParaRPr lang="de-DE" sz="900" dirty="0">
+              <a:t>325</a:t>
+            </a:r>
+          </a:p>
+          <a:p>
+            <a:pPr algn="ctr">
+              <a:lnSpc>
+                <a:spcPts val="1500"/>
+              </a:lnSpc>
+            </a:pPr>
+            <a:r>
+              <a:rPr lang="en-US" sz="1100" dirty="0">
+                <a:solidFill>
+                  <a:schemeClr val="bg1">
+                    <a:lumMod val="50000"/>
+                  </a:schemeClr>
+                </a:solidFill>
+                <a:latin typeface="Arial" panose="020B0604020202020204" pitchFamily="34" charset="0"/>
+                <a:cs typeface="Arial" panose="020B0604020202020204" pitchFamily="34" charset="0"/>
+              </a:rPr>
+              <a:t>Overlapping</a:t>
+            </a:r>
+            <a:endParaRPr lang="de-DE" sz="1100" dirty="0">
               <a:solidFill>
                 <a:schemeClr val="bg1">
-                  <a:lumMod val="65000"/>
+                  <a:lumMod val="50000"/>
                 </a:schemeClr>
               </a:solidFill>
               <a:latin typeface="Arial" panose="020B0604020202020204" pitchFamily="34" charset="0"/>
@@ -4788,6 +4869,317 @@
           </a:p>
         </p:txBody>
       </p:sp>
+      <p:cxnSp>
+        <p:nvCxnSpPr>
+          <p:cNvPr id="32" name="Straight Arrow Connector 31">
+            <a:extLst>
+              <a:ext uri="{FF2B5EF4-FFF2-40B4-BE49-F238E27FC236}">
+                <a16:creationId xmlns:a16="http://schemas.microsoft.com/office/drawing/2014/main" id="{210F5922-3CDA-4585-8326-9CB45756D445}"/>
+              </a:ext>
+            </a:extLst>
+          </p:cNvPr>
+          <p:cNvCxnSpPr>
+            <a:cxnSpLocks/>
+            <a:stCxn id="2" idx="2"/>
+            <a:endCxn id="89" idx="0"/>
+          </p:cNvCxnSpPr>
+          <p:nvPr/>
+        </p:nvCxnSpPr>
+        <p:spPr>
+          <a:xfrm>
+            <a:off x="4557867" y="2531004"/>
+            <a:ext cx="0" cy="325231"/>
+          </a:xfrm>
+          <a:prstGeom prst="straightConnector1">
+            <a:avLst/>
+          </a:prstGeom>
+          <a:ln>
+            <a:solidFill>
+              <a:schemeClr val="bg1">
+                <a:lumMod val="65000"/>
+              </a:schemeClr>
+            </a:solidFill>
+            <a:tailEnd type="triangle"/>
+          </a:ln>
+        </p:spPr>
+        <p:style>
+          <a:lnRef idx="1">
+            <a:schemeClr val="accent1"/>
+          </a:lnRef>
+          <a:fillRef idx="0">
+            <a:schemeClr val="accent1"/>
+          </a:fillRef>
+          <a:effectRef idx="0">
+            <a:schemeClr val="accent1"/>
+          </a:effectRef>
+          <a:fontRef idx="minor">
+            <a:schemeClr val="tx1"/>
+          </a:fontRef>
+        </p:style>
+      </p:cxnSp>
+      <p:sp>
+        <p:nvSpPr>
+          <p:cNvPr id="2" name="Rectangle 1">
+            <a:extLst>
+              <a:ext uri="{FF2B5EF4-FFF2-40B4-BE49-F238E27FC236}">
+                <a16:creationId xmlns:a16="http://schemas.microsoft.com/office/drawing/2014/main" id="{86A5693A-EED4-4551-9CD6-0153B32A6EF7}"/>
+              </a:ext>
+            </a:extLst>
+          </p:cNvPr>
+          <p:cNvSpPr/>
+          <p:nvPr/>
+        </p:nvSpPr>
+        <p:spPr>
+          <a:xfrm>
+            <a:off x="3709045" y="2007784"/>
+            <a:ext cx="1697644" cy="523220"/>
+          </a:xfrm>
+          <a:prstGeom prst="rect">
+            <a:avLst/>
+          </a:prstGeom>
+        </p:spPr>
+        <p:txBody>
+          <a:bodyPr wrap="none">
+            <a:spAutoFit/>
+          </a:bodyPr>
+          <a:lstStyle/>
+          <a:p>
+            <a:pPr algn="ctr"/>
+            <a:r>
+              <a:rPr lang="de-DE" sz="1400" dirty="0">
+                <a:solidFill>
+                  <a:schemeClr val="accent5">
+                    <a:lumMod val="50000"/>
+                  </a:schemeClr>
+                </a:solidFill>
+                <a:latin typeface="Arial" panose="020B0604020202020204" pitchFamily="34" charset="0"/>
+                <a:cs typeface="Arial" panose="020B0604020202020204" pitchFamily="34" charset="0"/>
+              </a:rPr>
+              <a:t>ODDPub</a:t>
+            </a:r>
+            <a:r>
+              <a:rPr lang="de-DE" sz="1400" dirty="0">
+                <a:solidFill>
+                  <a:schemeClr val="accent5">
+                    <a:lumMod val="50000"/>
+                  </a:schemeClr>
+                </a:solidFill>
+                <a:latin typeface="Arial" panose="020B0604020202020204" pitchFamily="34" charset="0"/>
+              </a:rPr>
+              <a:t> and</a:t>
+            </a:r>
+          </a:p>
+          <a:p>
+            <a:pPr algn="ctr"/>
+            <a:r>
+              <a:rPr lang="de-DE" sz="1400" dirty="0">
+                <a:solidFill>
+                  <a:schemeClr val="accent5">
+                    <a:lumMod val="50000"/>
+                  </a:schemeClr>
+                </a:solidFill>
+                <a:latin typeface="Arial" panose="020B0604020202020204" pitchFamily="34" charset="0"/>
+              </a:rPr>
+              <a:t>Manual Verification</a:t>
+            </a:r>
+            <a:endParaRPr lang="de-DE" sz="1400" dirty="0">
+              <a:solidFill>
+                <a:schemeClr val="accent5">
+                  <a:lumMod val="50000"/>
+                </a:schemeClr>
+              </a:solidFill>
+            </a:endParaRPr>
+          </a:p>
+        </p:txBody>
+      </p:sp>
+      <p:cxnSp>
+        <p:nvCxnSpPr>
+          <p:cNvPr id="10" name="Straight Connector 9">
+            <a:extLst>
+              <a:ext uri="{FF2B5EF4-FFF2-40B4-BE49-F238E27FC236}">
+                <a16:creationId xmlns:a16="http://schemas.microsoft.com/office/drawing/2014/main" id="{B38E50F4-3EB6-4472-AB36-428E5FC342AB}"/>
+              </a:ext>
+            </a:extLst>
+          </p:cNvPr>
+          <p:cNvCxnSpPr>
+            <a:cxnSpLocks/>
+          </p:cNvCxnSpPr>
+          <p:nvPr/>
+        </p:nvCxnSpPr>
+        <p:spPr>
+          <a:xfrm flipH="1" flipV="1">
+            <a:off x="4557866" y="1405801"/>
+            <a:ext cx="2239" cy="646868"/>
+          </a:xfrm>
+          <a:prstGeom prst="line">
+            <a:avLst/>
+          </a:prstGeom>
+          <a:ln>
+            <a:solidFill>
+              <a:schemeClr val="bg1">
+                <a:lumMod val="65000"/>
+              </a:schemeClr>
+            </a:solidFill>
+          </a:ln>
+        </p:spPr>
+        <p:style>
+          <a:lnRef idx="1">
+            <a:schemeClr val="accent1"/>
+          </a:lnRef>
+          <a:fillRef idx="0">
+            <a:schemeClr val="accent1"/>
+          </a:fillRef>
+          <a:effectRef idx="0">
+            <a:schemeClr val="accent1"/>
+          </a:effectRef>
+          <a:fontRef idx="minor">
+            <a:schemeClr val="tx1"/>
+          </a:fontRef>
+        </p:style>
+      </p:cxnSp>
+      <p:cxnSp>
+        <p:nvCxnSpPr>
+          <p:cNvPr id="45" name="Straight Arrow Connector 44">
+            <a:extLst>
+              <a:ext uri="{FF2B5EF4-FFF2-40B4-BE49-F238E27FC236}">
+                <a16:creationId xmlns:a16="http://schemas.microsoft.com/office/drawing/2014/main" id="{BF7B5AA1-6411-4DB4-BA6B-6917164AE427}"/>
+              </a:ext>
+            </a:extLst>
+          </p:cNvPr>
+          <p:cNvCxnSpPr>
+            <a:cxnSpLocks/>
+            <a:stCxn id="46" idx="2"/>
+            <a:endCxn id="37" idx="0"/>
+          </p:cNvCxnSpPr>
+          <p:nvPr/>
+        </p:nvCxnSpPr>
+        <p:spPr>
+          <a:xfrm>
+            <a:off x="2271910" y="2405232"/>
+            <a:ext cx="1" cy="2683713"/>
+          </a:xfrm>
+          <a:prstGeom prst="straightConnector1">
+            <a:avLst/>
+          </a:prstGeom>
+          <a:ln>
+            <a:solidFill>
+              <a:schemeClr val="bg1">
+                <a:lumMod val="65000"/>
+              </a:schemeClr>
+            </a:solidFill>
+            <a:tailEnd type="triangle"/>
+          </a:ln>
+        </p:spPr>
+        <p:style>
+          <a:lnRef idx="1">
+            <a:schemeClr val="accent1"/>
+          </a:lnRef>
+          <a:fillRef idx="0">
+            <a:schemeClr val="accent1"/>
+          </a:fillRef>
+          <a:effectRef idx="0">
+            <a:schemeClr val="accent1"/>
+          </a:effectRef>
+          <a:fontRef idx="minor">
+            <a:schemeClr val="tx1"/>
+          </a:fontRef>
+        </p:style>
+      </p:cxnSp>
+      <p:sp>
+        <p:nvSpPr>
+          <p:cNvPr id="46" name="Rectangle 45">
+            <a:extLst>
+              <a:ext uri="{FF2B5EF4-FFF2-40B4-BE49-F238E27FC236}">
+                <a16:creationId xmlns:a16="http://schemas.microsoft.com/office/drawing/2014/main" id="{E436A577-EB67-4219-929E-242465663E95}"/>
+              </a:ext>
+            </a:extLst>
+          </p:cNvPr>
+          <p:cNvSpPr/>
+          <p:nvPr/>
+        </p:nvSpPr>
+        <p:spPr>
+          <a:xfrm>
+            <a:off x="1830923" y="2097455"/>
+            <a:ext cx="881973" cy="307777"/>
+          </a:xfrm>
+          <a:prstGeom prst="rect">
+            <a:avLst/>
+          </a:prstGeom>
+        </p:spPr>
+        <p:txBody>
+          <a:bodyPr wrap="none">
+            <a:spAutoFit/>
+          </a:bodyPr>
+          <a:lstStyle/>
+          <a:p>
+            <a:pPr algn="ctr"/>
+            <a:r>
+              <a:rPr lang="de-DE" sz="1400" dirty="0">
+                <a:solidFill>
+                  <a:schemeClr val="accent5">
+                    <a:lumMod val="50000"/>
+                  </a:schemeClr>
+                </a:solidFill>
+                <a:latin typeface="Arial" panose="020B0604020202020204" pitchFamily="34" charset="0"/>
+                <a:cs typeface="Arial" panose="020B0604020202020204" pitchFamily="34" charset="0"/>
+              </a:rPr>
+              <a:t>DataStet</a:t>
+            </a:r>
+            <a:endParaRPr lang="de-DE" sz="1400" dirty="0">
+              <a:solidFill>
+                <a:schemeClr val="accent5">
+                  <a:lumMod val="50000"/>
+                </a:schemeClr>
+              </a:solidFill>
+            </a:endParaRPr>
+          </a:p>
+        </p:txBody>
+      </p:sp>
+      <p:cxnSp>
+        <p:nvCxnSpPr>
+          <p:cNvPr id="47" name="Straight Connector 46">
+            <a:extLst>
+              <a:ext uri="{FF2B5EF4-FFF2-40B4-BE49-F238E27FC236}">
+                <a16:creationId xmlns:a16="http://schemas.microsoft.com/office/drawing/2014/main" id="{86F92F92-9331-477A-8B37-F8DE7AC5719E}"/>
+              </a:ext>
+            </a:extLst>
+          </p:cNvPr>
+          <p:cNvCxnSpPr>
+            <a:cxnSpLocks/>
+          </p:cNvCxnSpPr>
+          <p:nvPr/>
+        </p:nvCxnSpPr>
+        <p:spPr>
+          <a:xfrm flipH="1" flipV="1">
+            <a:off x="2273693" y="1405802"/>
+            <a:ext cx="1" cy="691653"/>
+          </a:xfrm>
+          <a:prstGeom prst="line">
+            <a:avLst/>
+          </a:prstGeom>
+          <a:ln>
+            <a:solidFill>
+              <a:schemeClr val="bg1">
+                <a:lumMod val="65000"/>
+              </a:schemeClr>
+            </a:solidFill>
+          </a:ln>
+        </p:spPr>
+        <p:style>
+          <a:lnRef idx="1">
+            <a:schemeClr val="accent1"/>
+          </a:lnRef>
+          <a:fillRef idx="0">
+            <a:schemeClr val="accent1"/>
+          </a:fillRef>
+          <a:effectRef idx="0">
+            <a:schemeClr val="accent1"/>
+          </a:effectRef>
+          <a:fontRef idx="minor">
+            <a:schemeClr val="tx1"/>
+          </a:fontRef>
+        </p:style>
+      </p:cxnSp>
     </p:spTree>
     <p:extLst>
       <p:ext uri="{BB962C8B-B14F-4D97-AF65-F5344CB8AC3E}">
@@ -4832,8 +5224,8 @@
         </p:nvSpPr>
         <p:spPr>
           <a:xfrm>
-            <a:off x="4311933" y="3699924"/>
-            <a:ext cx="1557989" cy="430887"/>
+            <a:off x="5059535" y="3284493"/>
+            <a:ext cx="1828113" cy="480581"/>
           </a:xfrm>
           <a:prstGeom prst="rect">
             <a:avLst/>
@@ -4846,7 +5238,7 @@
           <a:lstStyle/>
           <a:p>
             <a:r>
-              <a:rPr lang="en-US" sz="1100" dirty="0">
+              <a:rPr lang="en-US" sz="1291" dirty="0">
                 <a:latin typeface="Arial" panose="020B0604020202020204" pitchFamily="34" charset="0"/>
                 <a:cs typeface="Arial" panose="020B0604020202020204" pitchFamily="34" charset="0"/>
               </a:rPr>
@@ -4855,7 +5247,7 @@
           </a:p>
           <a:p>
             <a:r>
-              <a:rPr lang="de-DE" sz="1050" dirty="0">
+              <a:rPr lang="de-DE" sz="1232" dirty="0">
                 <a:solidFill>
                   <a:schemeClr val="bg1">
                     <a:lumMod val="50000"/>
@@ -4883,8 +5275,8 @@
         </p:nvSpPr>
         <p:spPr>
           <a:xfrm>
-            <a:off x="3464482" y="3739545"/>
-            <a:ext cx="847452" cy="351647"/>
+            <a:off x="4065153" y="3330985"/>
+            <a:ext cx="994383" cy="412615"/>
           </a:xfrm>
           <a:prstGeom prst="roundRect">
             <a:avLst/>
@@ -4939,7 +5331,7 @@
           <a:p>
             <a:pPr algn="ctr"/>
             <a:r>
-              <a:rPr lang="en-US" sz="1200">
+              <a:rPr lang="en-US" sz="1408">
                 <a:solidFill>
                   <a:schemeClr val="tx1"/>
                 </a:solidFill>
@@ -4948,7 +5340,7 @@
               </a:rPr>
               <a:t>1765</a:t>
             </a:r>
-            <a:endParaRPr lang="de-DE" sz="1200" dirty="0">
+            <a:endParaRPr lang="de-DE" sz="1408" dirty="0">
               <a:solidFill>
                 <a:schemeClr val="tx1"/>
               </a:solidFill>
@@ -4972,8 +5364,8 @@
         </p:nvSpPr>
         <p:spPr>
           <a:xfrm>
-            <a:off x="3464482" y="4659776"/>
-            <a:ext cx="847452" cy="351647"/>
+            <a:off x="4065153" y="4410766"/>
+            <a:ext cx="994383" cy="412615"/>
           </a:xfrm>
           <a:prstGeom prst="roundRect">
             <a:avLst/>
@@ -5028,7 +5420,7 @@
           <a:p>
             <a:pPr algn="ctr"/>
             <a:r>
-              <a:rPr lang="en-US" sz="1200" dirty="0">
+              <a:rPr lang="en-US" sz="1408" dirty="0">
                 <a:solidFill>
                   <a:schemeClr val="tx1"/>
                 </a:solidFill>
@@ -5037,7 +5429,7 @@
               </a:rPr>
               <a:t>?</a:t>
             </a:r>
-            <a:endParaRPr lang="de-DE" sz="1200" dirty="0">
+            <a:endParaRPr lang="de-DE" sz="1408" dirty="0">
               <a:solidFill>
                 <a:schemeClr val="tx1"/>
               </a:solidFill>
@@ -5065,8 +5457,8 @@
         </p:nvCxnSpPr>
         <p:spPr>
           <a:xfrm>
-            <a:off x="3888208" y="4091192"/>
-            <a:ext cx="0" cy="568585"/>
+            <a:off x="4562344" y="3743600"/>
+            <a:ext cx="0" cy="667166"/>
           </a:xfrm>
           <a:prstGeom prst="straightConnector1">
             <a:avLst/>
@@ -5109,8 +5501,8 @@
         </p:nvSpPr>
         <p:spPr>
           <a:xfrm>
-            <a:off x="4304303" y="4704794"/>
-            <a:ext cx="1558000" cy="261610"/>
+            <a:off x="5050582" y="4463588"/>
+            <a:ext cx="1828125" cy="290977"/>
           </a:xfrm>
           <a:prstGeom prst="rect">
             <a:avLst/>
@@ -5123,13 +5515,13 @@
           <a:lstStyle/>
           <a:p>
             <a:r>
-              <a:rPr lang="en-US" sz="1100" dirty="0">
+              <a:rPr lang="en-US" sz="1291" dirty="0">
                 <a:latin typeface="Arial" panose="020B0604020202020204" pitchFamily="34" charset="0"/>
                 <a:cs typeface="Arial" panose="020B0604020202020204" pitchFamily="34" charset="0"/>
               </a:rPr>
               <a:t>Estimated Citations</a:t>
             </a:r>
-            <a:endParaRPr lang="de-DE" sz="1100" dirty="0">
+            <a:endParaRPr lang="de-DE" sz="1291" dirty="0">
               <a:latin typeface="Arial" panose="020B0604020202020204" pitchFamily="34" charset="0"/>
               <a:cs typeface="Arial" panose="020B0604020202020204" pitchFamily="34" charset="0"/>
             </a:endParaRPr>
@@ -5150,8 +5542,8 @@
         </p:nvSpPr>
         <p:spPr>
           <a:xfrm>
-            <a:off x="3464482" y="2805223"/>
-            <a:ext cx="847452" cy="351647"/>
+            <a:off x="4065153" y="2234670"/>
+            <a:ext cx="994383" cy="412615"/>
           </a:xfrm>
           <a:prstGeom prst="roundRect">
             <a:avLst/>
@@ -5206,7 +5598,7 @@
           <a:p>
             <a:pPr algn="ctr"/>
             <a:r>
-              <a:rPr lang="en-US" sz="1200" dirty="0">
+              <a:rPr lang="en-US" sz="1408" dirty="0">
                 <a:solidFill>
                   <a:schemeClr val="tx1"/>
                 </a:solidFill>
@@ -5215,7 +5607,7 @@
               </a:rPr>
               <a:t>34</a:t>
             </a:r>
-            <a:endParaRPr lang="de-DE" sz="1200" dirty="0">
+            <a:endParaRPr lang="de-DE" sz="1408" dirty="0">
               <a:solidFill>
                 <a:schemeClr val="tx1"/>
               </a:solidFill>
@@ -5243,8 +5635,8 @@
         </p:nvCxnSpPr>
         <p:spPr>
           <a:xfrm>
-            <a:off x="3888208" y="3156870"/>
-            <a:ext cx="0" cy="582675"/>
+            <a:off x="4562344" y="2647285"/>
+            <a:ext cx="0" cy="683699"/>
           </a:xfrm>
           <a:prstGeom prst="straightConnector1">
             <a:avLst/>
@@ -5287,8 +5679,8 @@
         </p:nvSpPr>
         <p:spPr>
           <a:xfrm>
-            <a:off x="4308118" y="2842546"/>
-            <a:ext cx="1372571" cy="261610"/>
+            <a:off x="5055059" y="2278464"/>
+            <a:ext cx="1610547" cy="290977"/>
           </a:xfrm>
           <a:prstGeom prst="rect">
             <a:avLst/>
@@ -5301,13 +5693,13 @@
           <a:lstStyle/>
           <a:p>
             <a:r>
-              <a:rPr lang="en-US" sz="1100" dirty="0">
+              <a:rPr lang="en-US" sz="1291" dirty="0">
                 <a:latin typeface="Arial" panose="020B0604020202020204" pitchFamily="34" charset="0"/>
                 <a:cs typeface="Arial" panose="020B0604020202020204" pitchFamily="34" charset="0"/>
               </a:rPr>
               <a:t>Charité Datasets</a:t>
             </a:r>
-            <a:endParaRPr lang="de-DE" sz="1100" dirty="0">
+            <a:endParaRPr lang="de-DE" sz="1291" dirty="0">
               <a:latin typeface="Arial" panose="020B0604020202020204" pitchFamily="34" charset="0"/>
               <a:cs typeface="Arial" panose="020B0604020202020204" pitchFamily="34" charset="0"/>
             </a:endParaRPr>
@@ -5328,8 +5720,8 @@
         </p:nvSpPr>
         <p:spPr>
           <a:xfrm>
-            <a:off x="3460666" y="1868520"/>
-            <a:ext cx="847452" cy="351647"/>
+            <a:off x="4060675" y="1135562"/>
+            <a:ext cx="994383" cy="412615"/>
           </a:xfrm>
           <a:prstGeom prst="roundRect">
             <a:avLst/>
@@ -5384,7 +5776,7 @@
           <a:p>
             <a:pPr algn="ctr"/>
             <a:r>
-              <a:rPr lang="en-US" sz="1200" dirty="0">
+              <a:rPr lang="en-US" sz="1408" dirty="0">
                 <a:solidFill>
                   <a:schemeClr val="tx1"/>
                 </a:solidFill>
@@ -5393,7 +5785,7 @@
               </a:rPr>
               <a:t>28</a:t>
             </a:r>
-            <a:endParaRPr lang="de-DE" sz="1200" dirty="0">
+            <a:endParaRPr lang="de-DE" sz="1408" dirty="0">
               <a:solidFill>
                 <a:schemeClr val="tx1"/>
               </a:solidFill>
@@ -5421,8 +5813,8 @@
         </p:nvCxnSpPr>
         <p:spPr>
           <a:xfrm>
-            <a:off x="3884392" y="2220167"/>
-            <a:ext cx="3816" cy="585056"/>
+            <a:off x="4557867" y="1548176"/>
+            <a:ext cx="4478" cy="686493"/>
           </a:xfrm>
           <a:prstGeom prst="straightConnector1">
             <a:avLst/>
@@ -5465,8 +5857,8 @@
         </p:nvSpPr>
         <p:spPr>
           <a:xfrm>
-            <a:off x="4304302" y="1905843"/>
-            <a:ext cx="1558000" cy="261610"/>
+            <a:off x="5050581" y="1179356"/>
+            <a:ext cx="1828125" cy="290977"/>
           </a:xfrm>
           <a:prstGeom prst="rect">
             <a:avLst/>
@@ -5479,13 +5871,13 @@
           <a:lstStyle/>
           <a:p>
             <a:r>
-              <a:rPr lang="en-US" sz="1100" dirty="0">
+              <a:rPr lang="en-US" sz="1291" dirty="0">
                 <a:latin typeface="Arial" panose="020B0604020202020204" pitchFamily="34" charset="0"/>
                 <a:cs typeface="Arial" panose="020B0604020202020204" pitchFamily="34" charset="0"/>
               </a:rPr>
               <a:t>Charité Data Articles</a:t>
             </a:r>
-            <a:endParaRPr lang="de-DE" sz="1100" dirty="0">
+            <a:endParaRPr lang="de-DE" sz="1291" dirty="0">
               <a:latin typeface="Arial" panose="020B0604020202020204" pitchFamily="34" charset="0"/>
               <a:cs typeface="Arial" panose="020B0604020202020204" pitchFamily="34" charset="0"/>
             </a:endParaRPr>
@@ -5496,6 +5888,86 @@
     <p:extLst>
       <p:ext uri="{BB962C8B-B14F-4D97-AF65-F5344CB8AC3E}">
         <p14:creationId xmlns:p14="http://schemas.microsoft.com/office/powerpoint/2010/main" val="225445080"/>
+      </p:ext>
+    </p:extLst>
+  </p:cSld>
+  <p:clrMapOvr>
+    <a:masterClrMapping/>
+  </p:clrMapOvr>
+</p:sld>
+</file>
+
+<file path=ppt/slides/slide3.xml><?xml version="1.0" encoding="utf-8"?>
+<p:sld xmlns:a="http://schemas.openxmlformats.org/drawingml/2006/main" xmlns:r="http://schemas.openxmlformats.org/officeDocument/2006/relationships" xmlns:p="http://schemas.openxmlformats.org/presentationml/2006/main">
+  <p:cSld>
+    <p:spTree>
+      <p:nvGrpSpPr>
+        <p:cNvPr id="1" name=""/>
+        <p:cNvGrpSpPr/>
+        <p:nvPr/>
+      </p:nvGrpSpPr>
+      <p:grpSpPr>
+        <a:xfrm>
+          <a:off x="0" y="0"/>
+          <a:ext cx="0" cy="0"/>
+          <a:chOff x="0" y="0"/>
+          <a:chExt cx="0" cy="0"/>
+        </a:xfrm>
+      </p:grpSpPr>
+      <p:sp>
+        <p:nvSpPr>
+          <p:cNvPr id="2" name="Title 1">
+            <a:extLst>
+              <a:ext uri="{FF2B5EF4-FFF2-40B4-BE49-F238E27FC236}">
+                <a16:creationId xmlns:a16="http://schemas.microsoft.com/office/drawing/2014/main" id="{BF53E300-3FD7-4319-9640-2C4886D462FD}"/>
+              </a:ext>
+            </a:extLst>
+          </p:cNvPr>
+          <p:cNvSpPr>
+            <a:spLocks noGrp="1"/>
+          </p:cNvSpPr>
+          <p:nvPr>
+            <p:ph type="title"/>
+          </p:nvPr>
+        </p:nvSpPr>
+        <p:spPr/>
+        <p:txBody>
+          <a:bodyPr/>
+          <a:lstStyle/>
+          <a:p>
+            <a:endParaRPr lang="de-DE"/>
+          </a:p>
+        </p:txBody>
+      </p:sp>
+      <p:sp>
+        <p:nvSpPr>
+          <p:cNvPr id="3" name="Content Placeholder 2">
+            <a:extLst>
+              <a:ext uri="{FF2B5EF4-FFF2-40B4-BE49-F238E27FC236}">
+                <a16:creationId xmlns:a16="http://schemas.microsoft.com/office/drawing/2014/main" id="{34B3A751-5B87-4E9F-8BB0-8F64161D3A4C}"/>
+              </a:ext>
+            </a:extLst>
+          </p:cNvPr>
+          <p:cNvSpPr>
+            <a:spLocks noGrp="1"/>
+          </p:cNvSpPr>
+          <p:nvPr>
+            <p:ph idx="1"/>
+          </p:nvPr>
+        </p:nvSpPr>
+        <p:spPr/>
+        <p:txBody>
+          <a:bodyPr/>
+          <a:lstStyle/>
+          <a:p>
+            <a:endParaRPr lang="de-DE"/>
+          </a:p>
+        </p:txBody>
+      </p:sp>
+    </p:spTree>
+    <p:extLst>
+      <p:ext uri="{BB962C8B-B14F-4D97-AF65-F5344CB8AC3E}">
+        <p14:creationId xmlns:p14="http://schemas.microsoft.com/office/powerpoint/2010/main" val="3543156593"/>
       </p:ext>
     </p:extLst>
   </p:cSld>

</xml_diff>

<commit_message>
Added more information & replies throughout index.qmd (not only methods section). Added Ns to plots. Updated data articles flowchart with extrapolated number. Rendered an updated index.qmd.
</commit_message>
<xml_diff>
--- a/plots_png/pptx/plots_png.pptx
+++ b/plots_png/pptx/plots_png.pptx
@@ -7,7 +7,6 @@
   <p:sldIdLst>
     <p:sldId id="260" r:id="rId2"/>
     <p:sldId id="256" r:id="rId3"/>
-    <p:sldId id="261" r:id="rId4"/>
   </p:sldIdLst>
   <p:sldSz cx="8047038" cy="12192000"/>
   <p:notesSz cx="6858000" cy="9144000"/>
@@ -256,7 +255,7 @@
           <a:p>
             <a:fld id="{83D14EEA-DE26-4810-8E05-A65F0010FADE}" type="datetimeFigureOut">
               <a:rPr lang="de-DE" smtClean="0"/>
-              <a:t>23.10.2025</a:t>
+              <a:t>28.10.2025</a:t>
             </a:fld>
             <a:endParaRPr lang="de-DE"/>
           </a:p>
@@ -426,7 +425,7 @@
           <a:p>
             <a:fld id="{83D14EEA-DE26-4810-8E05-A65F0010FADE}" type="datetimeFigureOut">
               <a:rPr lang="de-DE" smtClean="0"/>
-              <a:t>23.10.2025</a:t>
+              <a:t>28.10.2025</a:t>
             </a:fld>
             <a:endParaRPr lang="de-DE"/>
           </a:p>
@@ -606,7 +605,7 @@
           <a:p>
             <a:fld id="{83D14EEA-DE26-4810-8E05-A65F0010FADE}" type="datetimeFigureOut">
               <a:rPr lang="de-DE" smtClean="0"/>
-              <a:t>23.10.2025</a:t>
+              <a:t>28.10.2025</a:t>
             </a:fld>
             <a:endParaRPr lang="de-DE"/>
           </a:p>
@@ -776,7 +775,7 @@
           <a:p>
             <a:fld id="{83D14EEA-DE26-4810-8E05-A65F0010FADE}" type="datetimeFigureOut">
               <a:rPr lang="de-DE" smtClean="0"/>
-              <a:t>23.10.2025</a:t>
+              <a:t>28.10.2025</a:t>
             </a:fld>
             <a:endParaRPr lang="de-DE"/>
           </a:p>
@@ -1020,7 +1019,7 @@
           <a:p>
             <a:fld id="{83D14EEA-DE26-4810-8E05-A65F0010FADE}" type="datetimeFigureOut">
               <a:rPr lang="de-DE" smtClean="0"/>
-              <a:t>23.10.2025</a:t>
+              <a:t>28.10.2025</a:t>
             </a:fld>
             <a:endParaRPr lang="de-DE"/>
           </a:p>
@@ -1252,7 +1251,7 @@
           <a:p>
             <a:fld id="{83D14EEA-DE26-4810-8E05-A65F0010FADE}" type="datetimeFigureOut">
               <a:rPr lang="de-DE" smtClean="0"/>
-              <a:t>23.10.2025</a:t>
+              <a:t>28.10.2025</a:t>
             </a:fld>
             <a:endParaRPr lang="de-DE"/>
           </a:p>
@@ -1619,7 +1618,7 @@
           <a:p>
             <a:fld id="{83D14EEA-DE26-4810-8E05-A65F0010FADE}" type="datetimeFigureOut">
               <a:rPr lang="de-DE" smtClean="0"/>
-              <a:t>23.10.2025</a:t>
+              <a:t>28.10.2025</a:t>
             </a:fld>
             <a:endParaRPr lang="de-DE"/>
           </a:p>
@@ -1737,7 +1736,7 @@
           <a:p>
             <a:fld id="{83D14EEA-DE26-4810-8E05-A65F0010FADE}" type="datetimeFigureOut">
               <a:rPr lang="de-DE" smtClean="0"/>
-              <a:t>23.10.2025</a:t>
+              <a:t>28.10.2025</a:t>
             </a:fld>
             <a:endParaRPr lang="de-DE"/>
           </a:p>
@@ -1832,7 +1831,7 @@
           <a:p>
             <a:fld id="{83D14EEA-DE26-4810-8E05-A65F0010FADE}" type="datetimeFigureOut">
               <a:rPr lang="de-DE" smtClean="0"/>
-              <a:t>23.10.2025</a:t>
+              <a:t>28.10.2025</a:t>
             </a:fld>
             <a:endParaRPr lang="de-DE"/>
           </a:p>
@@ -2109,7 +2108,7 @@
           <a:p>
             <a:fld id="{83D14EEA-DE26-4810-8E05-A65F0010FADE}" type="datetimeFigureOut">
               <a:rPr lang="de-DE" smtClean="0"/>
-              <a:t>23.10.2025</a:t>
+              <a:t>28.10.2025</a:t>
             </a:fld>
             <a:endParaRPr lang="de-DE"/>
           </a:p>
@@ -2366,7 +2365,7 @@
           <a:p>
             <a:fld id="{83D14EEA-DE26-4810-8E05-A65F0010FADE}" type="datetimeFigureOut">
               <a:rPr lang="de-DE" smtClean="0"/>
-              <a:t>23.10.2025</a:t>
+              <a:t>28.10.2025</a:t>
             </a:fld>
             <a:endParaRPr lang="de-DE"/>
           </a:p>
@@ -2579,7 +2578,7 @@
           <a:p>
             <a:fld id="{83D14EEA-DE26-4810-8E05-A65F0010FADE}" type="datetimeFigureOut">
               <a:rPr lang="de-DE" smtClean="0"/>
-              <a:t>23.10.2025</a:t>
+              <a:t>28.10.2025</a:t>
             </a:fld>
             <a:endParaRPr lang="de-DE"/>
           </a:p>
@@ -5427,7 +5426,7 @@
                 <a:latin typeface="Arial" panose="020B0604020202020204" pitchFamily="34" charset="0"/>
                 <a:cs typeface="Arial" panose="020B0604020202020204" pitchFamily="34" charset="0"/>
               </a:rPr>
-              <a:t>?</a:t>
+              <a:t>852</a:t>
             </a:r>
             <a:endParaRPr lang="de-DE" sz="1408" dirty="0">
               <a:solidFill>
@@ -5888,86 +5887,6 @@
     <p:extLst>
       <p:ext uri="{BB962C8B-B14F-4D97-AF65-F5344CB8AC3E}">
         <p14:creationId xmlns:p14="http://schemas.microsoft.com/office/powerpoint/2010/main" val="225445080"/>
-      </p:ext>
-    </p:extLst>
-  </p:cSld>
-  <p:clrMapOvr>
-    <a:masterClrMapping/>
-  </p:clrMapOvr>
-</p:sld>
-</file>
-
-<file path=ppt/slides/slide3.xml><?xml version="1.0" encoding="utf-8"?>
-<p:sld xmlns:a="http://schemas.openxmlformats.org/drawingml/2006/main" xmlns:r="http://schemas.openxmlformats.org/officeDocument/2006/relationships" xmlns:p="http://schemas.openxmlformats.org/presentationml/2006/main">
-  <p:cSld>
-    <p:spTree>
-      <p:nvGrpSpPr>
-        <p:cNvPr id="1" name=""/>
-        <p:cNvGrpSpPr/>
-        <p:nvPr/>
-      </p:nvGrpSpPr>
-      <p:grpSpPr>
-        <a:xfrm>
-          <a:off x="0" y="0"/>
-          <a:ext cx="0" cy="0"/>
-          <a:chOff x="0" y="0"/>
-          <a:chExt cx="0" cy="0"/>
-        </a:xfrm>
-      </p:grpSpPr>
-      <p:sp>
-        <p:nvSpPr>
-          <p:cNvPr id="2" name="Title 1">
-            <a:extLst>
-              <a:ext uri="{FF2B5EF4-FFF2-40B4-BE49-F238E27FC236}">
-                <a16:creationId xmlns:a16="http://schemas.microsoft.com/office/drawing/2014/main" id="{BF53E300-3FD7-4319-9640-2C4886D462FD}"/>
-              </a:ext>
-            </a:extLst>
-          </p:cNvPr>
-          <p:cNvSpPr>
-            <a:spLocks noGrp="1"/>
-          </p:cNvSpPr>
-          <p:nvPr>
-            <p:ph type="title"/>
-          </p:nvPr>
-        </p:nvSpPr>
-        <p:spPr/>
-        <p:txBody>
-          <a:bodyPr/>
-          <a:lstStyle/>
-          <a:p>
-            <a:endParaRPr lang="de-DE"/>
-          </a:p>
-        </p:txBody>
-      </p:sp>
-      <p:sp>
-        <p:nvSpPr>
-          <p:cNvPr id="3" name="Content Placeholder 2">
-            <a:extLst>
-              <a:ext uri="{FF2B5EF4-FFF2-40B4-BE49-F238E27FC236}">
-                <a16:creationId xmlns:a16="http://schemas.microsoft.com/office/drawing/2014/main" id="{34B3A751-5B87-4E9F-8BB0-8F64161D3A4C}"/>
-              </a:ext>
-            </a:extLst>
-          </p:cNvPr>
-          <p:cNvSpPr>
-            <a:spLocks noGrp="1"/>
-          </p:cNvSpPr>
-          <p:nvPr>
-            <p:ph idx="1"/>
-          </p:nvPr>
-        </p:nvSpPr>
-        <p:spPr/>
-        <p:txBody>
-          <a:bodyPr/>
-          <a:lstStyle/>
-          <a:p>
-            <a:endParaRPr lang="de-DE"/>
-          </a:p>
-        </p:txBody>
-      </p:sp>
-    </p:spTree>
-    <p:extLst>
-      <p:ext uri="{BB962C8B-B14F-4D97-AF65-F5344CB8AC3E}">
-        <p14:creationId xmlns:p14="http://schemas.microsoft.com/office/powerpoint/2010/main" val="3543156593"/>
       </p:ext>
     </p:extLst>
   </p:cSld>

</xml_diff>

<commit_message>
more index.qmd issues from EB's tasks are fixed
</commit_message>
<xml_diff>
--- a/plots_png/pptx/plots_png.pptx
+++ b/plots_png/pptx/plots_png.pptx
@@ -255,7 +255,7 @@
           <a:p>
             <a:fld id="{83D14EEA-DE26-4810-8E05-A65F0010FADE}" type="datetimeFigureOut">
               <a:rPr lang="de-DE" smtClean="0"/>
-              <a:t>28.10.2025</a:t>
+              <a:t>12.12.2025</a:t>
             </a:fld>
             <a:endParaRPr lang="de-DE"/>
           </a:p>
@@ -425,7 +425,7 @@
           <a:p>
             <a:fld id="{83D14EEA-DE26-4810-8E05-A65F0010FADE}" type="datetimeFigureOut">
               <a:rPr lang="de-DE" smtClean="0"/>
-              <a:t>28.10.2025</a:t>
+              <a:t>12.12.2025</a:t>
             </a:fld>
             <a:endParaRPr lang="de-DE"/>
           </a:p>
@@ -605,7 +605,7 @@
           <a:p>
             <a:fld id="{83D14EEA-DE26-4810-8E05-A65F0010FADE}" type="datetimeFigureOut">
               <a:rPr lang="de-DE" smtClean="0"/>
-              <a:t>28.10.2025</a:t>
+              <a:t>12.12.2025</a:t>
             </a:fld>
             <a:endParaRPr lang="de-DE"/>
           </a:p>
@@ -775,7 +775,7 @@
           <a:p>
             <a:fld id="{83D14EEA-DE26-4810-8E05-A65F0010FADE}" type="datetimeFigureOut">
               <a:rPr lang="de-DE" smtClean="0"/>
-              <a:t>28.10.2025</a:t>
+              <a:t>12.12.2025</a:t>
             </a:fld>
             <a:endParaRPr lang="de-DE"/>
           </a:p>
@@ -1019,7 +1019,7 @@
           <a:p>
             <a:fld id="{83D14EEA-DE26-4810-8E05-A65F0010FADE}" type="datetimeFigureOut">
               <a:rPr lang="de-DE" smtClean="0"/>
-              <a:t>28.10.2025</a:t>
+              <a:t>12.12.2025</a:t>
             </a:fld>
             <a:endParaRPr lang="de-DE"/>
           </a:p>
@@ -1251,7 +1251,7 @@
           <a:p>
             <a:fld id="{83D14EEA-DE26-4810-8E05-A65F0010FADE}" type="datetimeFigureOut">
               <a:rPr lang="de-DE" smtClean="0"/>
-              <a:t>28.10.2025</a:t>
+              <a:t>12.12.2025</a:t>
             </a:fld>
             <a:endParaRPr lang="de-DE"/>
           </a:p>
@@ -1618,7 +1618,7 @@
           <a:p>
             <a:fld id="{83D14EEA-DE26-4810-8E05-A65F0010FADE}" type="datetimeFigureOut">
               <a:rPr lang="de-DE" smtClean="0"/>
-              <a:t>28.10.2025</a:t>
+              <a:t>12.12.2025</a:t>
             </a:fld>
             <a:endParaRPr lang="de-DE"/>
           </a:p>
@@ -1736,7 +1736,7 @@
           <a:p>
             <a:fld id="{83D14EEA-DE26-4810-8E05-A65F0010FADE}" type="datetimeFigureOut">
               <a:rPr lang="de-DE" smtClean="0"/>
-              <a:t>28.10.2025</a:t>
+              <a:t>12.12.2025</a:t>
             </a:fld>
             <a:endParaRPr lang="de-DE"/>
           </a:p>
@@ -1831,7 +1831,7 @@
           <a:p>
             <a:fld id="{83D14EEA-DE26-4810-8E05-A65F0010FADE}" type="datetimeFigureOut">
               <a:rPr lang="de-DE" smtClean="0"/>
-              <a:t>28.10.2025</a:t>
+              <a:t>12.12.2025</a:t>
             </a:fld>
             <a:endParaRPr lang="de-DE"/>
           </a:p>
@@ -2108,7 +2108,7 @@
           <a:p>
             <a:fld id="{83D14EEA-DE26-4810-8E05-A65F0010FADE}" type="datetimeFigureOut">
               <a:rPr lang="de-DE" smtClean="0"/>
-              <a:t>28.10.2025</a:t>
+              <a:t>12.12.2025</a:t>
             </a:fld>
             <a:endParaRPr lang="de-DE"/>
           </a:p>
@@ -2365,7 +2365,7 @@
           <a:p>
             <a:fld id="{83D14EEA-DE26-4810-8E05-A65F0010FADE}" type="datetimeFigureOut">
               <a:rPr lang="de-DE" smtClean="0"/>
-              <a:t>28.10.2025</a:t>
+              <a:t>12.12.2025</a:t>
             </a:fld>
             <a:endParaRPr lang="de-DE"/>
           </a:p>
@@ -2578,7 +2578,7 @@
           <a:p>
             <a:fld id="{83D14EEA-DE26-4810-8E05-A65F0010FADE}" type="datetimeFigureOut">
               <a:rPr lang="de-DE" smtClean="0"/>
-              <a:t>28.10.2025</a:t>
+              <a:t>12.12.2025</a:t>
             </a:fld>
             <a:endParaRPr lang="de-DE"/>
           </a:p>
@@ -4368,7 +4368,7 @@
                 <a:latin typeface="Arial" panose="020B0604020202020204" pitchFamily="34" charset="0"/>
                 <a:cs typeface="Arial" panose="020B0604020202020204" pitchFamily="34" charset="0"/>
               </a:rPr>
-              <a:t>Detected Datasets</a:t>
+              <a:t>Mentioned Datasets</a:t>
             </a:r>
             <a:endParaRPr lang="de-DE" sz="1291" dirty="0">
               <a:latin typeface="Arial" panose="020B0604020202020204" pitchFamily="34" charset="0"/>

</xml_diff>

<commit_message>
fixed some more minur issues in index.qmd including adding commas to 1000s; rendered index.qmd
</commit_message>
<xml_diff>
--- a/plots_png/pptx/plots_png.pptx
+++ b/plots_png/pptx/plots_png.pptx
@@ -255,7 +255,7 @@
           <a:p>
             <a:fld id="{83D14EEA-DE26-4810-8E05-A65F0010FADE}" type="datetimeFigureOut">
               <a:rPr lang="de-DE" smtClean="0"/>
-              <a:t>12.12.2025</a:t>
+              <a:t>19.12.2025</a:t>
             </a:fld>
             <a:endParaRPr lang="de-DE"/>
           </a:p>
@@ -425,7 +425,7 @@
           <a:p>
             <a:fld id="{83D14EEA-DE26-4810-8E05-A65F0010FADE}" type="datetimeFigureOut">
               <a:rPr lang="de-DE" smtClean="0"/>
-              <a:t>12.12.2025</a:t>
+              <a:t>19.12.2025</a:t>
             </a:fld>
             <a:endParaRPr lang="de-DE"/>
           </a:p>
@@ -605,7 +605,7 @@
           <a:p>
             <a:fld id="{83D14EEA-DE26-4810-8E05-A65F0010FADE}" type="datetimeFigureOut">
               <a:rPr lang="de-DE" smtClean="0"/>
-              <a:t>12.12.2025</a:t>
+              <a:t>19.12.2025</a:t>
             </a:fld>
             <a:endParaRPr lang="de-DE"/>
           </a:p>
@@ -775,7 +775,7 @@
           <a:p>
             <a:fld id="{83D14EEA-DE26-4810-8E05-A65F0010FADE}" type="datetimeFigureOut">
               <a:rPr lang="de-DE" smtClean="0"/>
-              <a:t>12.12.2025</a:t>
+              <a:t>19.12.2025</a:t>
             </a:fld>
             <a:endParaRPr lang="de-DE"/>
           </a:p>
@@ -1019,7 +1019,7 @@
           <a:p>
             <a:fld id="{83D14EEA-DE26-4810-8E05-A65F0010FADE}" type="datetimeFigureOut">
               <a:rPr lang="de-DE" smtClean="0"/>
-              <a:t>12.12.2025</a:t>
+              <a:t>19.12.2025</a:t>
             </a:fld>
             <a:endParaRPr lang="de-DE"/>
           </a:p>
@@ -1251,7 +1251,7 @@
           <a:p>
             <a:fld id="{83D14EEA-DE26-4810-8E05-A65F0010FADE}" type="datetimeFigureOut">
               <a:rPr lang="de-DE" smtClean="0"/>
-              <a:t>12.12.2025</a:t>
+              <a:t>19.12.2025</a:t>
             </a:fld>
             <a:endParaRPr lang="de-DE"/>
           </a:p>
@@ -1618,7 +1618,7 @@
           <a:p>
             <a:fld id="{83D14EEA-DE26-4810-8E05-A65F0010FADE}" type="datetimeFigureOut">
               <a:rPr lang="de-DE" smtClean="0"/>
-              <a:t>12.12.2025</a:t>
+              <a:t>19.12.2025</a:t>
             </a:fld>
             <a:endParaRPr lang="de-DE"/>
           </a:p>
@@ -1736,7 +1736,7 @@
           <a:p>
             <a:fld id="{83D14EEA-DE26-4810-8E05-A65F0010FADE}" type="datetimeFigureOut">
               <a:rPr lang="de-DE" smtClean="0"/>
-              <a:t>12.12.2025</a:t>
+              <a:t>19.12.2025</a:t>
             </a:fld>
             <a:endParaRPr lang="de-DE"/>
           </a:p>
@@ -1831,7 +1831,7 @@
           <a:p>
             <a:fld id="{83D14EEA-DE26-4810-8E05-A65F0010FADE}" type="datetimeFigureOut">
               <a:rPr lang="de-DE" smtClean="0"/>
-              <a:t>12.12.2025</a:t>
+              <a:t>19.12.2025</a:t>
             </a:fld>
             <a:endParaRPr lang="de-DE"/>
           </a:p>
@@ -2108,7 +2108,7 @@
           <a:p>
             <a:fld id="{83D14EEA-DE26-4810-8E05-A65F0010FADE}" type="datetimeFigureOut">
               <a:rPr lang="de-DE" smtClean="0"/>
-              <a:t>12.12.2025</a:t>
+              <a:t>19.12.2025</a:t>
             </a:fld>
             <a:endParaRPr lang="de-DE"/>
           </a:p>
@@ -2365,7 +2365,7 @@
           <a:p>
             <a:fld id="{83D14EEA-DE26-4810-8E05-A65F0010FADE}" type="datetimeFigureOut">
               <a:rPr lang="de-DE" smtClean="0"/>
-              <a:t>12.12.2025</a:t>
+              <a:t>19.12.2025</a:t>
             </a:fld>
             <a:endParaRPr lang="de-DE"/>
           </a:p>
@@ -2578,7 +2578,7 @@
           <a:p>
             <a:fld id="{83D14EEA-DE26-4810-8E05-A65F0010FADE}" type="datetimeFigureOut">
               <a:rPr lang="de-DE" smtClean="0"/>
-              <a:t>12.12.2025</a:t>
+              <a:t>19.12.2025</a:t>
             </a:fld>
             <a:endParaRPr lang="de-DE"/>
           </a:p>
@@ -3063,7 +3063,7 @@
                 <a:latin typeface="Arial" panose="020B0604020202020204" pitchFamily="34" charset="0"/>
                 <a:cs typeface="Arial" panose="020B0604020202020204" pitchFamily="34" charset="0"/>
               </a:rPr>
-              <a:t>2385</a:t>
+              <a:t>2,385</a:t>
             </a:r>
             <a:endParaRPr lang="de-DE" sz="1408" dirty="0">
               <a:solidFill>
@@ -3247,7 +3247,7 @@
                 <a:latin typeface="Arial" panose="020B0604020202020204" pitchFamily="34" charset="0"/>
                 <a:cs typeface="Arial" panose="020B0604020202020204" pitchFamily="34" charset="0"/>
               </a:rPr>
-              <a:t>1032</a:t>
+              <a:t>1,032</a:t>
             </a:r>
             <a:endParaRPr lang="de-DE" sz="1408" dirty="0">
               <a:solidFill>
@@ -3762,7 +3762,7 @@
                 <a:latin typeface="Arial" panose="020B0604020202020204" pitchFamily="34" charset="0"/>
                 <a:cs typeface="Arial" panose="020B0604020202020204" pitchFamily="34" charset="0"/>
               </a:rPr>
-              <a:t>1497</a:t>
+              <a:t>1,497</a:t>
             </a:r>
             <a:endParaRPr lang="de-DE" sz="1408" dirty="0">
               <a:solidFill>
@@ -4101,7 +4101,7 @@
                 <a:latin typeface="Arial" panose="020B0604020202020204" pitchFamily="34" charset="0"/>
                 <a:cs typeface="Arial" panose="020B0604020202020204" pitchFamily="34" charset="0"/>
               </a:rPr>
-              <a:t>Reused by 1390 Papers</a:t>
+              <a:t>Reused by 1,390 Papers</a:t>
             </a:r>
           </a:p>
         </p:txBody>
@@ -4457,7 +4457,7 @@
                 <a:latin typeface="Arial" panose="020B0604020202020204" pitchFamily="34" charset="0"/>
                 <a:cs typeface="Arial" panose="020B0604020202020204" pitchFamily="34" charset="0"/>
               </a:rPr>
-              <a:t>1583</a:t>
+              <a:t>1,583</a:t>
             </a:r>
             <a:endParaRPr lang="de-DE" sz="1408" dirty="0">
               <a:solidFill>
@@ -4590,7 +4590,7 @@
                 <a:latin typeface="Arial" panose="020B0604020202020204" pitchFamily="34" charset="0"/>
                 <a:cs typeface="Arial" panose="020B0604020202020204" pitchFamily="34" charset="0"/>
               </a:rPr>
-              <a:t>15748 Charité Papers (2020-2023)</a:t>
+              <a:t>15,748 Charité Papers (2020-2023)</a:t>
             </a:r>
             <a:endParaRPr lang="de-DE" sz="1408" dirty="0">
               <a:solidFill>
@@ -5223,8 +5223,8 @@
         </p:nvSpPr>
         <p:spPr>
           <a:xfrm>
-            <a:off x="5059535" y="3284493"/>
-            <a:ext cx="1828113" cy="480581"/>
+            <a:off x="5059536" y="3299728"/>
+            <a:ext cx="2655711" cy="480581"/>
           </a:xfrm>
           <a:prstGeom prst="rect">
             <a:avLst/>
@@ -5241,7 +5241,7 @@
                 <a:latin typeface="Arial" panose="020B0604020202020204" pitchFamily="34" charset="0"/>
                 <a:cs typeface="Arial" panose="020B0604020202020204" pitchFamily="34" charset="0"/>
               </a:rPr>
-              <a:t>Confirmed Citations</a:t>
+              <a:t>Confirmed Indirect Data Citations</a:t>
             </a:r>
           </a:p>
           <a:p>
@@ -5255,7 +5255,7 @@
                 <a:latin typeface="Arial" panose="020B0604020202020204" pitchFamily="34" charset="0"/>
                 <a:cs typeface="Arial" panose="020B0604020202020204" pitchFamily="34" charset="0"/>
               </a:rPr>
-              <a:t>(113 Reusing Papers)</a:t>
+              <a:t>(1,722 Citations Overall)</a:t>
             </a:r>
           </a:p>
         </p:txBody>
@@ -5330,14 +5330,14 @@
           <a:p>
             <a:pPr algn="ctr"/>
             <a:r>
-              <a:rPr lang="en-US" sz="1408">
+              <a:rPr lang="en-US" sz="1408" dirty="0">
                 <a:solidFill>
                   <a:schemeClr val="tx1"/>
                 </a:solidFill>
                 <a:latin typeface="Arial" panose="020B0604020202020204" pitchFamily="34" charset="0"/>
                 <a:cs typeface="Arial" panose="020B0604020202020204" pitchFamily="34" charset="0"/>
               </a:rPr>
-              <a:t>1765</a:t>
+              <a:t>113</a:t>
             </a:r>
             <a:endParaRPr lang="de-DE" sz="1408" dirty="0">
               <a:solidFill>
@@ -5426,7 +5426,7 @@
                 <a:latin typeface="Arial" panose="020B0604020202020204" pitchFamily="34" charset="0"/>
                 <a:cs typeface="Arial" panose="020B0604020202020204" pitchFamily="34" charset="0"/>
               </a:rPr>
-              <a:t>852</a:t>
+              <a:t>846</a:t>
             </a:r>
             <a:endParaRPr lang="de-DE" sz="1408" dirty="0">
               <a:solidFill>
@@ -5604,7 +5604,7 @@
                 <a:latin typeface="Arial" panose="020B0604020202020204" pitchFamily="34" charset="0"/>
                 <a:cs typeface="Arial" panose="020B0604020202020204" pitchFamily="34" charset="0"/>
               </a:rPr>
-              <a:t>34</a:t>
+              <a:t>35</a:t>
             </a:r>
             <a:endParaRPr lang="de-DE" sz="1408" dirty="0">
               <a:solidFill>
@@ -5782,7 +5782,7 @@
                 <a:latin typeface="Arial" panose="020B0604020202020204" pitchFamily="34" charset="0"/>
                 <a:cs typeface="Arial" panose="020B0604020202020204" pitchFamily="34" charset="0"/>
               </a:rPr>
-              <a:t>28</a:t>
+              <a:t>21</a:t>
             </a:r>
             <a:endParaRPr lang="de-DE" sz="1408" dirty="0">
               <a:solidFill>

</xml_diff>